<commit_message>
feat: complete ppt template pack pipeline
</commit_message>
<xml_diff>
--- a/frontend/public/presentation-templates/academic-editorial-v2.pptx
+++ b/frontend/public/presentation-templates/academic-editorial-v2.pptx
@@ -2,30 +2,30 @@
 <file path=ppt/presentation.xml><?xml version="1.0" encoding="utf-8"?>
 <p:presentation xmlns:p="http://schemas.openxmlformats.org/presentationml/2006/main">
   <p:sldMasterIdLst>
-    <p:sldMasterId xmlns:r="http://schemas.openxmlformats.org/officeDocument/2006/relationships" id="2147483648" r:id="R2041e52b25e44117"/>
+    <p:sldMasterId xmlns:r="http://schemas.openxmlformats.org/officeDocument/2006/relationships" id="2147483648" r:id="Rc15f2093983844c6"/>
   </p:sldMasterIdLst>
   <p:notesMasterIdLst>
-    <p:notesMasterId xmlns:r="http://schemas.openxmlformats.org/officeDocument/2006/relationships" r:id="R04f78a5a14844c3a"/>
+    <p:notesMasterId xmlns:r="http://schemas.openxmlformats.org/officeDocument/2006/relationships" r:id="R46acbdfaa2a04d8e"/>
   </p:notesMasterIdLst>
   <p:sldIdLst>
-    <p:sldId xmlns:r="http://schemas.openxmlformats.org/officeDocument/2006/relationships" id="256" r:id="R3e9fe69af0a64ba2"/>
-    <p:sldId xmlns:r="http://schemas.openxmlformats.org/officeDocument/2006/relationships" id="257" r:id="R1cb80e54966e45d7"/>
-    <p:sldId xmlns:r="http://schemas.openxmlformats.org/officeDocument/2006/relationships" id="258" r:id="Ra2a3c892b8b94228"/>
-    <p:sldId xmlns:r="http://schemas.openxmlformats.org/officeDocument/2006/relationships" id="259" r:id="Rad3353433cef4e51"/>
-    <p:sldId xmlns:r="http://schemas.openxmlformats.org/officeDocument/2006/relationships" id="260" r:id="R874c43749bf34eff"/>
-    <p:sldId xmlns:r="http://schemas.openxmlformats.org/officeDocument/2006/relationships" id="261" r:id="R505197bc55a74f32"/>
-    <p:sldId xmlns:r="http://schemas.openxmlformats.org/officeDocument/2006/relationships" id="262" r:id="R6212ff9bcf75416f"/>
-    <p:sldId xmlns:r="http://schemas.openxmlformats.org/officeDocument/2006/relationships" id="263" r:id="R7ad43913d2734db9"/>
-    <p:sldId xmlns:r="http://schemas.openxmlformats.org/officeDocument/2006/relationships" id="264" r:id="R1bed12d8e1ac4216"/>
-    <p:sldId xmlns:r="http://schemas.openxmlformats.org/officeDocument/2006/relationships" id="265" r:id="R910fbb5220064898"/>
-    <p:sldId xmlns:r="http://schemas.openxmlformats.org/officeDocument/2006/relationships" id="266" r:id="R88a052d56a814013"/>
-    <p:sldId xmlns:r="http://schemas.openxmlformats.org/officeDocument/2006/relationships" id="267" r:id="R8ec2e701fe544700"/>
-    <p:sldId xmlns:r="http://schemas.openxmlformats.org/officeDocument/2006/relationships" id="268" r:id="Rad3eb31ac1954399"/>
-    <p:sldId xmlns:r="http://schemas.openxmlformats.org/officeDocument/2006/relationships" id="269" r:id="R2604d77fa8c04ad9"/>
-    <p:sldId xmlns:r="http://schemas.openxmlformats.org/officeDocument/2006/relationships" id="270" r:id="R20179e159c14449c"/>
-    <p:sldId xmlns:r="http://schemas.openxmlformats.org/officeDocument/2006/relationships" id="271" r:id="R48bc9209c34449ff"/>
-    <p:sldId xmlns:r="http://schemas.openxmlformats.org/officeDocument/2006/relationships" id="272" r:id="Rd43da50997d44e0b"/>
-    <p:sldId xmlns:r="http://schemas.openxmlformats.org/officeDocument/2006/relationships" id="273" r:id="Ra9f88ec6c7994161"/>
+    <p:sldId xmlns:r="http://schemas.openxmlformats.org/officeDocument/2006/relationships" id="256" r:id="Ra82dc72f68e94302"/>
+    <p:sldId xmlns:r="http://schemas.openxmlformats.org/officeDocument/2006/relationships" id="257" r:id="Rd04a59474d6f492c"/>
+    <p:sldId xmlns:r="http://schemas.openxmlformats.org/officeDocument/2006/relationships" id="258" r:id="R23a2f13bde4d4bc9"/>
+    <p:sldId xmlns:r="http://schemas.openxmlformats.org/officeDocument/2006/relationships" id="259" r:id="R7aebcab4d8b74550"/>
+    <p:sldId xmlns:r="http://schemas.openxmlformats.org/officeDocument/2006/relationships" id="260" r:id="Recee8e08a5e14b82"/>
+    <p:sldId xmlns:r="http://schemas.openxmlformats.org/officeDocument/2006/relationships" id="261" r:id="Ra3b3dcae92754589"/>
+    <p:sldId xmlns:r="http://schemas.openxmlformats.org/officeDocument/2006/relationships" id="262" r:id="Rb9ccd08af88a4383"/>
+    <p:sldId xmlns:r="http://schemas.openxmlformats.org/officeDocument/2006/relationships" id="263" r:id="R4a00bcfb57804e7a"/>
+    <p:sldId xmlns:r="http://schemas.openxmlformats.org/officeDocument/2006/relationships" id="264" r:id="R09e86bb96be44d3c"/>
+    <p:sldId xmlns:r="http://schemas.openxmlformats.org/officeDocument/2006/relationships" id="265" r:id="R86066f6767124ac6"/>
+    <p:sldId xmlns:r="http://schemas.openxmlformats.org/officeDocument/2006/relationships" id="266" r:id="Raf1ece31eb43479b"/>
+    <p:sldId xmlns:r="http://schemas.openxmlformats.org/officeDocument/2006/relationships" id="267" r:id="R758cd00cfc6a425e"/>
+    <p:sldId xmlns:r="http://schemas.openxmlformats.org/officeDocument/2006/relationships" id="268" r:id="R10b425b50a274e58"/>
+    <p:sldId xmlns:r="http://schemas.openxmlformats.org/officeDocument/2006/relationships" id="269" r:id="R29f92db29ac04fe2"/>
+    <p:sldId xmlns:r="http://schemas.openxmlformats.org/officeDocument/2006/relationships" id="270" r:id="Rf69fc01312744a54"/>
+    <p:sldId xmlns:r="http://schemas.openxmlformats.org/officeDocument/2006/relationships" id="271" r:id="Re2d7bae1b09344dd"/>
+    <p:sldId xmlns:r="http://schemas.openxmlformats.org/officeDocument/2006/relationships" id="272" r:id="Rc40f3b36107f4645"/>
+    <p:sldId xmlns:r="http://schemas.openxmlformats.org/officeDocument/2006/relationships" id="273" r:id="R3abd69c178ac44c2"/>
   </p:sldIdLst>
   <p:sldSz cx="12192000" cy="6858000"/>
   <p:notesSz cx="6858000" cy="9144000"/>
@@ -1897,7 +1897,7 @@
   </p:cSld>
   <p:clrMap bg1="lt1" tx1="dk1" bg2="lt2" tx2="dk2" accent1="accent1" accent2="accent2" accent3="accent3" accent4="accent4" accent5="accent5" accent6="accent6" hlink="hlink" folHlink="folHlink"/>
   <p:sldLayoutIdLst>
-    <p:sldLayoutId xmlns:r="http://schemas.openxmlformats.org/officeDocument/2006/relationships" id="2147483649" r:id="R284b01efd33e404b"/>
+    <p:sldLayoutId xmlns:r="http://schemas.openxmlformats.org/officeDocument/2006/relationships" id="2147483649" r:id="R2d9135d59f364a99"/>
   </p:sldLayoutIdLst>
   <p:txStyles>
     <p:titleStyle>
@@ -2445,7 +2445,7 @@
           <p:nvPr/>
         </p:nvPicPr>
         <p:blipFill>
-          <a:blip xmlns:r="http://schemas.openxmlformats.org/officeDocument/2006/relationships" xmlns:a="http://schemas.openxmlformats.org/drawingml/2006/main" r:embed="R23a9086e2c2a49f7"/>
+          <a:blip xmlns:r="http://schemas.openxmlformats.org/officeDocument/2006/relationships" xmlns:a="http://schemas.openxmlformats.org/drawingml/2006/main" r:embed="R0716bee7facb4f78"/>
           <a:srcRect xmlns:a="http://schemas.openxmlformats.org/drawingml/2006/main" l="0" t="0" r="0" b="0"/>
           <a:stretch xmlns:a="http://schemas.openxmlformats.org/drawingml/2006/main">
             <a:fillRect l="0" t="0" r="0" b="0"/>
@@ -2466,7 +2466,7 @@
           <p:cNvPr id="2" name="">
             <a:extLst xmlns:a="http://schemas.openxmlformats.org/drawingml/2006/main">
               <a:ext uri="{FF2B5EF4-FFF2-40B4-BE49-F238E27FC236}">
-                <a16:creationId xmlns:a16="http://schemas.microsoft.com/office/drawing/2014/main" id="{C6EC1DAC-EBAF-4A99-A29B-E2F58AE1E168}"/>
+                <a16:creationId xmlns:a16="http://schemas.microsoft.com/office/drawing/2014/main" id="{EA377F2B-83FD-417D-B103-36A84511C7E4}"/>
               </a:ext>
             </a:extLst>
           </p:cNvPr>
@@ -2528,7 +2528,7 @@
           <p:cNvPr id="3" name="">
             <a:extLst xmlns:a="http://schemas.openxmlformats.org/drawingml/2006/main">
               <a:ext uri="{FF2B5EF4-FFF2-40B4-BE49-F238E27FC236}">
-                <a16:creationId xmlns:a16="http://schemas.microsoft.com/office/drawing/2014/main" id="{2733CC70-E09A-4EE2-AE9E-C28CE0B835C0}"/>
+                <a16:creationId xmlns:a16="http://schemas.microsoft.com/office/drawing/2014/main" id="{E43B7397-840D-48F0-B437-A98AFA24B370}"/>
               </a:ext>
             </a:extLst>
           </p:cNvPr>
@@ -2540,7 +2540,7 @@
         <p:spPr>
           <a:xfrm xmlns:a="http://schemas.openxmlformats.org/drawingml/2006/main">
             <a:off x="2000250" y="1885950"/>
-            <a:ext cx="6572250" cy="1524000"/>
+            <a:ext cx="7620000" cy="1524000"/>
           </a:xfrm>
           <a:prstGeom xmlns:a="http://schemas.openxmlformats.org/drawingml/2006/main" prst="rect">
             <a:avLst/>
@@ -2590,7 +2590,7 @@
           <p:cNvPr id="4" name="">
             <a:extLst xmlns:a="http://schemas.openxmlformats.org/drawingml/2006/main">
               <a:ext uri="{FF2B5EF4-FFF2-40B4-BE49-F238E27FC236}">
-                <a16:creationId xmlns:a16="http://schemas.microsoft.com/office/drawing/2014/main" id="{E4E08795-9394-46C4-A475-653EBB09379A}"/>
+                <a16:creationId xmlns:a16="http://schemas.microsoft.com/office/drawing/2014/main" id="{A4A2D4FD-C13B-4ED6-A583-73482C612917}"/>
               </a:ext>
             </a:extLst>
           </p:cNvPr>
@@ -2652,7 +2652,7 @@
           <p:cNvPr id="5" name="">
             <a:extLst xmlns:a="http://schemas.openxmlformats.org/drawingml/2006/main">
               <a:ext uri="{FF2B5EF4-FFF2-40B4-BE49-F238E27FC236}">
-                <a16:creationId xmlns:a16="http://schemas.microsoft.com/office/drawing/2014/main" id="{35A3E123-E578-4AE4-989A-65992C1357B6}"/>
+                <a16:creationId xmlns:a16="http://schemas.microsoft.com/office/drawing/2014/main" id="{DF5F6A8D-719E-4C4D-A359-CC82493E8668}"/>
               </a:ext>
             </a:extLst>
           </p:cNvPr>
@@ -2714,7 +2714,7 @@
           <p:cNvPr id="6" name="">
             <a:extLst xmlns:a="http://schemas.openxmlformats.org/drawingml/2006/main">
               <a:ext uri="{FF2B5EF4-FFF2-40B4-BE49-F238E27FC236}">
-                <a16:creationId xmlns:a16="http://schemas.microsoft.com/office/drawing/2014/main" id="{B098654F-C002-4847-A808-CE6600D56810}"/>
+                <a16:creationId xmlns:a16="http://schemas.microsoft.com/office/drawing/2014/main" id="{E2123EAA-16AA-4A2C-B275-490A7DF7D555}"/>
               </a:ext>
             </a:extLst>
           </p:cNvPr>
@@ -2774,7 +2774,7 @@
     </p:spTree>
     <p:extLst>
       <p:ext uri="{BB962C8B-B14F-4D97-AF65-F5344CB8AC3E}">
-        <p14:creationId xmlns:p14="http://schemas.microsoft.com/office/powerpoint/2010/main" val="107284372"/>
+        <p14:creationId xmlns:p14="http://schemas.microsoft.com/office/powerpoint/2010/main" val="1578407699"/>
       </p:ext>
     </p:extLst>
   </p:cSld>
@@ -2802,7 +2802,7 @@
           <p:nvPr/>
         </p:nvPicPr>
         <p:blipFill>
-          <a:blip xmlns:r="http://schemas.openxmlformats.org/officeDocument/2006/relationships" xmlns:a="http://schemas.openxmlformats.org/drawingml/2006/main" r:embed="Red03e3e49a9f4c89"/>
+          <a:blip xmlns:r="http://schemas.openxmlformats.org/officeDocument/2006/relationships" xmlns:a="http://schemas.openxmlformats.org/drawingml/2006/main" r:embed="R65a43b26856c423f"/>
           <a:srcRect xmlns:a="http://schemas.openxmlformats.org/drawingml/2006/main" l="0" t="0" r="0" b="0"/>
           <a:stretch xmlns:a="http://schemas.openxmlformats.org/drawingml/2006/main">
             <a:fillRect l="0" t="0" r="0" b="0"/>
@@ -2823,7 +2823,7 @@
           <p:cNvPr id="2" name="">
             <a:extLst xmlns:a="http://schemas.openxmlformats.org/drawingml/2006/main">
               <a:ext uri="{FF2B5EF4-FFF2-40B4-BE49-F238E27FC236}">
-                <a16:creationId xmlns:a16="http://schemas.microsoft.com/office/drawing/2014/main" id="{9F0E1448-CF2C-42B5-9903-95D13B046B78}"/>
+                <a16:creationId xmlns:a16="http://schemas.microsoft.com/office/drawing/2014/main" id="{5ED98568-B961-431E-A59E-E00DDF6B6618}"/>
               </a:ext>
             </a:extLst>
           </p:cNvPr>
@@ -2885,7 +2885,7 @@
           <p:cNvPr id="3" name="">
             <a:extLst xmlns:a="http://schemas.openxmlformats.org/drawingml/2006/main">
               <a:ext uri="{FF2B5EF4-FFF2-40B4-BE49-F238E27FC236}">
-                <a16:creationId xmlns:a16="http://schemas.microsoft.com/office/drawing/2014/main" id="{12C27AE1-2459-48B6-AEF9-74DB2CA84E3C}"/>
+                <a16:creationId xmlns:a16="http://schemas.microsoft.com/office/drawing/2014/main" id="{DEDDD1B6-8AD6-4BDA-97E0-1FE1FBBD0903}"/>
               </a:ext>
             </a:extLst>
           </p:cNvPr>
@@ -2947,7 +2947,7 @@
           <p:cNvPr id="4" name="">
             <a:extLst xmlns:a="http://schemas.openxmlformats.org/drawingml/2006/main">
               <a:ext uri="{FF2B5EF4-FFF2-40B4-BE49-F238E27FC236}">
-                <a16:creationId xmlns:a16="http://schemas.microsoft.com/office/drawing/2014/main" id="{8E61CA3F-5BB1-4104-ADA8-885FFCDD53B9}"/>
+                <a16:creationId xmlns:a16="http://schemas.microsoft.com/office/drawing/2014/main" id="{3240B3B3-18C3-47C1-AC73-8EC69A67FEE9}"/>
               </a:ext>
             </a:extLst>
           </p:cNvPr>
@@ -3009,7 +3009,7 @@
           <p:cNvPr id="5" name="">
             <a:extLst xmlns:a="http://schemas.openxmlformats.org/drawingml/2006/main">
               <a:ext uri="{FF2B5EF4-FFF2-40B4-BE49-F238E27FC236}">
-                <a16:creationId xmlns:a16="http://schemas.microsoft.com/office/drawing/2014/main" id="{85C38B45-C945-4FE2-87C1-CB880A9D8210}"/>
+                <a16:creationId xmlns:a16="http://schemas.microsoft.com/office/drawing/2014/main" id="{7BB856B4-9F98-4A8E-91C9-D069E461A719}"/>
               </a:ext>
             </a:extLst>
           </p:cNvPr>
@@ -3040,7 +3040,7 @@
           <p:cNvPr id="6" name="">
             <a:extLst xmlns:a="http://schemas.openxmlformats.org/drawingml/2006/main">
               <a:ext uri="{FF2B5EF4-FFF2-40B4-BE49-F238E27FC236}">
-                <a16:creationId xmlns:a16="http://schemas.microsoft.com/office/drawing/2014/main" id="{1FEEDCDE-A5B3-4742-A7C6-E74BB0B55E88}"/>
+                <a16:creationId xmlns:a16="http://schemas.microsoft.com/office/drawing/2014/main" id="{21916CE2-B1C6-4992-9F35-D2469EFCBE46}"/>
               </a:ext>
             </a:extLst>
           </p:cNvPr>
@@ -3102,7 +3102,7 @@
           <p:cNvPr id="7" name="">
             <a:extLst xmlns:a="http://schemas.openxmlformats.org/drawingml/2006/main">
               <a:ext uri="{FF2B5EF4-FFF2-40B4-BE49-F238E27FC236}">
-                <a16:creationId xmlns:a16="http://schemas.microsoft.com/office/drawing/2014/main" id="{9159B639-56F2-42C4-A8CA-235C7B78D744}"/>
+                <a16:creationId xmlns:a16="http://schemas.microsoft.com/office/drawing/2014/main" id="{981BAFFF-9995-4BCA-A3D1-00BDCB95DB7E}"/>
               </a:ext>
             </a:extLst>
           </p:cNvPr>
@@ -3135,7 +3135,7 @@
           <p:cNvPr id="8" name="">
             <a:extLst xmlns:a="http://schemas.openxmlformats.org/drawingml/2006/main">
               <a:ext uri="{FF2B5EF4-FFF2-40B4-BE49-F238E27FC236}">
-                <a16:creationId xmlns:a16="http://schemas.microsoft.com/office/drawing/2014/main" id="{616AD593-B77D-4E0C-B22D-2EF20B8965ED}"/>
+                <a16:creationId xmlns:a16="http://schemas.microsoft.com/office/drawing/2014/main" id="{5149E85B-C982-42FB-9AE0-1B10BEDBB5F3}"/>
               </a:ext>
             </a:extLst>
           </p:cNvPr>
@@ -3170,7 +3170,7 @@
           <p:cNvPr id="9" name="">
             <a:extLst xmlns:a="http://schemas.openxmlformats.org/drawingml/2006/main">
               <a:ext uri="{FF2B5EF4-FFF2-40B4-BE49-F238E27FC236}">
-                <a16:creationId xmlns:a16="http://schemas.microsoft.com/office/drawing/2014/main" id="{3369DCCC-8A73-4A14-9548-58D7A56E8368}"/>
+                <a16:creationId xmlns:a16="http://schemas.microsoft.com/office/drawing/2014/main" id="{552635AB-4FB9-47D5-B016-C0D02A2C8216}"/>
               </a:ext>
             </a:extLst>
           </p:cNvPr>
@@ -3201,7 +3201,7 @@
           <p:cNvPr id="10" name="">
             <a:extLst xmlns:a="http://schemas.openxmlformats.org/drawingml/2006/main">
               <a:ext uri="{FF2B5EF4-FFF2-40B4-BE49-F238E27FC236}">
-                <a16:creationId xmlns:a16="http://schemas.microsoft.com/office/drawing/2014/main" id="{412038A9-83B9-43A2-84AD-014074024904}"/>
+                <a16:creationId xmlns:a16="http://schemas.microsoft.com/office/drawing/2014/main" id="{1EF70727-AD43-4B45-8ABA-C8452DE2EC5C}"/>
               </a:ext>
             </a:extLst>
           </p:cNvPr>
@@ -3263,7 +3263,7 @@
           <p:cNvPr id="11" name="">
             <a:extLst xmlns:a="http://schemas.openxmlformats.org/drawingml/2006/main">
               <a:ext uri="{FF2B5EF4-FFF2-40B4-BE49-F238E27FC236}">
-                <a16:creationId xmlns:a16="http://schemas.microsoft.com/office/drawing/2014/main" id="{DD41D108-BD97-49EB-BDE6-6ACDEFDDD2FD}"/>
+                <a16:creationId xmlns:a16="http://schemas.microsoft.com/office/drawing/2014/main" id="{31DC386B-50C7-4CBA-BC0C-6E3CCD2D315E}"/>
               </a:ext>
             </a:extLst>
           </p:cNvPr>
@@ -3325,7 +3325,7 @@
           <p:cNvPr id="12" name="">
             <a:extLst xmlns:a="http://schemas.openxmlformats.org/drawingml/2006/main">
               <a:ext uri="{FF2B5EF4-FFF2-40B4-BE49-F238E27FC236}">
-                <a16:creationId xmlns:a16="http://schemas.microsoft.com/office/drawing/2014/main" id="{17823FE3-8791-453A-A4CB-24A1F33CAB87}"/>
+                <a16:creationId xmlns:a16="http://schemas.microsoft.com/office/drawing/2014/main" id="{BA527673-FA2A-4E93-BAB5-B28ADDE40CEF}"/>
               </a:ext>
             </a:extLst>
           </p:cNvPr>
@@ -3358,7 +3358,7 @@
           <p:cNvPr id="13" name="">
             <a:extLst xmlns:a="http://schemas.openxmlformats.org/drawingml/2006/main">
               <a:ext uri="{FF2B5EF4-FFF2-40B4-BE49-F238E27FC236}">
-                <a16:creationId xmlns:a16="http://schemas.microsoft.com/office/drawing/2014/main" id="{A16A3804-E446-46E1-9AD2-5DFA4FABE846}"/>
+                <a16:creationId xmlns:a16="http://schemas.microsoft.com/office/drawing/2014/main" id="{AE94C6B8-7510-4D6F-88F5-67192F6C2861}"/>
               </a:ext>
             </a:extLst>
           </p:cNvPr>
@@ -3393,7 +3393,7 @@
           <p:cNvPr id="14" name="">
             <a:extLst xmlns:a="http://schemas.openxmlformats.org/drawingml/2006/main">
               <a:ext uri="{FF2B5EF4-FFF2-40B4-BE49-F238E27FC236}">
-                <a16:creationId xmlns:a16="http://schemas.microsoft.com/office/drawing/2014/main" id="{AAC74717-CF0B-45FF-8CCF-1A90EE2DB6D6}"/>
+                <a16:creationId xmlns:a16="http://schemas.microsoft.com/office/drawing/2014/main" id="{000BDA24-32E5-4FFE-9C34-8CCC54F06979}"/>
               </a:ext>
             </a:extLst>
           </p:cNvPr>
@@ -3424,7 +3424,7 @@
           <p:cNvPr id="15" name="">
             <a:extLst xmlns:a="http://schemas.openxmlformats.org/drawingml/2006/main">
               <a:ext uri="{FF2B5EF4-FFF2-40B4-BE49-F238E27FC236}">
-                <a16:creationId xmlns:a16="http://schemas.microsoft.com/office/drawing/2014/main" id="{A1705F7A-508E-4300-A478-3237A146B208}"/>
+                <a16:creationId xmlns:a16="http://schemas.microsoft.com/office/drawing/2014/main" id="{FE912D56-F85E-40CC-B4DA-8C861AD4086B}"/>
               </a:ext>
             </a:extLst>
           </p:cNvPr>
@@ -3486,7 +3486,7 @@
           <p:cNvPr id="16" name="">
             <a:extLst xmlns:a="http://schemas.openxmlformats.org/drawingml/2006/main">
               <a:ext uri="{FF2B5EF4-FFF2-40B4-BE49-F238E27FC236}">
-                <a16:creationId xmlns:a16="http://schemas.microsoft.com/office/drawing/2014/main" id="{B64E9E6B-6396-4238-A166-81F7338FBEE1}"/>
+                <a16:creationId xmlns:a16="http://schemas.microsoft.com/office/drawing/2014/main" id="{5950C230-0DCB-4E08-B17B-6BF339CE3F69}"/>
               </a:ext>
             </a:extLst>
           </p:cNvPr>
@@ -3548,7 +3548,7 @@
           <p:cNvPr id="17" name="">
             <a:extLst xmlns:a="http://schemas.openxmlformats.org/drawingml/2006/main">
               <a:ext uri="{FF2B5EF4-FFF2-40B4-BE49-F238E27FC236}">
-                <a16:creationId xmlns:a16="http://schemas.microsoft.com/office/drawing/2014/main" id="{A507F456-CAE8-4CBB-9A92-72C9A9805321}"/>
+                <a16:creationId xmlns:a16="http://schemas.microsoft.com/office/drawing/2014/main" id="{D4C3AA7D-5200-428B-A2D2-D451FC6F500B}"/>
               </a:ext>
             </a:extLst>
           </p:cNvPr>
@@ -3610,7 +3610,7 @@
           <p:cNvPr id="18" name="">
             <a:extLst xmlns:a="http://schemas.openxmlformats.org/drawingml/2006/main">
               <a:ext uri="{FF2B5EF4-FFF2-40B4-BE49-F238E27FC236}">
-                <a16:creationId xmlns:a16="http://schemas.microsoft.com/office/drawing/2014/main" id="{9C81AEC3-F6F2-42C0-9FBF-714873FD466A}"/>
+                <a16:creationId xmlns:a16="http://schemas.microsoft.com/office/drawing/2014/main" id="{3A6FB44C-1BFA-4FE4-96E5-DB3670BB0354}"/>
               </a:ext>
             </a:extLst>
           </p:cNvPr>
@@ -3670,7 +3670,7 @@
     </p:spTree>
     <p:extLst>
       <p:ext uri="{BB962C8B-B14F-4D97-AF65-F5344CB8AC3E}">
-        <p14:creationId xmlns:p14="http://schemas.microsoft.com/office/powerpoint/2010/main" val="843858707"/>
+        <p14:creationId xmlns:p14="http://schemas.microsoft.com/office/powerpoint/2010/main" val="1102114702"/>
       </p:ext>
     </p:extLst>
   </p:cSld>
@@ -3698,7 +3698,7 @@
           <p:nvPr/>
         </p:nvPicPr>
         <p:blipFill>
-          <a:blip xmlns:r="http://schemas.openxmlformats.org/officeDocument/2006/relationships" xmlns:a="http://schemas.openxmlformats.org/drawingml/2006/main" r:embed="Rbf875e42a7934b7a"/>
+          <a:blip xmlns:r="http://schemas.openxmlformats.org/officeDocument/2006/relationships" xmlns:a="http://schemas.openxmlformats.org/drawingml/2006/main" r:embed="R23ca7ec4deac4bfd"/>
           <a:srcRect xmlns:a="http://schemas.openxmlformats.org/drawingml/2006/main" l="0" t="0" r="0" b="0"/>
           <a:stretch xmlns:a="http://schemas.openxmlformats.org/drawingml/2006/main">
             <a:fillRect l="0" t="0" r="0" b="0"/>
@@ -3719,7 +3719,7 @@
           <p:cNvPr id="2" name="">
             <a:extLst xmlns:a="http://schemas.openxmlformats.org/drawingml/2006/main">
               <a:ext uri="{FF2B5EF4-FFF2-40B4-BE49-F238E27FC236}">
-                <a16:creationId xmlns:a16="http://schemas.microsoft.com/office/drawing/2014/main" id="{5980EEC0-C616-490F-9456-346592421DE7}"/>
+                <a16:creationId xmlns:a16="http://schemas.microsoft.com/office/drawing/2014/main" id="{5C8D93D8-9F76-44B6-9F59-039C19CAF6EA}"/>
               </a:ext>
             </a:extLst>
           </p:cNvPr>
@@ -3781,7 +3781,7 @@
           <p:cNvPr id="3" name="">
             <a:extLst xmlns:a="http://schemas.openxmlformats.org/drawingml/2006/main">
               <a:ext uri="{FF2B5EF4-FFF2-40B4-BE49-F238E27FC236}">
-                <a16:creationId xmlns:a16="http://schemas.microsoft.com/office/drawing/2014/main" id="{CC2BB616-D172-4C78-952F-2D35F6C1F877}"/>
+                <a16:creationId xmlns:a16="http://schemas.microsoft.com/office/drawing/2014/main" id="{A1B6F5B0-6A60-4C88-AF1B-F1D67213E88B}"/>
               </a:ext>
             </a:extLst>
           </p:cNvPr>
@@ -3843,7 +3843,7 @@
           <p:cNvPr id="4" name="">
             <a:extLst xmlns:a="http://schemas.openxmlformats.org/drawingml/2006/main">
               <a:ext uri="{FF2B5EF4-FFF2-40B4-BE49-F238E27FC236}">
-                <a16:creationId xmlns:a16="http://schemas.microsoft.com/office/drawing/2014/main" id="{DF3C3336-6DAD-479F-B69B-8F1BA69C2835}"/>
+                <a16:creationId xmlns:a16="http://schemas.microsoft.com/office/drawing/2014/main" id="{E278EDB4-593D-4FB2-AAEB-718CC3DE9A31}"/>
               </a:ext>
             </a:extLst>
           </p:cNvPr>
@@ -3905,7 +3905,7 @@
           <p:cNvPr id="5" name="">
             <a:extLst xmlns:a="http://schemas.openxmlformats.org/drawingml/2006/main">
               <a:ext uri="{FF2B5EF4-FFF2-40B4-BE49-F238E27FC236}">
-                <a16:creationId xmlns:a16="http://schemas.microsoft.com/office/drawing/2014/main" id="{61E461B9-0619-4936-93C8-78A99B662CF7}"/>
+                <a16:creationId xmlns:a16="http://schemas.microsoft.com/office/drawing/2014/main" id="{CADD3470-5869-42A8-A438-11F2187DE45B}"/>
               </a:ext>
             </a:extLst>
           </p:cNvPr>
@@ -3936,7 +3936,7 @@
           <p:cNvPr id="6" name="">
             <a:extLst xmlns:a="http://schemas.openxmlformats.org/drawingml/2006/main">
               <a:ext uri="{FF2B5EF4-FFF2-40B4-BE49-F238E27FC236}">
-                <a16:creationId xmlns:a16="http://schemas.microsoft.com/office/drawing/2014/main" id="{B07C45D3-9C05-4887-9CB3-626C6E4F1CC6}"/>
+                <a16:creationId xmlns:a16="http://schemas.microsoft.com/office/drawing/2014/main" id="{4E83D569-BDBD-45BB-B42E-CA176E9990E6}"/>
               </a:ext>
             </a:extLst>
           </p:cNvPr>
@@ -3998,7 +3998,7 @@
           <p:cNvPr id="7" name="">
             <a:extLst xmlns:a="http://schemas.openxmlformats.org/drawingml/2006/main">
               <a:ext uri="{FF2B5EF4-FFF2-40B4-BE49-F238E27FC236}">
-                <a16:creationId xmlns:a16="http://schemas.microsoft.com/office/drawing/2014/main" id="{EC1179F9-A8BD-4DDC-9553-44C7BBD5C372}"/>
+                <a16:creationId xmlns:a16="http://schemas.microsoft.com/office/drawing/2014/main" id="{111BC2B4-C2DF-43CE-9FFE-0A34E1105819}"/>
               </a:ext>
             </a:extLst>
           </p:cNvPr>
@@ -4031,7 +4031,7 @@
           <p:cNvPr id="8" name="">
             <a:extLst xmlns:a="http://schemas.openxmlformats.org/drawingml/2006/main">
               <a:ext uri="{FF2B5EF4-FFF2-40B4-BE49-F238E27FC236}">
-                <a16:creationId xmlns:a16="http://schemas.microsoft.com/office/drawing/2014/main" id="{F5FA4FAA-0A2A-44DC-8E76-3FE0F693456A}"/>
+                <a16:creationId xmlns:a16="http://schemas.microsoft.com/office/drawing/2014/main" id="{54A989E0-9F2A-4BFA-852A-518F38E6A8C7}"/>
               </a:ext>
             </a:extLst>
           </p:cNvPr>
@@ -4066,7 +4066,7 @@
           <p:cNvPr id="9" name="">
             <a:extLst xmlns:a="http://schemas.openxmlformats.org/drawingml/2006/main">
               <a:ext uri="{FF2B5EF4-FFF2-40B4-BE49-F238E27FC236}">
-                <a16:creationId xmlns:a16="http://schemas.microsoft.com/office/drawing/2014/main" id="{43780F9A-DBC7-4F35-96D5-1A4AED067E0D}"/>
+                <a16:creationId xmlns:a16="http://schemas.microsoft.com/office/drawing/2014/main" id="{8FE58BB7-EC99-48E3-A5E7-D0FF13B2481D}"/>
               </a:ext>
             </a:extLst>
           </p:cNvPr>
@@ -4097,7 +4097,7 @@
           <p:cNvPr id="10" name="">
             <a:extLst xmlns:a="http://schemas.openxmlformats.org/drawingml/2006/main">
               <a:ext uri="{FF2B5EF4-FFF2-40B4-BE49-F238E27FC236}">
-                <a16:creationId xmlns:a16="http://schemas.microsoft.com/office/drawing/2014/main" id="{41542F94-0BB7-4B5C-BDB4-8920F129984A}"/>
+                <a16:creationId xmlns:a16="http://schemas.microsoft.com/office/drawing/2014/main" id="{E711335E-183F-4406-907D-30BC674C59DC}"/>
               </a:ext>
             </a:extLst>
           </p:cNvPr>
@@ -4159,7 +4159,7 @@
           <p:cNvPr id="11" name="">
             <a:extLst xmlns:a="http://schemas.openxmlformats.org/drawingml/2006/main">
               <a:ext uri="{FF2B5EF4-FFF2-40B4-BE49-F238E27FC236}">
-                <a16:creationId xmlns:a16="http://schemas.microsoft.com/office/drawing/2014/main" id="{3C907F85-7627-49DA-95EE-E1F4F729C544}"/>
+                <a16:creationId xmlns:a16="http://schemas.microsoft.com/office/drawing/2014/main" id="{7E3B1C50-10ED-4E41-8D4C-49937358EC2F}"/>
               </a:ext>
             </a:extLst>
           </p:cNvPr>
@@ -4302,7 +4302,7 @@
           <p:cNvPr id="12" name="">
             <a:extLst xmlns:a="http://schemas.openxmlformats.org/drawingml/2006/main">
               <a:ext uri="{FF2B5EF4-FFF2-40B4-BE49-F238E27FC236}">
-                <a16:creationId xmlns:a16="http://schemas.microsoft.com/office/drawing/2014/main" id="{205933FE-D0F2-418A-BABA-87563CFE4DD0}"/>
+                <a16:creationId xmlns:a16="http://schemas.microsoft.com/office/drawing/2014/main" id="{DB8F5932-8385-418B-B540-E65DE1191B6E}"/>
               </a:ext>
             </a:extLst>
           </p:cNvPr>
@@ -4364,7 +4364,7 @@
           <p:cNvPr id="13" name="">
             <a:extLst xmlns:a="http://schemas.openxmlformats.org/drawingml/2006/main">
               <a:ext uri="{FF2B5EF4-FFF2-40B4-BE49-F238E27FC236}">
-                <a16:creationId xmlns:a16="http://schemas.microsoft.com/office/drawing/2014/main" id="{4F426393-CC8C-4BF8-9D72-57E1E970E690}"/>
+                <a16:creationId xmlns:a16="http://schemas.microsoft.com/office/drawing/2014/main" id="{FFB702E0-6D63-4C79-AAE0-B46B903EB75D}"/>
               </a:ext>
             </a:extLst>
           </p:cNvPr>
@@ -4424,7 +4424,7 @@
     </p:spTree>
     <p:extLst>
       <p:ext uri="{BB962C8B-B14F-4D97-AF65-F5344CB8AC3E}">
-        <p14:creationId xmlns:p14="http://schemas.microsoft.com/office/powerpoint/2010/main" val="866708386"/>
+        <p14:creationId xmlns:p14="http://schemas.microsoft.com/office/powerpoint/2010/main" val="1482341710"/>
       </p:ext>
     </p:extLst>
   </p:cSld>
@@ -4452,7 +4452,7 @@
           <p:nvPr/>
         </p:nvPicPr>
         <p:blipFill>
-          <a:blip xmlns:r="http://schemas.openxmlformats.org/officeDocument/2006/relationships" xmlns:a="http://schemas.openxmlformats.org/drawingml/2006/main" r:embed="R8a9aa918637d404c"/>
+          <a:blip xmlns:r="http://schemas.openxmlformats.org/officeDocument/2006/relationships" xmlns:a="http://schemas.openxmlformats.org/drawingml/2006/main" r:embed="Rd1455082911b4be1"/>
           <a:srcRect xmlns:a="http://schemas.openxmlformats.org/drawingml/2006/main" l="0" t="0" r="0" b="0"/>
           <a:stretch xmlns:a="http://schemas.openxmlformats.org/drawingml/2006/main">
             <a:fillRect l="0" t="0" r="0" b="0"/>
@@ -4473,7 +4473,7 @@
           <p:cNvPr id="2" name="">
             <a:extLst xmlns:a="http://schemas.openxmlformats.org/drawingml/2006/main">
               <a:ext uri="{FF2B5EF4-FFF2-40B4-BE49-F238E27FC236}">
-                <a16:creationId xmlns:a16="http://schemas.microsoft.com/office/drawing/2014/main" id="{7FA23BC9-01E9-4E24-847A-2AB359A47F2F}"/>
+                <a16:creationId xmlns:a16="http://schemas.microsoft.com/office/drawing/2014/main" id="{AC5466F0-1AF0-4E4F-A740-FD41540F3F78}"/>
               </a:ext>
             </a:extLst>
           </p:cNvPr>
@@ -4535,7 +4535,7 @@
           <p:cNvPr id="3" name="">
             <a:extLst xmlns:a="http://schemas.openxmlformats.org/drawingml/2006/main">
               <a:ext uri="{FF2B5EF4-FFF2-40B4-BE49-F238E27FC236}">
-                <a16:creationId xmlns:a16="http://schemas.microsoft.com/office/drawing/2014/main" id="{040D8E94-877B-4495-8E65-16DAF56BA6B4}"/>
+                <a16:creationId xmlns:a16="http://schemas.microsoft.com/office/drawing/2014/main" id="{E017E81D-1EDF-49EB-9F27-86832101DA15}"/>
               </a:ext>
             </a:extLst>
           </p:cNvPr>
@@ -4597,7 +4597,7 @@
           <p:cNvPr id="4" name="">
             <a:extLst xmlns:a="http://schemas.openxmlformats.org/drawingml/2006/main">
               <a:ext uri="{FF2B5EF4-FFF2-40B4-BE49-F238E27FC236}">
-                <a16:creationId xmlns:a16="http://schemas.microsoft.com/office/drawing/2014/main" id="{B6C6B1DD-9254-4927-A216-202566D45378}"/>
+                <a16:creationId xmlns:a16="http://schemas.microsoft.com/office/drawing/2014/main" id="{013F945E-AB8C-4D57-98E7-7D79B62D8BD2}"/>
               </a:ext>
             </a:extLst>
           </p:cNvPr>
@@ -4659,7 +4659,7 @@
           <p:cNvPr id="5" name="">
             <a:extLst xmlns:a="http://schemas.openxmlformats.org/drawingml/2006/main">
               <a:ext uri="{FF2B5EF4-FFF2-40B4-BE49-F238E27FC236}">
-                <a16:creationId xmlns:a16="http://schemas.microsoft.com/office/drawing/2014/main" id="{447FC463-BDF6-4DA0-B9F8-B17D0575742C}"/>
+                <a16:creationId xmlns:a16="http://schemas.microsoft.com/office/drawing/2014/main" id="{20D9A8FF-AE72-4D06-9385-C97C3B45C856}"/>
               </a:ext>
             </a:extLst>
           </p:cNvPr>
@@ -4690,7 +4690,7 @@
           <p:cNvPr id="6" name="">
             <a:extLst xmlns:a="http://schemas.openxmlformats.org/drawingml/2006/main">
               <a:ext uri="{FF2B5EF4-FFF2-40B4-BE49-F238E27FC236}">
-                <a16:creationId xmlns:a16="http://schemas.microsoft.com/office/drawing/2014/main" id="{F26551C9-CB42-4079-BB62-EB6D50B71BEA}"/>
+                <a16:creationId xmlns:a16="http://schemas.microsoft.com/office/drawing/2014/main" id="{535D955E-AB26-4ECB-A7BD-CEC2ACECF40E}"/>
               </a:ext>
             </a:extLst>
           </p:cNvPr>
@@ -4752,7 +4752,7 @@
           <p:cNvPr id="7" name="">
             <a:extLst xmlns:a="http://schemas.openxmlformats.org/drawingml/2006/main">
               <a:ext uri="{FF2B5EF4-FFF2-40B4-BE49-F238E27FC236}">
-                <a16:creationId xmlns:a16="http://schemas.microsoft.com/office/drawing/2014/main" id="{2660BF6E-74B5-4F95-A3F1-B813321F1475}"/>
+                <a16:creationId xmlns:a16="http://schemas.microsoft.com/office/drawing/2014/main" id="{96B1C578-AF89-4715-9D29-468181040059}"/>
               </a:ext>
             </a:extLst>
           </p:cNvPr>
@@ -4785,7 +4785,7 @@
           <p:cNvPr id="8" name="">
             <a:extLst xmlns:a="http://schemas.openxmlformats.org/drawingml/2006/main">
               <a:ext uri="{FF2B5EF4-FFF2-40B4-BE49-F238E27FC236}">
-                <a16:creationId xmlns:a16="http://schemas.microsoft.com/office/drawing/2014/main" id="{ADFDE41F-C651-4A0D-8F67-681840B54214}"/>
+                <a16:creationId xmlns:a16="http://schemas.microsoft.com/office/drawing/2014/main" id="{9407EBDE-BB41-4F2D-A567-6EA55C2F1841}"/>
               </a:ext>
             </a:extLst>
           </p:cNvPr>
@@ -4820,7 +4820,7 @@
           <p:cNvPr id="9" name="">
             <a:extLst xmlns:a="http://schemas.openxmlformats.org/drawingml/2006/main">
               <a:ext uri="{FF2B5EF4-FFF2-40B4-BE49-F238E27FC236}">
-                <a16:creationId xmlns:a16="http://schemas.microsoft.com/office/drawing/2014/main" id="{BEE6B94D-8F58-4D11-A5F7-E214504B3849}"/>
+                <a16:creationId xmlns:a16="http://schemas.microsoft.com/office/drawing/2014/main" id="{C5E448E1-D8D2-4C62-88E2-02E322B28608}"/>
               </a:ext>
             </a:extLst>
           </p:cNvPr>
@@ -4851,7 +4851,7 @@
           <p:cNvPr id="10" name="">
             <a:extLst xmlns:a="http://schemas.openxmlformats.org/drawingml/2006/main">
               <a:ext uri="{FF2B5EF4-FFF2-40B4-BE49-F238E27FC236}">
-                <a16:creationId xmlns:a16="http://schemas.microsoft.com/office/drawing/2014/main" id="{E4BEDDD6-A6B1-4080-AA74-6D16610F0B17}"/>
+                <a16:creationId xmlns:a16="http://schemas.microsoft.com/office/drawing/2014/main" id="{F66DE5DA-3D54-4E69-9B77-32173C8DBD28}"/>
               </a:ext>
             </a:extLst>
           </p:cNvPr>
@@ -4913,7 +4913,7 @@
           <p:cNvPr id="11" name="">
             <a:extLst xmlns:a="http://schemas.openxmlformats.org/drawingml/2006/main">
               <a:ext uri="{FF2B5EF4-FFF2-40B4-BE49-F238E27FC236}">
-                <a16:creationId xmlns:a16="http://schemas.microsoft.com/office/drawing/2014/main" id="{A902A758-7F74-4428-A735-AFDA4762FDE6}"/>
+                <a16:creationId xmlns:a16="http://schemas.microsoft.com/office/drawing/2014/main" id="{595B86B2-D1FB-4400-BAAD-B8174FB4FF8A}"/>
               </a:ext>
             </a:extLst>
           </p:cNvPr>
@@ -4975,7 +4975,7 @@
           <p:cNvPr id="12" name="">
             <a:extLst xmlns:a="http://schemas.openxmlformats.org/drawingml/2006/main">
               <a:ext uri="{FF2B5EF4-FFF2-40B4-BE49-F238E27FC236}">
-                <a16:creationId xmlns:a16="http://schemas.microsoft.com/office/drawing/2014/main" id="{82891CBE-E18B-4336-AE66-909E91D599C8}"/>
+                <a16:creationId xmlns:a16="http://schemas.microsoft.com/office/drawing/2014/main" id="{2E69022E-55B3-4C05-88D1-3AAC759B2CFE}"/>
               </a:ext>
             </a:extLst>
           </p:cNvPr>
@@ -5008,7 +5008,7 @@
           <p:cNvPr id="13" name="">
             <a:extLst xmlns:a="http://schemas.openxmlformats.org/drawingml/2006/main">
               <a:ext uri="{FF2B5EF4-FFF2-40B4-BE49-F238E27FC236}">
-                <a16:creationId xmlns:a16="http://schemas.microsoft.com/office/drawing/2014/main" id="{65090332-76A1-40CE-8D88-6BCF255FCCBB}"/>
+                <a16:creationId xmlns:a16="http://schemas.microsoft.com/office/drawing/2014/main" id="{5558A4AD-D1F8-406F-8935-918E2969995F}"/>
               </a:ext>
             </a:extLst>
           </p:cNvPr>
@@ -5043,7 +5043,7 @@
           <p:cNvPr id="14" name="">
             <a:extLst xmlns:a="http://schemas.openxmlformats.org/drawingml/2006/main">
               <a:ext uri="{FF2B5EF4-FFF2-40B4-BE49-F238E27FC236}">
-                <a16:creationId xmlns:a16="http://schemas.microsoft.com/office/drawing/2014/main" id="{D8F9917F-BC1C-47C2-86E7-7B64E05AEFB1}"/>
+                <a16:creationId xmlns:a16="http://schemas.microsoft.com/office/drawing/2014/main" id="{A4B063CD-D88F-47F7-AEE8-DC47AFE6B8B2}"/>
               </a:ext>
             </a:extLst>
           </p:cNvPr>
@@ -5074,7 +5074,7 @@
           <p:cNvPr id="15" name="">
             <a:extLst xmlns:a="http://schemas.openxmlformats.org/drawingml/2006/main">
               <a:ext uri="{FF2B5EF4-FFF2-40B4-BE49-F238E27FC236}">
-                <a16:creationId xmlns:a16="http://schemas.microsoft.com/office/drawing/2014/main" id="{A52704F3-FF53-45E4-A34B-393D52DD0E12}"/>
+                <a16:creationId xmlns:a16="http://schemas.microsoft.com/office/drawing/2014/main" id="{CE30B854-BDFF-4CAC-9C4C-FE8078A52C09}"/>
               </a:ext>
             </a:extLst>
           </p:cNvPr>
@@ -5136,7 +5136,7 @@
           <p:cNvPr id="16" name="">
             <a:extLst xmlns:a="http://schemas.openxmlformats.org/drawingml/2006/main">
               <a:ext uri="{FF2B5EF4-FFF2-40B4-BE49-F238E27FC236}">
-                <a16:creationId xmlns:a16="http://schemas.microsoft.com/office/drawing/2014/main" id="{F21E5C23-33CC-438B-9445-861C6BB93738}"/>
+                <a16:creationId xmlns:a16="http://schemas.microsoft.com/office/drawing/2014/main" id="{24F6457E-5509-457C-B043-0F7D583C60F9}"/>
               </a:ext>
             </a:extLst>
           </p:cNvPr>
@@ -5198,7 +5198,7 @@
           <p:cNvPr id="17" name="">
             <a:extLst xmlns:a="http://schemas.openxmlformats.org/drawingml/2006/main">
               <a:ext uri="{FF2B5EF4-FFF2-40B4-BE49-F238E27FC236}">
-                <a16:creationId xmlns:a16="http://schemas.microsoft.com/office/drawing/2014/main" id="{5C4B3AAE-0C17-49D7-8F7D-A79F0C13E29A}"/>
+                <a16:creationId xmlns:a16="http://schemas.microsoft.com/office/drawing/2014/main" id="{8AB0B680-0BCB-4BA5-9025-409E227389B0}"/>
               </a:ext>
             </a:extLst>
           </p:cNvPr>
@@ -5231,7 +5231,7 @@
           <p:cNvPr id="18" name="">
             <a:extLst xmlns:a="http://schemas.openxmlformats.org/drawingml/2006/main">
               <a:ext uri="{FF2B5EF4-FFF2-40B4-BE49-F238E27FC236}">
-                <a16:creationId xmlns:a16="http://schemas.microsoft.com/office/drawing/2014/main" id="{12C87E1C-9042-42AB-8902-14D1943091CA}"/>
+                <a16:creationId xmlns:a16="http://schemas.microsoft.com/office/drawing/2014/main" id="{ADB12CD0-5A96-424B-93E0-DEA415C8A962}"/>
               </a:ext>
             </a:extLst>
           </p:cNvPr>
@@ -5266,7 +5266,7 @@
           <p:cNvPr id="19" name="">
             <a:extLst xmlns:a="http://schemas.openxmlformats.org/drawingml/2006/main">
               <a:ext uri="{FF2B5EF4-FFF2-40B4-BE49-F238E27FC236}">
-                <a16:creationId xmlns:a16="http://schemas.microsoft.com/office/drawing/2014/main" id="{516909E3-6CD8-4F8C-824E-8BDB4CF971DA}"/>
+                <a16:creationId xmlns:a16="http://schemas.microsoft.com/office/drawing/2014/main" id="{5B4AF099-0B87-4022-8BCE-D159506857BB}"/>
               </a:ext>
             </a:extLst>
           </p:cNvPr>
@@ -5297,7 +5297,7 @@
           <p:cNvPr id="20" name="">
             <a:extLst xmlns:a="http://schemas.openxmlformats.org/drawingml/2006/main">
               <a:ext uri="{FF2B5EF4-FFF2-40B4-BE49-F238E27FC236}">
-                <a16:creationId xmlns:a16="http://schemas.microsoft.com/office/drawing/2014/main" id="{61562DCE-0623-4AB4-8189-AF0CBD5E2B91}"/>
+                <a16:creationId xmlns:a16="http://schemas.microsoft.com/office/drawing/2014/main" id="{D5BADE13-A9A1-498B-BF7E-DAF44F333E5E}"/>
               </a:ext>
             </a:extLst>
           </p:cNvPr>
@@ -5359,7 +5359,7 @@
           <p:cNvPr id="21" name="">
             <a:extLst xmlns:a="http://schemas.openxmlformats.org/drawingml/2006/main">
               <a:ext uri="{FF2B5EF4-FFF2-40B4-BE49-F238E27FC236}">
-                <a16:creationId xmlns:a16="http://schemas.microsoft.com/office/drawing/2014/main" id="{E06D08FD-3BF5-4433-80B8-CE652E4D8D03}"/>
+                <a16:creationId xmlns:a16="http://schemas.microsoft.com/office/drawing/2014/main" id="{0B67029F-D034-42FE-A4EE-BD781C2FF035}"/>
               </a:ext>
             </a:extLst>
           </p:cNvPr>
@@ -5421,7 +5421,7 @@
           <p:cNvPr id="22" name="">
             <a:extLst xmlns:a="http://schemas.openxmlformats.org/drawingml/2006/main">
               <a:ext uri="{FF2B5EF4-FFF2-40B4-BE49-F238E27FC236}">
-                <a16:creationId xmlns:a16="http://schemas.microsoft.com/office/drawing/2014/main" id="{208A840D-9503-47BD-8F24-512B7BF63634}"/>
+                <a16:creationId xmlns:a16="http://schemas.microsoft.com/office/drawing/2014/main" id="{E2524075-5676-4741-8F1F-664D6922E964}"/>
               </a:ext>
             </a:extLst>
           </p:cNvPr>
@@ -5483,7 +5483,7 @@
           <p:cNvPr id="23" name="">
             <a:extLst xmlns:a="http://schemas.openxmlformats.org/drawingml/2006/main">
               <a:ext uri="{FF2B5EF4-FFF2-40B4-BE49-F238E27FC236}">
-                <a16:creationId xmlns:a16="http://schemas.microsoft.com/office/drawing/2014/main" id="{D7D6C2E4-F957-49E8-B401-9F20AC3365E0}"/>
+                <a16:creationId xmlns:a16="http://schemas.microsoft.com/office/drawing/2014/main" id="{9DF7A2D2-DB2A-4A99-A3E4-8399935173D4}"/>
               </a:ext>
             </a:extLst>
           </p:cNvPr>
@@ -5543,7 +5543,7 @@
     </p:spTree>
     <p:extLst>
       <p:ext uri="{BB962C8B-B14F-4D97-AF65-F5344CB8AC3E}">
-        <p14:creationId xmlns:p14="http://schemas.microsoft.com/office/powerpoint/2010/main" val="334728484"/>
+        <p14:creationId xmlns:p14="http://schemas.microsoft.com/office/powerpoint/2010/main" val="85689657"/>
       </p:ext>
     </p:extLst>
   </p:cSld>
@@ -5571,7 +5571,7 @@
           <p:nvPr/>
         </p:nvPicPr>
         <p:blipFill>
-          <a:blip xmlns:r="http://schemas.openxmlformats.org/officeDocument/2006/relationships" xmlns:a="http://schemas.openxmlformats.org/drawingml/2006/main" r:embed="Rac9d7fb1d58745aa"/>
+          <a:blip xmlns:r="http://schemas.openxmlformats.org/officeDocument/2006/relationships" xmlns:a="http://schemas.openxmlformats.org/drawingml/2006/main" r:embed="R0ebec20daabb4ade"/>
           <a:srcRect xmlns:a="http://schemas.openxmlformats.org/drawingml/2006/main" l="0" t="0" r="0" b="0"/>
           <a:stretch xmlns:a="http://schemas.openxmlformats.org/drawingml/2006/main">
             <a:fillRect l="0" t="0" r="0" b="0"/>
@@ -5592,7 +5592,7 @@
           <p:cNvPr id="2" name="">
             <a:extLst xmlns:a="http://schemas.openxmlformats.org/drawingml/2006/main">
               <a:ext uri="{FF2B5EF4-FFF2-40B4-BE49-F238E27FC236}">
-                <a16:creationId xmlns:a16="http://schemas.microsoft.com/office/drawing/2014/main" id="{A83F70AD-A4A4-4685-97A9-6A83C2C91EC0}"/>
+                <a16:creationId xmlns:a16="http://schemas.microsoft.com/office/drawing/2014/main" id="{46031C9B-7930-40C6-9972-E24E18DC9A54}"/>
               </a:ext>
             </a:extLst>
           </p:cNvPr>
@@ -5654,7 +5654,7 @@
           <p:cNvPr id="3" name="">
             <a:extLst xmlns:a="http://schemas.openxmlformats.org/drawingml/2006/main">
               <a:ext uri="{FF2B5EF4-FFF2-40B4-BE49-F238E27FC236}">
-                <a16:creationId xmlns:a16="http://schemas.microsoft.com/office/drawing/2014/main" id="{AFD117F7-F3E5-4B52-A724-1C9B7BED582E}"/>
+                <a16:creationId xmlns:a16="http://schemas.microsoft.com/office/drawing/2014/main" id="{39C2445F-8F1D-47F1-B534-EC1142CD9FB8}"/>
               </a:ext>
             </a:extLst>
           </p:cNvPr>
@@ -5716,7 +5716,7 @@
           <p:cNvPr id="4" name="">
             <a:extLst xmlns:a="http://schemas.openxmlformats.org/drawingml/2006/main">
               <a:ext uri="{FF2B5EF4-FFF2-40B4-BE49-F238E27FC236}">
-                <a16:creationId xmlns:a16="http://schemas.microsoft.com/office/drawing/2014/main" id="{472C09EE-7909-4759-9100-4FC2D4700651}"/>
+                <a16:creationId xmlns:a16="http://schemas.microsoft.com/office/drawing/2014/main" id="{05F60C5E-98FC-4747-9934-67D35037BAB1}"/>
               </a:ext>
             </a:extLst>
           </p:cNvPr>
@@ -5778,7 +5778,7 @@
           <p:cNvPr id="5" name="">
             <a:extLst xmlns:a="http://schemas.openxmlformats.org/drawingml/2006/main">
               <a:ext uri="{FF2B5EF4-FFF2-40B4-BE49-F238E27FC236}">
-                <a16:creationId xmlns:a16="http://schemas.microsoft.com/office/drawing/2014/main" id="{CF211B86-3E12-40E7-892B-1B05A03B8131}"/>
+                <a16:creationId xmlns:a16="http://schemas.microsoft.com/office/drawing/2014/main" id="{65D86B73-9A7C-4328-AC5D-0C961E268F11}"/>
               </a:ext>
             </a:extLst>
           </p:cNvPr>
@@ -5809,7 +5809,7 @@
           <p:cNvPr id="6" name="">
             <a:extLst xmlns:a="http://schemas.openxmlformats.org/drawingml/2006/main">
               <a:ext uri="{FF2B5EF4-FFF2-40B4-BE49-F238E27FC236}">
-                <a16:creationId xmlns:a16="http://schemas.microsoft.com/office/drawing/2014/main" id="{A3E3BBC6-0FB3-4680-A8E9-185031590CDC}"/>
+                <a16:creationId xmlns:a16="http://schemas.microsoft.com/office/drawing/2014/main" id="{E5906E06-4810-43F1-9FF0-BE97F91F0EDF}"/>
               </a:ext>
             </a:extLst>
           </p:cNvPr>
@@ -5871,7 +5871,7 @@
           <p:cNvPr id="7" name="">
             <a:extLst xmlns:a="http://schemas.openxmlformats.org/drawingml/2006/main">
               <a:ext uri="{FF2B5EF4-FFF2-40B4-BE49-F238E27FC236}">
-                <a16:creationId xmlns:a16="http://schemas.microsoft.com/office/drawing/2014/main" id="{C7329898-DD0D-4778-8182-1BBD82683E99}"/>
+                <a16:creationId xmlns:a16="http://schemas.microsoft.com/office/drawing/2014/main" id="{B1E5B414-A5E0-4D6E-B948-C558523BDA4A}"/>
               </a:ext>
             </a:extLst>
           </p:cNvPr>
@@ -5904,7 +5904,7 @@
           <p:cNvPr id="8" name="">
             <a:extLst xmlns:a="http://schemas.openxmlformats.org/drawingml/2006/main">
               <a:ext uri="{FF2B5EF4-FFF2-40B4-BE49-F238E27FC236}">
-                <a16:creationId xmlns:a16="http://schemas.microsoft.com/office/drawing/2014/main" id="{FD6D00CA-7D58-42BF-8E06-3055384AF8A9}"/>
+                <a16:creationId xmlns:a16="http://schemas.microsoft.com/office/drawing/2014/main" id="{753B6DCB-1506-4B70-9018-14552BFA9971}"/>
               </a:ext>
             </a:extLst>
           </p:cNvPr>
@@ -5939,7 +5939,7 @@
           <p:cNvPr id="9" name="">
             <a:extLst xmlns:a="http://schemas.openxmlformats.org/drawingml/2006/main">
               <a:ext uri="{FF2B5EF4-FFF2-40B4-BE49-F238E27FC236}">
-                <a16:creationId xmlns:a16="http://schemas.microsoft.com/office/drawing/2014/main" id="{90678FD2-434F-4317-986C-BCDFBEDFB0F6}"/>
+                <a16:creationId xmlns:a16="http://schemas.microsoft.com/office/drawing/2014/main" id="{1CE1C3CD-D68E-493A-9E2E-23D87613BC16}"/>
               </a:ext>
             </a:extLst>
           </p:cNvPr>
@@ -5970,7 +5970,7 @@
           <p:cNvPr id="10" name="">
             <a:extLst xmlns:a="http://schemas.openxmlformats.org/drawingml/2006/main">
               <a:ext uri="{FF2B5EF4-FFF2-40B4-BE49-F238E27FC236}">
-                <a16:creationId xmlns:a16="http://schemas.microsoft.com/office/drawing/2014/main" id="{808374B8-56AA-4833-89E5-DD90F44BB217}"/>
+                <a16:creationId xmlns:a16="http://schemas.microsoft.com/office/drawing/2014/main" id="{098F84AA-557D-4E09-80DF-DF157FB02330}"/>
               </a:ext>
             </a:extLst>
           </p:cNvPr>
@@ -6032,7 +6032,7 @@
           <p:cNvPr id="11" name="">
             <a:extLst xmlns:a="http://schemas.openxmlformats.org/drawingml/2006/main">
               <a:ext uri="{FF2B5EF4-FFF2-40B4-BE49-F238E27FC236}">
-                <a16:creationId xmlns:a16="http://schemas.microsoft.com/office/drawing/2014/main" id="{8BDE38BF-2E92-4232-949D-4003A4901163}"/>
+                <a16:creationId xmlns:a16="http://schemas.microsoft.com/office/drawing/2014/main" id="{459153D0-E3DA-4769-9CC2-DDA7844C20C1}"/>
               </a:ext>
             </a:extLst>
           </p:cNvPr>
@@ -6094,7 +6094,7 @@
           <p:cNvPr id="12" name="">
             <a:extLst xmlns:a="http://schemas.openxmlformats.org/drawingml/2006/main">
               <a:ext uri="{FF2B5EF4-FFF2-40B4-BE49-F238E27FC236}">
-                <a16:creationId xmlns:a16="http://schemas.microsoft.com/office/drawing/2014/main" id="{D5FAF3B1-2E1A-47BF-8A2A-F524FD45910F}"/>
+                <a16:creationId xmlns:a16="http://schemas.microsoft.com/office/drawing/2014/main" id="{749ECCCD-2FD9-482F-B8B1-8199A8EFB5FF}"/>
               </a:ext>
             </a:extLst>
           </p:cNvPr>
@@ -6156,7 +6156,7 @@
           <p:cNvPr id="13" name="">
             <a:extLst xmlns:a="http://schemas.openxmlformats.org/drawingml/2006/main">
               <a:ext uri="{FF2B5EF4-FFF2-40B4-BE49-F238E27FC236}">
-                <a16:creationId xmlns:a16="http://schemas.microsoft.com/office/drawing/2014/main" id="{746703CC-F438-47D2-AC67-D833BCFC37EA}"/>
+                <a16:creationId xmlns:a16="http://schemas.microsoft.com/office/drawing/2014/main" id="{D251FB6C-A6B3-461C-8B35-AFF2F3E6B074}"/>
               </a:ext>
             </a:extLst>
           </p:cNvPr>
@@ -6216,7 +6216,7 @@
     </p:spTree>
     <p:extLst>
       <p:ext uri="{BB962C8B-B14F-4D97-AF65-F5344CB8AC3E}">
-        <p14:creationId xmlns:p14="http://schemas.microsoft.com/office/powerpoint/2010/main" val="756507418"/>
+        <p14:creationId xmlns:p14="http://schemas.microsoft.com/office/powerpoint/2010/main" val="1871388004"/>
       </p:ext>
     </p:extLst>
   </p:cSld>
@@ -6244,7 +6244,7 @@
           <p:nvPr/>
         </p:nvPicPr>
         <p:blipFill>
-          <a:blip xmlns:r="http://schemas.openxmlformats.org/officeDocument/2006/relationships" xmlns:a="http://schemas.openxmlformats.org/drawingml/2006/main" r:embed="Rb411f4f02f684f80"/>
+          <a:blip xmlns:r="http://schemas.openxmlformats.org/officeDocument/2006/relationships" xmlns:a="http://schemas.openxmlformats.org/drawingml/2006/main" r:embed="Rceb1d5eb18074510"/>
           <a:srcRect xmlns:a="http://schemas.openxmlformats.org/drawingml/2006/main" l="0" t="0" r="0" b="0"/>
           <a:stretch xmlns:a="http://schemas.openxmlformats.org/drawingml/2006/main">
             <a:fillRect l="0" t="0" r="0" b="0"/>
@@ -6265,7 +6265,7 @@
           <p:cNvPr id="2" name="">
             <a:extLst xmlns:a="http://schemas.openxmlformats.org/drawingml/2006/main">
               <a:ext uri="{FF2B5EF4-FFF2-40B4-BE49-F238E27FC236}">
-                <a16:creationId xmlns:a16="http://schemas.microsoft.com/office/drawing/2014/main" id="{14FA882A-2B93-4E2E-BC20-B82F52FDEEBB}"/>
+                <a16:creationId xmlns:a16="http://schemas.microsoft.com/office/drawing/2014/main" id="{CB4C8B03-8BF6-4B3A-91AD-95EED897D6F1}"/>
               </a:ext>
             </a:extLst>
           </p:cNvPr>
@@ -6327,7 +6327,7 @@
           <p:cNvPr id="3" name="">
             <a:extLst xmlns:a="http://schemas.openxmlformats.org/drawingml/2006/main">
               <a:ext uri="{FF2B5EF4-FFF2-40B4-BE49-F238E27FC236}">
-                <a16:creationId xmlns:a16="http://schemas.microsoft.com/office/drawing/2014/main" id="{3DD6E03C-DF3B-485B-89E5-9DBABBC90A79}"/>
+                <a16:creationId xmlns:a16="http://schemas.microsoft.com/office/drawing/2014/main" id="{C357C042-B37F-4ED2-BF9B-4B6C727A399B}"/>
               </a:ext>
             </a:extLst>
           </p:cNvPr>
@@ -6389,7 +6389,7 @@
           <p:cNvPr id="4" name="">
             <a:extLst xmlns:a="http://schemas.openxmlformats.org/drawingml/2006/main">
               <a:ext uri="{FF2B5EF4-FFF2-40B4-BE49-F238E27FC236}">
-                <a16:creationId xmlns:a16="http://schemas.microsoft.com/office/drawing/2014/main" id="{5620AE60-9A9A-44FE-BE9A-CC238340F311}"/>
+                <a16:creationId xmlns:a16="http://schemas.microsoft.com/office/drawing/2014/main" id="{A0B56643-853B-4B7C-9016-94E75EB66089}"/>
               </a:ext>
             </a:extLst>
           </p:cNvPr>
@@ -6451,7 +6451,7 @@
           <p:cNvPr id="5" name="">
             <a:extLst xmlns:a="http://schemas.openxmlformats.org/drawingml/2006/main">
               <a:ext uri="{FF2B5EF4-FFF2-40B4-BE49-F238E27FC236}">
-                <a16:creationId xmlns:a16="http://schemas.microsoft.com/office/drawing/2014/main" id="{E111CEF7-EFEF-4F68-B99B-E5B9A4E5E0B2}"/>
+                <a16:creationId xmlns:a16="http://schemas.microsoft.com/office/drawing/2014/main" id="{F3A91810-F08D-44AE-A6A6-7E2973F704AB}"/>
               </a:ext>
             </a:extLst>
           </p:cNvPr>
@@ -6482,7 +6482,7 @@
           <p:cNvPr id="6" name="">
             <a:extLst xmlns:a="http://schemas.openxmlformats.org/drawingml/2006/main">
               <a:ext uri="{FF2B5EF4-FFF2-40B4-BE49-F238E27FC236}">
-                <a16:creationId xmlns:a16="http://schemas.microsoft.com/office/drawing/2014/main" id="{3A928AE7-1749-453E-8CFC-10E124503F92}"/>
+                <a16:creationId xmlns:a16="http://schemas.microsoft.com/office/drawing/2014/main" id="{4F8C285C-FAB5-4F80-A713-68ABF73BED5A}"/>
               </a:ext>
             </a:extLst>
           </p:cNvPr>
@@ -6544,7 +6544,7 @@
           <p:cNvPr id="7" name="">
             <a:extLst xmlns:a="http://schemas.openxmlformats.org/drawingml/2006/main">
               <a:ext uri="{FF2B5EF4-FFF2-40B4-BE49-F238E27FC236}">
-                <a16:creationId xmlns:a16="http://schemas.microsoft.com/office/drawing/2014/main" id="{FD80B83A-AF59-4DDC-850D-91FA7286A2D5}"/>
+                <a16:creationId xmlns:a16="http://schemas.microsoft.com/office/drawing/2014/main" id="{215A75DB-93B1-4512-8D56-8526E6FD7F79}"/>
               </a:ext>
             </a:extLst>
           </p:cNvPr>
@@ -6577,7 +6577,7 @@
           <p:cNvPr id="8" name="">
             <a:extLst xmlns:a="http://schemas.openxmlformats.org/drawingml/2006/main">
               <a:ext uri="{FF2B5EF4-FFF2-40B4-BE49-F238E27FC236}">
-                <a16:creationId xmlns:a16="http://schemas.microsoft.com/office/drawing/2014/main" id="{0FE9B659-50B5-4EC7-AD24-401A7ECA62FF}"/>
+                <a16:creationId xmlns:a16="http://schemas.microsoft.com/office/drawing/2014/main" id="{4E5398B3-CE5F-428C-8094-79F2E2645436}"/>
               </a:ext>
             </a:extLst>
           </p:cNvPr>
@@ -6612,7 +6612,7 @@
           <p:cNvPr id="9" name="">
             <a:extLst xmlns:a="http://schemas.openxmlformats.org/drawingml/2006/main">
               <a:ext uri="{FF2B5EF4-FFF2-40B4-BE49-F238E27FC236}">
-                <a16:creationId xmlns:a16="http://schemas.microsoft.com/office/drawing/2014/main" id="{D869F8B5-69E8-43BD-92E3-DCA4D021B8CD}"/>
+                <a16:creationId xmlns:a16="http://schemas.microsoft.com/office/drawing/2014/main" id="{4B64D6A0-41FC-4742-B929-CC6FE587316A}"/>
               </a:ext>
             </a:extLst>
           </p:cNvPr>
@@ -6643,7 +6643,7 @@
           <p:cNvPr id="10" name="">
             <a:extLst xmlns:a="http://schemas.openxmlformats.org/drawingml/2006/main">
               <a:ext uri="{FF2B5EF4-FFF2-40B4-BE49-F238E27FC236}">
-                <a16:creationId xmlns:a16="http://schemas.microsoft.com/office/drawing/2014/main" id="{ACD93587-CD7D-4C3A-A616-5F5EB87B3951}"/>
+                <a16:creationId xmlns:a16="http://schemas.microsoft.com/office/drawing/2014/main" id="{F7E46940-1971-4DB1-BE32-B0D9F7AE5CA2}"/>
               </a:ext>
             </a:extLst>
           </p:cNvPr>
@@ -6705,7 +6705,7 @@
           <p:cNvPr id="11" name="">
             <a:extLst xmlns:a="http://schemas.openxmlformats.org/drawingml/2006/main">
               <a:ext uri="{FF2B5EF4-FFF2-40B4-BE49-F238E27FC236}">
-                <a16:creationId xmlns:a16="http://schemas.microsoft.com/office/drawing/2014/main" id="{52E216DA-5C2C-446F-842F-0B439B912E88}"/>
+                <a16:creationId xmlns:a16="http://schemas.microsoft.com/office/drawing/2014/main" id="{7179E462-AAD7-4EF0-AAA8-D260B6ADC25B}"/>
               </a:ext>
             </a:extLst>
           </p:cNvPr>
@@ -6767,7 +6767,7 @@
           <p:cNvPr id="12" name="">
             <a:extLst xmlns:a="http://schemas.openxmlformats.org/drawingml/2006/main">
               <a:ext uri="{FF2B5EF4-FFF2-40B4-BE49-F238E27FC236}">
-                <a16:creationId xmlns:a16="http://schemas.microsoft.com/office/drawing/2014/main" id="{407CF5A9-9B59-431E-99C1-B16EE8975A61}"/>
+                <a16:creationId xmlns:a16="http://schemas.microsoft.com/office/drawing/2014/main" id="{27572133-A7B7-47D0-BD26-BF72E38AD1D3}"/>
               </a:ext>
             </a:extLst>
           </p:cNvPr>
@@ -6800,7 +6800,7 @@
           <p:cNvPr id="13" name="">
             <a:extLst xmlns:a="http://schemas.openxmlformats.org/drawingml/2006/main">
               <a:ext uri="{FF2B5EF4-FFF2-40B4-BE49-F238E27FC236}">
-                <a16:creationId xmlns:a16="http://schemas.microsoft.com/office/drawing/2014/main" id="{C5CE758A-6AE2-4991-B4A5-8A3691FB92A2}"/>
+                <a16:creationId xmlns:a16="http://schemas.microsoft.com/office/drawing/2014/main" id="{B8F1BE8C-C9C6-4225-86C6-08F539190084}"/>
               </a:ext>
             </a:extLst>
           </p:cNvPr>
@@ -6835,7 +6835,7 @@
           <p:cNvPr id="14" name="">
             <a:extLst xmlns:a="http://schemas.openxmlformats.org/drawingml/2006/main">
               <a:ext uri="{FF2B5EF4-FFF2-40B4-BE49-F238E27FC236}">
-                <a16:creationId xmlns:a16="http://schemas.microsoft.com/office/drawing/2014/main" id="{36D069D8-BB11-4D89-82F7-27D31EF25868}"/>
+                <a16:creationId xmlns:a16="http://schemas.microsoft.com/office/drawing/2014/main" id="{ECB43DC4-C895-4086-9785-00D56C6EC0F1}"/>
               </a:ext>
             </a:extLst>
           </p:cNvPr>
@@ -6866,7 +6866,7 @@
           <p:cNvPr id="15" name="">
             <a:extLst xmlns:a="http://schemas.openxmlformats.org/drawingml/2006/main">
               <a:ext uri="{FF2B5EF4-FFF2-40B4-BE49-F238E27FC236}">
-                <a16:creationId xmlns:a16="http://schemas.microsoft.com/office/drawing/2014/main" id="{0C577AB5-3AA6-4194-93F7-74AD28E941D1}"/>
+                <a16:creationId xmlns:a16="http://schemas.microsoft.com/office/drawing/2014/main" id="{DA6521A9-EF57-47A0-94EA-C821B91F8833}"/>
               </a:ext>
             </a:extLst>
           </p:cNvPr>
@@ -6928,7 +6928,7 @@
           <p:cNvPr id="16" name="">
             <a:extLst xmlns:a="http://schemas.openxmlformats.org/drawingml/2006/main">
               <a:ext uri="{FF2B5EF4-FFF2-40B4-BE49-F238E27FC236}">
-                <a16:creationId xmlns:a16="http://schemas.microsoft.com/office/drawing/2014/main" id="{299F6713-A8C0-4605-B94E-D4DB64496BE3}"/>
+                <a16:creationId xmlns:a16="http://schemas.microsoft.com/office/drawing/2014/main" id="{55362FB6-47A2-4E7E-A497-793EB185F5D8}"/>
               </a:ext>
             </a:extLst>
           </p:cNvPr>
@@ -6990,7 +6990,7 @@
           <p:cNvPr id="17" name="">
             <a:extLst xmlns:a="http://schemas.openxmlformats.org/drawingml/2006/main">
               <a:ext uri="{FF2B5EF4-FFF2-40B4-BE49-F238E27FC236}">
-                <a16:creationId xmlns:a16="http://schemas.microsoft.com/office/drawing/2014/main" id="{8E2B485B-6D3E-44B6-83B8-0034599E7A82}"/>
+                <a16:creationId xmlns:a16="http://schemas.microsoft.com/office/drawing/2014/main" id="{788E9563-78FE-4259-91CA-FA915C06326F}"/>
               </a:ext>
             </a:extLst>
           </p:cNvPr>
@@ -7052,7 +7052,7 @@
           <p:cNvPr id="18" name="">
             <a:extLst xmlns:a="http://schemas.openxmlformats.org/drawingml/2006/main">
               <a:ext uri="{FF2B5EF4-FFF2-40B4-BE49-F238E27FC236}">
-                <a16:creationId xmlns:a16="http://schemas.microsoft.com/office/drawing/2014/main" id="{737D8BA4-F9F1-45E0-A2D9-FB381282E534}"/>
+                <a16:creationId xmlns:a16="http://schemas.microsoft.com/office/drawing/2014/main" id="{C5A06C51-1E6A-4013-8E7A-5E9B02434121}"/>
               </a:ext>
             </a:extLst>
           </p:cNvPr>
@@ -7112,7 +7112,7 @@
     </p:spTree>
     <p:extLst>
       <p:ext uri="{BB962C8B-B14F-4D97-AF65-F5344CB8AC3E}">
-        <p14:creationId xmlns:p14="http://schemas.microsoft.com/office/powerpoint/2010/main" val="829053982"/>
+        <p14:creationId xmlns:p14="http://schemas.microsoft.com/office/powerpoint/2010/main" val="392568315"/>
       </p:ext>
     </p:extLst>
   </p:cSld>
@@ -7140,7 +7140,7 @@
           <p:nvPr/>
         </p:nvPicPr>
         <p:blipFill>
-          <a:blip xmlns:r="http://schemas.openxmlformats.org/officeDocument/2006/relationships" xmlns:a="http://schemas.openxmlformats.org/drawingml/2006/main" r:embed="R942a5cd193704ab3"/>
+          <a:blip xmlns:r="http://schemas.openxmlformats.org/officeDocument/2006/relationships" xmlns:a="http://schemas.openxmlformats.org/drawingml/2006/main" r:embed="R9782fcbfce0f49d6"/>
           <a:srcRect xmlns:a="http://schemas.openxmlformats.org/drawingml/2006/main" l="0" t="0" r="0" b="0"/>
           <a:stretch xmlns:a="http://schemas.openxmlformats.org/drawingml/2006/main">
             <a:fillRect l="0" t="0" r="0" b="0"/>
@@ -7161,7 +7161,7 @@
           <p:cNvPr id="2" name="">
             <a:extLst xmlns:a="http://schemas.openxmlformats.org/drawingml/2006/main">
               <a:ext uri="{FF2B5EF4-FFF2-40B4-BE49-F238E27FC236}">
-                <a16:creationId xmlns:a16="http://schemas.microsoft.com/office/drawing/2014/main" id="{3D6FD370-1E73-48AB-8C32-C0EC19940613}"/>
+                <a16:creationId xmlns:a16="http://schemas.microsoft.com/office/drawing/2014/main" id="{738313DE-177B-4A10-92DC-8D08A2990994}"/>
               </a:ext>
             </a:extLst>
           </p:cNvPr>
@@ -7223,7 +7223,7 @@
           <p:cNvPr id="3" name="">
             <a:extLst xmlns:a="http://schemas.openxmlformats.org/drawingml/2006/main">
               <a:ext uri="{FF2B5EF4-FFF2-40B4-BE49-F238E27FC236}">
-                <a16:creationId xmlns:a16="http://schemas.microsoft.com/office/drawing/2014/main" id="{6CDA3283-565C-482E-9180-4525C1B53554}"/>
+                <a16:creationId xmlns:a16="http://schemas.microsoft.com/office/drawing/2014/main" id="{22AA2BA4-F046-497A-89D9-60A4207B6707}"/>
               </a:ext>
             </a:extLst>
           </p:cNvPr>
@@ -7285,7 +7285,7 @@
           <p:cNvPr id="4" name="">
             <a:extLst xmlns:a="http://schemas.openxmlformats.org/drawingml/2006/main">
               <a:ext uri="{FF2B5EF4-FFF2-40B4-BE49-F238E27FC236}">
-                <a16:creationId xmlns:a16="http://schemas.microsoft.com/office/drawing/2014/main" id="{D8CA1C71-4D4A-4372-A297-FB44061B3407}"/>
+                <a16:creationId xmlns:a16="http://schemas.microsoft.com/office/drawing/2014/main" id="{ECC3C223-D464-44F6-BF61-6ACD6401B169}"/>
               </a:ext>
             </a:extLst>
           </p:cNvPr>
@@ -7347,7 +7347,7 @@
           <p:cNvPr id="5" name="">
             <a:extLst xmlns:a="http://schemas.openxmlformats.org/drawingml/2006/main">
               <a:ext uri="{FF2B5EF4-FFF2-40B4-BE49-F238E27FC236}">
-                <a16:creationId xmlns:a16="http://schemas.microsoft.com/office/drawing/2014/main" id="{29CA81FF-02A8-416A-8542-F18895B5EC9F}"/>
+                <a16:creationId xmlns:a16="http://schemas.microsoft.com/office/drawing/2014/main" id="{87E8D9E6-EC3A-4375-9A63-E7B7839B7364}"/>
               </a:ext>
             </a:extLst>
           </p:cNvPr>
@@ -7378,7 +7378,7 @@
           <p:cNvPr id="6" name="">
             <a:extLst xmlns:a="http://schemas.openxmlformats.org/drawingml/2006/main">
               <a:ext uri="{FF2B5EF4-FFF2-40B4-BE49-F238E27FC236}">
-                <a16:creationId xmlns:a16="http://schemas.microsoft.com/office/drawing/2014/main" id="{CA1F8878-54A1-46CA-8B97-725CE2D91854}"/>
+                <a16:creationId xmlns:a16="http://schemas.microsoft.com/office/drawing/2014/main" id="{CCA1293C-7DF4-48AD-8592-E1E8580F4B59}"/>
               </a:ext>
             </a:extLst>
           </p:cNvPr>
@@ -7440,7 +7440,7 @@
           <p:cNvPr id="7" name="">
             <a:extLst xmlns:a="http://schemas.openxmlformats.org/drawingml/2006/main">
               <a:ext uri="{FF2B5EF4-FFF2-40B4-BE49-F238E27FC236}">
-                <a16:creationId xmlns:a16="http://schemas.microsoft.com/office/drawing/2014/main" id="{25C4CDCD-C581-4439-B4D6-38E36C0E5F1F}"/>
+                <a16:creationId xmlns:a16="http://schemas.microsoft.com/office/drawing/2014/main" id="{694477D8-A119-4BCB-903D-07F904096DF1}"/>
               </a:ext>
             </a:extLst>
           </p:cNvPr>
@@ -7473,7 +7473,7 @@
           <p:cNvPr id="8" name="">
             <a:extLst xmlns:a="http://schemas.openxmlformats.org/drawingml/2006/main">
               <a:ext uri="{FF2B5EF4-FFF2-40B4-BE49-F238E27FC236}">
-                <a16:creationId xmlns:a16="http://schemas.microsoft.com/office/drawing/2014/main" id="{422ACE3D-83B3-41D1-81A6-0FD3F813301B}"/>
+                <a16:creationId xmlns:a16="http://schemas.microsoft.com/office/drawing/2014/main" id="{DC5939A2-0792-4EB5-ADF0-5192AE7747FE}"/>
               </a:ext>
             </a:extLst>
           </p:cNvPr>
@@ -7508,7 +7508,7 @@
           <p:cNvPr id="9" name="">
             <a:extLst xmlns:a="http://schemas.openxmlformats.org/drawingml/2006/main">
               <a:ext uri="{FF2B5EF4-FFF2-40B4-BE49-F238E27FC236}">
-                <a16:creationId xmlns:a16="http://schemas.microsoft.com/office/drawing/2014/main" id="{898344A7-F83C-4C6B-B6F4-860F58E7BD87}"/>
+                <a16:creationId xmlns:a16="http://schemas.microsoft.com/office/drawing/2014/main" id="{A3A26477-742A-48CC-B26A-82EA9BD714DE}"/>
               </a:ext>
             </a:extLst>
           </p:cNvPr>
@@ -7539,7 +7539,7 @@
           <p:cNvPr id="10" name="">
             <a:extLst xmlns:a="http://schemas.openxmlformats.org/drawingml/2006/main">
               <a:ext uri="{FF2B5EF4-FFF2-40B4-BE49-F238E27FC236}">
-                <a16:creationId xmlns:a16="http://schemas.microsoft.com/office/drawing/2014/main" id="{ABA77B6F-257C-469A-977A-A30DC2963EC5}"/>
+                <a16:creationId xmlns:a16="http://schemas.microsoft.com/office/drawing/2014/main" id="{900F1A7B-2C95-48B5-9265-7D12414EFAC2}"/>
               </a:ext>
             </a:extLst>
           </p:cNvPr>
@@ -7601,7 +7601,7 @@
           <p:cNvPr id="11" name="">
             <a:extLst xmlns:a="http://schemas.openxmlformats.org/drawingml/2006/main">
               <a:ext uri="{FF2B5EF4-FFF2-40B4-BE49-F238E27FC236}">
-                <a16:creationId xmlns:a16="http://schemas.microsoft.com/office/drawing/2014/main" id="{EC4E7EE8-E897-4543-BDEF-DB54CFA7CA9E}"/>
+                <a16:creationId xmlns:a16="http://schemas.microsoft.com/office/drawing/2014/main" id="{45E4D960-890A-46A5-BE84-70B07AD377E9}"/>
               </a:ext>
             </a:extLst>
           </p:cNvPr>
@@ -7663,7 +7663,7 @@
           <p:cNvPr id="12" name="">
             <a:extLst xmlns:a="http://schemas.openxmlformats.org/drawingml/2006/main">
               <a:ext uri="{FF2B5EF4-FFF2-40B4-BE49-F238E27FC236}">
-                <a16:creationId xmlns:a16="http://schemas.microsoft.com/office/drawing/2014/main" id="{CCEAA02B-06AC-4280-B26E-C673A66FE1C6}"/>
+                <a16:creationId xmlns:a16="http://schemas.microsoft.com/office/drawing/2014/main" id="{39C5E607-6F74-49EF-874F-8F926BE5A960}"/>
               </a:ext>
             </a:extLst>
           </p:cNvPr>
@@ -7696,7 +7696,7 @@
           <p:cNvPr id="13" name="">
             <a:extLst xmlns:a="http://schemas.openxmlformats.org/drawingml/2006/main">
               <a:ext uri="{FF2B5EF4-FFF2-40B4-BE49-F238E27FC236}">
-                <a16:creationId xmlns:a16="http://schemas.microsoft.com/office/drawing/2014/main" id="{98CAF631-8A8E-480F-8005-8A0174A2C22D}"/>
+                <a16:creationId xmlns:a16="http://schemas.microsoft.com/office/drawing/2014/main" id="{EB2AD9D2-2D1C-43F2-B478-85C51CBE4665}"/>
               </a:ext>
             </a:extLst>
           </p:cNvPr>
@@ -7731,7 +7731,7 @@
           <p:cNvPr id="14" name="">
             <a:extLst xmlns:a="http://schemas.openxmlformats.org/drawingml/2006/main">
               <a:ext uri="{FF2B5EF4-FFF2-40B4-BE49-F238E27FC236}">
-                <a16:creationId xmlns:a16="http://schemas.microsoft.com/office/drawing/2014/main" id="{BDB0FE35-34A7-4AC0-BCB1-D5554312AFCD}"/>
+                <a16:creationId xmlns:a16="http://schemas.microsoft.com/office/drawing/2014/main" id="{BC7A25CE-F707-4C2D-B480-B9A5985D2E59}"/>
               </a:ext>
             </a:extLst>
           </p:cNvPr>
@@ -7762,7 +7762,7 @@
           <p:cNvPr id="15" name="">
             <a:extLst xmlns:a="http://schemas.openxmlformats.org/drawingml/2006/main">
               <a:ext uri="{FF2B5EF4-FFF2-40B4-BE49-F238E27FC236}">
-                <a16:creationId xmlns:a16="http://schemas.microsoft.com/office/drawing/2014/main" id="{A4391AF3-4DFA-4FB0-B2D1-4ADE775DBBDE}"/>
+                <a16:creationId xmlns:a16="http://schemas.microsoft.com/office/drawing/2014/main" id="{14A0A970-AEC2-4288-BF02-78E277ADDBB4}"/>
               </a:ext>
             </a:extLst>
           </p:cNvPr>
@@ -7824,7 +7824,7 @@
           <p:cNvPr id="16" name="">
             <a:extLst xmlns:a="http://schemas.openxmlformats.org/drawingml/2006/main">
               <a:ext uri="{FF2B5EF4-FFF2-40B4-BE49-F238E27FC236}">
-                <a16:creationId xmlns:a16="http://schemas.microsoft.com/office/drawing/2014/main" id="{E68E4422-3A7D-4B6A-B336-5BF72AC7FE43}"/>
+                <a16:creationId xmlns:a16="http://schemas.microsoft.com/office/drawing/2014/main" id="{F43A68B9-69CF-47CB-A0F2-16B999EAA5E4}"/>
               </a:ext>
             </a:extLst>
           </p:cNvPr>
@@ -7886,7 +7886,7 @@
           <p:cNvPr id="17" name="">
             <a:extLst xmlns:a="http://schemas.openxmlformats.org/drawingml/2006/main">
               <a:ext uri="{FF2B5EF4-FFF2-40B4-BE49-F238E27FC236}">
-                <a16:creationId xmlns:a16="http://schemas.microsoft.com/office/drawing/2014/main" id="{A5695D50-2CF4-400A-B2F5-F6224432B3B5}"/>
+                <a16:creationId xmlns:a16="http://schemas.microsoft.com/office/drawing/2014/main" id="{38F92363-C07F-4326-9CBE-5316104274C6}"/>
               </a:ext>
             </a:extLst>
           </p:cNvPr>
@@ -7948,7 +7948,7 @@
           <p:cNvPr id="18" name="">
             <a:extLst xmlns:a="http://schemas.openxmlformats.org/drawingml/2006/main">
               <a:ext uri="{FF2B5EF4-FFF2-40B4-BE49-F238E27FC236}">
-                <a16:creationId xmlns:a16="http://schemas.microsoft.com/office/drawing/2014/main" id="{F72EB353-7809-439B-915C-86E90BCD8A8F}"/>
+                <a16:creationId xmlns:a16="http://schemas.microsoft.com/office/drawing/2014/main" id="{18210A3E-9347-4055-97C2-92EA19A68A50}"/>
               </a:ext>
             </a:extLst>
           </p:cNvPr>
@@ -8008,7 +8008,7 @@
     </p:spTree>
     <p:extLst>
       <p:ext uri="{BB962C8B-B14F-4D97-AF65-F5344CB8AC3E}">
-        <p14:creationId xmlns:p14="http://schemas.microsoft.com/office/powerpoint/2010/main" val="1478594440"/>
+        <p14:creationId xmlns:p14="http://schemas.microsoft.com/office/powerpoint/2010/main" val="1432043354"/>
       </p:ext>
     </p:extLst>
   </p:cSld>
@@ -8036,7 +8036,7 @@
           <p:nvPr/>
         </p:nvPicPr>
         <p:blipFill>
-          <a:blip xmlns:r="http://schemas.openxmlformats.org/officeDocument/2006/relationships" xmlns:a="http://schemas.openxmlformats.org/drawingml/2006/main" r:embed="R98f827bcba66480d"/>
+          <a:blip xmlns:r="http://schemas.openxmlformats.org/officeDocument/2006/relationships" xmlns:a="http://schemas.openxmlformats.org/drawingml/2006/main" r:embed="Re7b683d4dda641b1"/>
           <a:srcRect xmlns:a="http://schemas.openxmlformats.org/drawingml/2006/main" l="0" t="0" r="0" b="0"/>
           <a:stretch xmlns:a="http://schemas.openxmlformats.org/drawingml/2006/main">
             <a:fillRect l="0" t="0" r="0" b="0"/>
@@ -8057,7 +8057,7 @@
           <p:cNvPr id="2" name="">
             <a:extLst xmlns:a="http://schemas.openxmlformats.org/drawingml/2006/main">
               <a:ext uri="{FF2B5EF4-FFF2-40B4-BE49-F238E27FC236}">
-                <a16:creationId xmlns:a16="http://schemas.microsoft.com/office/drawing/2014/main" id="{3A5F71F8-5532-4C47-BF60-EE65BF826CC6}"/>
+                <a16:creationId xmlns:a16="http://schemas.microsoft.com/office/drawing/2014/main" id="{3C4867C4-D1B6-40C5-9F64-8F8242C67F1D}"/>
               </a:ext>
             </a:extLst>
           </p:cNvPr>
@@ -8119,7 +8119,7 @@
           <p:cNvPr id="3" name="">
             <a:extLst xmlns:a="http://schemas.openxmlformats.org/drawingml/2006/main">
               <a:ext uri="{FF2B5EF4-FFF2-40B4-BE49-F238E27FC236}">
-                <a16:creationId xmlns:a16="http://schemas.microsoft.com/office/drawing/2014/main" id="{4DEFC059-CF2D-49FF-9429-AC469C32EFB7}"/>
+                <a16:creationId xmlns:a16="http://schemas.microsoft.com/office/drawing/2014/main" id="{8CF2B493-37FA-4DFF-B0F1-2B35DEA7DC02}"/>
               </a:ext>
             </a:extLst>
           </p:cNvPr>
@@ -8181,7 +8181,7 @@
           <p:cNvPr id="4" name="">
             <a:extLst xmlns:a="http://schemas.openxmlformats.org/drawingml/2006/main">
               <a:ext uri="{FF2B5EF4-FFF2-40B4-BE49-F238E27FC236}">
-                <a16:creationId xmlns:a16="http://schemas.microsoft.com/office/drawing/2014/main" id="{54E14AEE-7175-4704-BF41-47E0DD5EC98B}"/>
+                <a16:creationId xmlns:a16="http://schemas.microsoft.com/office/drawing/2014/main" id="{DEA1B38E-EC6B-4BCB-AC58-2FB50021B654}"/>
               </a:ext>
             </a:extLst>
           </p:cNvPr>
@@ -8243,7 +8243,7 @@
           <p:cNvPr id="5" name="">
             <a:extLst xmlns:a="http://schemas.openxmlformats.org/drawingml/2006/main">
               <a:ext uri="{FF2B5EF4-FFF2-40B4-BE49-F238E27FC236}">
-                <a16:creationId xmlns:a16="http://schemas.microsoft.com/office/drawing/2014/main" id="{1A2E5BC8-A347-436E-8EE8-A512FBE10425}"/>
+                <a16:creationId xmlns:a16="http://schemas.microsoft.com/office/drawing/2014/main" id="{2358497D-6186-41E2-84E2-CF34F98F5304}"/>
               </a:ext>
             </a:extLst>
           </p:cNvPr>
@@ -8274,7 +8274,7 @@
           <p:cNvPr id="6" name="">
             <a:extLst xmlns:a="http://schemas.openxmlformats.org/drawingml/2006/main">
               <a:ext uri="{FF2B5EF4-FFF2-40B4-BE49-F238E27FC236}">
-                <a16:creationId xmlns:a16="http://schemas.microsoft.com/office/drawing/2014/main" id="{2A71AFCF-CFF8-48A3-8294-49F0426634CC}"/>
+                <a16:creationId xmlns:a16="http://schemas.microsoft.com/office/drawing/2014/main" id="{A95095BC-391B-4EE7-B285-65C32F8545E8}"/>
               </a:ext>
             </a:extLst>
           </p:cNvPr>
@@ -8336,7 +8336,7 @@
           <p:cNvPr id="7" name="">
             <a:extLst xmlns:a="http://schemas.openxmlformats.org/drawingml/2006/main">
               <a:ext uri="{FF2B5EF4-FFF2-40B4-BE49-F238E27FC236}">
-                <a16:creationId xmlns:a16="http://schemas.microsoft.com/office/drawing/2014/main" id="{55B6DB75-244F-4C64-9F72-D04B3061EE38}"/>
+                <a16:creationId xmlns:a16="http://schemas.microsoft.com/office/drawing/2014/main" id="{6E03BBE6-105D-4BBA-9A46-299929EB491D}"/>
               </a:ext>
             </a:extLst>
           </p:cNvPr>
@@ -8369,7 +8369,7 @@
           <p:cNvPr id="8" name="">
             <a:extLst xmlns:a="http://schemas.openxmlformats.org/drawingml/2006/main">
               <a:ext uri="{FF2B5EF4-FFF2-40B4-BE49-F238E27FC236}">
-                <a16:creationId xmlns:a16="http://schemas.microsoft.com/office/drawing/2014/main" id="{34DF6B4A-2CBE-42B2-AEE1-0920971375A5}"/>
+                <a16:creationId xmlns:a16="http://schemas.microsoft.com/office/drawing/2014/main" id="{29657EF3-FE17-4DE3-AA4F-D6297EBB1DCA}"/>
               </a:ext>
             </a:extLst>
           </p:cNvPr>
@@ -8404,7 +8404,7 @@
           <p:cNvPr id="9" name="">
             <a:extLst xmlns:a="http://schemas.openxmlformats.org/drawingml/2006/main">
               <a:ext uri="{FF2B5EF4-FFF2-40B4-BE49-F238E27FC236}">
-                <a16:creationId xmlns:a16="http://schemas.microsoft.com/office/drawing/2014/main" id="{D97F038B-6A6E-41C1-A8E3-4E8AFE742E71}"/>
+                <a16:creationId xmlns:a16="http://schemas.microsoft.com/office/drawing/2014/main" id="{6EF24ABB-E7AA-4E02-A6FE-5B35725495EC}"/>
               </a:ext>
             </a:extLst>
           </p:cNvPr>
@@ -8435,7 +8435,7 @@
           <p:cNvPr id="10" name="">
             <a:extLst xmlns:a="http://schemas.openxmlformats.org/drawingml/2006/main">
               <a:ext uri="{FF2B5EF4-FFF2-40B4-BE49-F238E27FC236}">
-                <a16:creationId xmlns:a16="http://schemas.microsoft.com/office/drawing/2014/main" id="{61C724FB-AFA6-4E3A-B213-0E0FAF21CC7A}"/>
+                <a16:creationId xmlns:a16="http://schemas.microsoft.com/office/drawing/2014/main" id="{2C92F2F3-2AF3-4EE5-A6B5-542C7E2E5488}"/>
               </a:ext>
             </a:extLst>
           </p:cNvPr>
@@ -8497,7 +8497,7 @@
           <p:cNvPr id="11" name="">
             <a:extLst xmlns:a="http://schemas.openxmlformats.org/drawingml/2006/main">
               <a:ext uri="{FF2B5EF4-FFF2-40B4-BE49-F238E27FC236}">
-                <a16:creationId xmlns:a16="http://schemas.microsoft.com/office/drawing/2014/main" id="{BEB4DCB1-D123-40B7-9488-1B84B9A2968B}"/>
+                <a16:creationId xmlns:a16="http://schemas.microsoft.com/office/drawing/2014/main" id="{64D8E1E6-1AF2-419F-A840-6CA2B1A575BD}"/>
               </a:ext>
             </a:extLst>
           </p:cNvPr>
@@ -8559,7 +8559,7 @@
           <p:cNvPr id="12" name="">
             <a:extLst xmlns:a="http://schemas.openxmlformats.org/drawingml/2006/main">
               <a:ext uri="{FF2B5EF4-FFF2-40B4-BE49-F238E27FC236}">
-                <a16:creationId xmlns:a16="http://schemas.microsoft.com/office/drawing/2014/main" id="{B1BDDBC1-B2E7-43F7-8551-086C265F2DFE}"/>
+                <a16:creationId xmlns:a16="http://schemas.microsoft.com/office/drawing/2014/main" id="{0AE94614-CDBB-4FA2-A984-CF675D299B10}"/>
               </a:ext>
             </a:extLst>
           </p:cNvPr>
@@ -8592,7 +8592,7 @@
           <p:cNvPr id="13" name="">
             <a:extLst xmlns:a="http://schemas.openxmlformats.org/drawingml/2006/main">
               <a:ext uri="{FF2B5EF4-FFF2-40B4-BE49-F238E27FC236}">
-                <a16:creationId xmlns:a16="http://schemas.microsoft.com/office/drawing/2014/main" id="{47380699-4285-4F04-8285-D2E12A1DB748}"/>
+                <a16:creationId xmlns:a16="http://schemas.microsoft.com/office/drawing/2014/main" id="{7FBBA266-DAC3-4D48-9520-695EB45C48EE}"/>
               </a:ext>
             </a:extLst>
           </p:cNvPr>
@@ -8627,7 +8627,7 @@
           <p:cNvPr id="14" name="">
             <a:extLst xmlns:a="http://schemas.openxmlformats.org/drawingml/2006/main">
               <a:ext uri="{FF2B5EF4-FFF2-40B4-BE49-F238E27FC236}">
-                <a16:creationId xmlns:a16="http://schemas.microsoft.com/office/drawing/2014/main" id="{C626254F-711D-4B47-AEA5-993E8B96BCDC}"/>
+                <a16:creationId xmlns:a16="http://schemas.microsoft.com/office/drawing/2014/main" id="{B288AEED-7FF9-41BD-AB1C-C752D303FAB7}"/>
               </a:ext>
             </a:extLst>
           </p:cNvPr>
@@ -8658,7 +8658,7 @@
           <p:cNvPr id="15" name="">
             <a:extLst xmlns:a="http://schemas.openxmlformats.org/drawingml/2006/main">
               <a:ext uri="{FF2B5EF4-FFF2-40B4-BE49-F238E27FC236}">
-                <a16:creationId xmlns:a16="http://schemas.microsoft.com/office/drawing/2014/main" id="{5144C6C6-E977-4946-940C-EA3B6A95ED9C}"/>
+                <a16:creationId xmlns:a16="http://schemas.microsoft.com/office/drawing/2014/main" id="{46D3F723-FFB0-4AD5-9E3E-9CF9057F3228}"/>
               </a:ext>
             </a:extLst>
           </p:cNvPr>
@@ -8720,7 +8720,7 @@
           <p:cNvPr id="16" name="">
             <a:extLst xmlns:a="http://schemas.openxmlformats.org/drawingml/2006/main">
               <a:ext uri="{FF2B5EF4-FFF2-40B4-BE49-F238E27FC236}">
-                <a16:creationId xmlns:a16="http://schemas.microsoft.com/office/drawing/2014/main" id="{D60D837C-4E09-4E5D-B817-4B9D61CB5A46}"/>
+                <a16:creationId xmlns:a16="http://schemas.microsoft.com/office/drawing/2014/main" id="{1A1A7DF0-1F77-4D61-8AAF-586AC3FD8D47}"/>
               </a:ext>
             </a:extLst>
           </p:cNvPr>
@@ -8782,7 +8782,7 @@
           <p:cNvPr id="17" name="">
             <a:extLst xmlns:a="http://schemas.openxmlformats.org/drawingml/2006/main">
               <a:ext uri="{FF2B5EF4-FFF2-40B4-BE49-F238E27FC236}">
-                <a16:creationId xmlns:a16="http://schemas.microsoft.com/office/drawing/2014/main" id="{6F81FF2F-EF4D-4A64-AAA5-0C49F1150BDB}"/>
+                <a16:creationId xmlns:a16="http://schemas.microsoft.com/office/drawing/2014/main" id="{7F8179E7-C05E-41F5-8809-9379D51998E7}"/>
               </a:ext>
             </a:extLst>
           </p:cNvPr>
@@ -8844,7 +8844,7 @@
           <p:cNvPr id="18" name="">
             <a:extLst xmlns:a="http://schemas.openxmlformats.org/drawingml/2006/main">
               <a:ext uri="{FF2B5EF4-FFF2-40B4-BE49-F238E27FC236}">
-                <a16:creationId xmlns:a16="http://schemas.microsoft.com/office/drawing/2014/main" id="{B66F7C7B-69BF-4FC2-9C9B-1095763E0521}"/>
+                <a16:creationId xmlns:a16="http://schemas.microsoft.com/office/drawing/2014/main" id="{FB438B1F-009C-4822-943E-8AD281118065}"/>
               </a:ext>
             </a:extLst>
           </p:cNvPr>
@@ -8904,7 +8904,7 @@
     </p:spTree>
     <p:extLst>
       <p:ext uri="{BB962C8B-B14F-4D97-AF65-F5344CB8AC3E}">
-        <p14:creationId xmlns:p14="http://schemas.microsoft.com/office/powerpoint/2010/main" val="395629450"/>
+        <p14:creationId xmlns:p14="http://schemas.microsoft.com/office/powerpoint/2010/main" val="2005573897"/>
       </p:ext>
     </p:extLst>
   </p:cSld>
@@ -8932,7 +8932,7 @@
           <p:nvPr/>
         </p:nvPicPr>
         <p:blipFill>
-          <a:blip xmlns:r="http://schemas.openxmlformats.org/officeDocument/2006/relationships" xmlns:a="http://schemas.openxmlformats.org/drawingml/2006/main" r:embed="Rb94b86745d554c03"/>
+          <a:blip xmlns:r="http://schemas.openxmlformats.org/officeDocument/2006/relationships" xmlns:a="http://schemas.openxmlformats.org/drawingml/2006/main" r:embed="R5c4f54a089604e4a"/>
           <a:srcRect xmlns:a="http://schemas.openxmlformats.org/drawingml/2006/main" l="0" t="0" r="0" b="0"/>
           <a:stretch xmlns:a="http://schemas.openxmlformats.org/drawingml/2006/main">
             <a:fillRect l="0" t="0" r="0" b="0"/>
@@ -8953,7 +8953,7 @@
           <p:cNvPr id="2" name="">
             <a:extLst xmlns:a="http://schemas.openxmlformats.org/drawingml/2006/main">
               <a:ext uri="{FF2B5EF4-FFF2-40B4-BE49-F238E27FC236}">
-                <a16:creationId xmlns:a16="http://schemas.microsoft.com/office/drawing/2014/main" id="{714527CE-1C08-4D35-BBF7-67F99576204D}"/>
+                <a16:creationId xmlns:a16="http://schemas.microsoft.com/office/drawing/2014/main" id="{B1CE8BF3-F5E5-4BFA-B6EE-A42F6AADA3BE}"/>
               </a:ext>
             </a:extLst>
           </p:cNvPr>
@@ -9015,7 +9015,7 @@
           <p:cNvPr id="3" name="">
             <a:extLst xmlns:a="http://schemas.openxmlformats.org/drawingml/2006/main">
               <a:ext uri="{FF2B5EF4-FFF2-40B4-BE49-F238E27FC236}">
-                <a16:creationId xmlns:a16="http://schemas.microsoft.com/office/drawing/2014/main" id="{00B63695-052D-43EC-9EBE-B8D377711F18}"/>
+                <a16:creationId xmlns:a16="http://schemas.microsoft.com/office/drawing/2014/main" id="{A6FF4348-7C28-480B-8F66-8C80CB8A76B3}"/>
               </a:ext>
             </a:extLst>
           </p:cNvPr>
@@ -9077,7 +9077,7 @@
           <p:cNvPr id="4" name="">
             <a:extLst xmlns:a="http://schemas.openxmlformats.org/drawingml/2006/main">
               <a:ext uri="{FF2B5EF4-FFF2-40B4-BE49-F238E27FC236}">
-                <a16:creationId xmlns:a16="http://schemas.microsoft.com/office/drawing/2014/main" id="{0F17FBBF-E463-4323-A9CD-D4915019E092}"/>
+                <a16:creationId xmlns:a16="http://schemas.microsoft.com/office/drawing/2014/main" id="{2209FAC5-B4CF-4E0C-8006-107174B6B919}"/>
               </a:ext>
             </a:extLst>
           </p:cNvPr>
@@ -9139,7 +9139,7 @@
           <p:cNvPr id="5" name="">
             <a:extLst xmlns:a="http://schemas.openxmlformats.org/drawingml/2006/main">
               <a:ext uri="{FF2B5EF4-FFF2-40B4-BE49-F238E27FC236}">
-                <a16:creationId xmlns:a16="http://schemas.microsoft.com/office/drawing/2014/main" id="{89887E59-B456-4BF5-B457-D14F1D1C3486}"/>
+                <a16:creationId xmlns:a16="http://schemas.microsoft.com/office/drawing/2014/main" id="{5B94EB3D-F453-4BA9-BAEA-EE3A0C677FE0}"/>
               </a:ext>
             </a:extLst>
           </p:cNvPr>
@@ -9170,7 +9170,7 @@
           <p:cNvPr id="6" name="">
             <a:extLst xmlns:a="http://schemas.openxmlformats.org/drawingml/2006/main">
               <a:ext uri="{FF2B5EF4-FFF2-40B4-BE49-F238E27FC236}">
-                <a16:creationId xmlns:a16="http://schemas.microsoft.com/office/drawing/2014/main" id="{C69A1171-A889-4831-86FE-037C31F731B4}"/>
+                <a16:creationId xmlns:a16="http://schemas.microsoft.com/office/drawing/2014/main" id="{3EE608A6-76F1-4AD8-BFD9-33E7CFDDDB44}"/>
               </a:ext>
             </a:extLst>
           </p:cNvPr>
@@ -9232,7 +9232,7 @@
           <p:cNvPr id="7" name="">
             <a:extLst xmlns:a="http://schemas.openxmlformats.org/drawingml/2006/main">
               <a:ext uri="{FF2B5EF4-FFF2-40B4-BE49-F238E27FC236}">
-                <a16:creationId xmlns:a16="http://schemas.microsoft.com/office/drawing/2014/main" id="{9211F79D-2F2F-4001-8FAA-25D8738AFFDF}"/>
+                <a16:creationId xmlns:a16="http://schemas.microsoft.com/office/drawing/2014/main" id="{2A8E5EBE-4D90-4B94-8F61-DE1BFD4EE1C7}"/>
               </a:ext>
             </a:extLst>
           </p:cNvPr>
@@ -9265,7 +9265,7 @@
           <p:cNvPr id="8" name="">
             <a:extLst xmlns:a="http://schemas.openxmlformats.org/drawingml/2006/main">
               <a:ext uri="{FF2B5EF4-FFF2-40B4-BE49-F238E27FC236}">
-                <a16:creationId xmlns:a16="http://schemas.microsoft.com/office/drawing/2014/main" id="{5A2E616D-38C1-410E-89C0-3640EC379667}"/>
+                <a16:creationId xmlns:a16="http://schemas.microsoft.com/office/drawing/2014/main" id="{56CB9461-6017-4455-9C64-E8C95F826E81}"/>
               </a:ext>
             </a:extLst>
           </p:cNvPr>
@@ -9300,7 +9300,7 @@
           <p:cNvPr id="9" name="">
             <a:extLst xmlns:a="http://schemas.openxmlformats.org/drawingml/2006/main">
               <a:ext uri="{FF2B5EF4-FFF2-40B4-BE49-F238E27FC236}">
-                <a16:creationId xmlns:a16="http://schemas.microsoft.com/office/drawing/2014/main" id="{90CE0110-3672-4AF9-B0C1-F7D0BEC47859}"/>
+                <a16:creationId xmlns:a16="http://schemas.microsoft.com/office/drawing/2014/main" id="{A8BB0F9C-257F-44A9-A022-5F90F11374FE}"/>
               </a:ext>
             </a:extLst>
           </p:cNvPr>
@@ -9331,7 +9331,7 @@
           <p:cNvPr id="10" name="">
             <a:extLst xmlns:a="http://schemas.openxmlformats.org/drawingml/2006/main">
               <a:ext uri="{FF2B5EF4-FFF2-40B4-BE49-F238E27FC236}">
-                <a16:creationId xmlns:a16="http://schemas.microsoft.com/office/drawing/2014/main" id="{6FB5AD39-9F27-47B7-983B-E56214CD9840}"/>
+                <a16:creationId xmlns:a16="http://schemas.microsoft.com/office/drawing/2014/main" id="{DA467407-FC20-435E-ADFB-FCF2CFA85D6A}"/>
               </a:ext>
             </a:extLst>
           </p:cNvPr>
@@ -9393,7 +9393,7 @@
           <p:cNvPr id="11" name="">
             <a:extLst xmlns:a="http://schemas.openxmlformats.org/drawingml/2006/main">
               <a:ext uri="{FF2B5EF4-FFF2-40B4-BE49-F238E27FC236}">
-                <a16:creationId xmlns:a16="http://schemas.microsoft.com/office/drawing/2014/main" id="{9DC2E2D6-3D78-4BDA-BDBF-979712D849F2}"/>
+                <a16:creationId xmlns:a16="http://schemas.microsoft.com/office/drawing/2014/main" id="{7C6970DC-5B61-462F-83B7-C151B7F8BE69}"/>
               </a:ext>
             </a:extLst>
           </p:cNvPr>
@@ -9455,7 +9455,7 @@
           <p:cNvPr id="12" name="">
             <a:extLst xmlns:a="http://schemas.openxmlformats.org/drawingml/2006/main">
               <a:ext uri="{FF2B5EF4-FFF2-40B4-BE49-F238E27FC236}">
-                <a16:creationId xmlns:a16="http://schemas.microsoft.com/office/drawing/2014/main" id="{9F6CE6F9-527C-4750-A503-9B7BB244CABF}"/>
+                <a16:creationId xmlns:a16="http://schemas.microsoft.com/office/drawing/2014/main" id="{8A9851EA-B9D2-4C3F-B32C-8E1D23E713BF}"/>
               </a:ext>
             </a:extLst>
           </p:cNvPr>
@@ -9517,7 +9517,7 @@
           <p:cNvPr id="13" name="">
             <a:extLst xmlns:a="http://schemas.openxmlformats.org/drawingml/2006/main">
               <a:ext uri="{FF2B5EF4-FFF2-40B4-BE49-F238E27FC236}">
-                <a16:creationId xmlns:a16="http://schemas.microsoft.com/office/drawing/2014/main" id="{D6ECF83C-7BCF-4E98-85B7-97263507D45E}"/>
+                <a16:creationId xmlns:a16="http://schemas.microsoft.com/office/drawing/2014/main" id="{F185180D-923A-4344-9C52-63CB84344313}"/>
               </a:ext>
             </a:extLst>
           </p:cNvPr>
@@ -9550,7 +9550,7 @@
           <p:cNvPr id="14" name="">
             <a:extLst xmlns:a="http://schemas.openxmlformats.org/drawingml/2006/main">
               <a:ext uri="{FF2B5EF4-FFF2-40B4-BE49-F238E27FC236}">
-                <a16:creationId xmlns:a16="http://schemas.microsoft.com/office/drawing/2014/main" id="{0742CAC1-8261-4BAE-9900-6EF9AFC0F012}"/>
+                <a16:creationId xmlns:a16="http://schemas.microsoft.com/office/drawing/2014/main" id="{AD5B32B6-FE99-431C-B9EA-95D79A45D4DE}"/>
               </a:ext>
             </a:extLst>
           </p:cNvPr>
@@ -9585,7 +9585,7 @@
           <p:cNvPr id="15" name="">
             <a:extLst xmlns:a="http://schemas.openxmlformats.org/drawingml/2006/main">
               <a:ext uri="{FF2B5EF4-FFF2-40B4-BE49-F238E27FC236}">
-                <a16:creationId xmlns:a16="http://schemas.microsoft.com/office/drawing/2014/main" id="{51A5B69B-4089-4049-98BD-43267BA866C7}"/>
+                <a16:creationId xmlns:a16="http://schemas.microsoft.com/office/drawing/2014/main" id="{64A2394F-0635-4F34-B82C-D77D9F480DED}"/>
               </a:ext>
             </a:extLst>
           </p:cNvPr>
@@ -9616,7 +9616,7 @@
           <p:cNvPr id="16" name="">
             <a:extLst xmlns:a="http://schemas.openxmlformats.org/drawingml/2006/main">
               <a:ext uri="{FF2B5EF4-FFF2-40B4-BE49-F238E27FC236}">
-                <a16:creationId xmlns:a16="http://schemas.microsoft.com/office/drawing/2014/main" id="{5084279E-957D-40E9-AEE5-1155DFA1DAE0}"/>
+                <a16:creationId xmlns:a16="http://schemas.microsoft.com/office/drawing/2014/main" id="{9D546D5B-7783-4D81-A7A1-EEAFE55F44F7}"/>
               </a:ext>
             </a:extLst>
           </p:cNvPr>
@@ -9678,7 +9678,7 @@
           <p:cNvPr id="17" name="">
             <a:extLst xmlns:a="http://schemas.openxmlformats.org/drawingml/2006/main">
               <a:ext uri="{FF2B5EF4-FFF2-40B4-BE49-F238E27FC236}">
-                <a16:creationId xmlns:a16="http://schemas.microsoft.com/office/drawing/2014/main" id="{744D1EB7-465F-4C23-8C8F-935B433B403B}"/>
+                <a16:creationId xmlns:a16="http://schemas.microsoft.com/office/drawing/2014/main" id="{7EBEF281-E096-47D9-AB0F-F117433CE863}"/>
               </a:ext>
             </a:extLst>
           </p:cNvPr>
@@ -9740,7 +9740,7 @@
           <p:cNvPr id="18" name="">
             <a:extLst xmlns:a="http://schemas.openxmlformats.org/drawingml/2006/main">
               <a:ext uri="{FF2B5EF4-FFF2-40B4-BE49-F238E27FC236}">
-                <a16:creationId xmlns:a16="http://schemas.microsoft.com/office/drawing/2014/main" id="{38334D44-2CBB-4770-928B-5539A0FDA066}"/>
+                <a16:creationId xmlns:a16="http://schemas.microsoft.com/office/drawing/2014/main" id="{0D3ED167-E28A-4968-AC52-BFA09A500C18}"/>
               </a:ext>
             </a:extLst>
           </p:cNvPr>
@@ -9802,7 +9802,7 @@
           <p:cNvPr id="19" name="">
             <a:extLst xmlns:a="http://schemas.openxmlformats.org/drawingml/2006/main">
               <a:ext uri="{FF2B5EF4-FFF2-40B4-BE49-F238E27FC236}">
-                <a16:creationId xmlns:a16="http://schemas.microsoft.com/office/drawing/2014/main" id="{893F0CEE-2846-4CDF-A728-172C79BDB75F}"/>
+                <a16:creationId xmlns:a16="http://schemas.microsoft.com/office/drawing/2014/main" id="{B30E9690-626B-4D64-BB2D-C4DFB3890486}"/>
               </a:ext>
             </a:extLst>
           </p:cNvPr>
@@ -9835,7 +9835,7 @@
           <p:cNvPr id="20" name="">
             <a:extLst xmlns:a="http://schemas.openxmlformats.org/drawingml/2006/main">
               <a:ext uri="{FF2B5EF4-FFF2-40B4-BE49-F238E27FC236}">
-                <a16:creationId xmlns:a16="http://schemas.microsoft.com/office/drawing/2014/main" id="{846872C3-B3FB-411B-97A8-F804013D426E}"/>
+                <a16:creationId xmlns:a16="http://schemas.microsoft.com/office/drawing/2014/main" id="{2F407504-E51E-4D2F-99C3-1A8A10481FA9}"/>
               </a:ext>
             </a:extLst>
           </p:cNvPr>
@@ -9870,7 +9870,7 @@
           <p:cNvPr id="21" name="">
             <a:extLst xmlns:a="http://schemas.openxmlformats.org/drawingml/2006/main">
               <a:ext uri="{FF2B5EF4-FFF2-40B4-BE49-F238E27FC236}">
-                <a16:creationId xmlns:a16="http://schemas.microsoft.com/office/drawing/2014/main" id="{918D34B8-1F4B-4F0D-9729-48A0BFFC606E}"/>
+                <a16:creationId xmlns:a16="http://schemas.microsoft.com/office/drawing/2014/main" id="{794C9F14-B880-41B0-81FD-582971CD8AE3}"/>
               </a:ext>
             </a:extLst>
           </p:cNvPr>
@@ -9901,7 +9901,7 @@
           <p:cNvPr id="22" name="">
             <a:extLst xmlns:a="http://schemas.openxmlformats.org/drawingml/2006/main">
               <a:ext uri="{FF2B5EF4-FFF2-40B4-BE49-F238E27FC236}">
-                <a16:creationId xmlns:a16="http://schemas.microsoft.com/office/drawing/2014/main" id="{E0EAAEB4-8723-4C62-816E-9C59AA765CA5}"/>
+                <a16:creationId xmlns:a16="http://schemas.microsoft.com/office/drawing/2014/main" id="{DF488722-F7A0-4C2E-8E84-2E298DFF603F}"/>
               </a:ext>
             </a:extLst>
           </p:cNvPr>
@@ -9963,7 +9963,7 @@
           <p:cNvPr id="23" name="">
             <a:extLst xmlns:a="http://schemas.openxmlformats.org/drawingml/2006/main">
               <a:ext uri="{FF2B5EF4-FFF2-40B4-BE49-F238E27FC236}">
-                <a16:creationId xmlns:a16="http://schemas.microsoft.com/office/drawing/2014/main" id="{CB7F07CC-CDEF-4BF0-8121-8DA81A06FA08}"/>
+                <a16:creationId xmlns:a16="http://schemas.microsoft.com/office/drawing/2014/main" id="{91D44AE9-AD09-4AB7-A7DD-001E3C98646B}"/>
               </a:ext>
             </a:extLst>
           </p:cNvPr>
@@ -10025,7 +10025,7 @@
           <p:cNvPr id="24" name="">
             <a:extLst xmlns:a="http://schemas.openxmlformats.org/drawingml/2006/main">
               <a:ext uri="{FF2B5EF4-FFF2-40B4-BE49-F238E27FC236}">
-                <a16:creationId xmlns:a16="http://schemas.microsoft.com/office/drawing/2014/main" id="{0B8DE7B1-4BD0-46F5-89BE-E56A5BEF7403}"/>
+                <a16:creationId xmlns:a16="http://schemas.microsoft.com/office/drawing/2014/main" id="{723EB7F6-73A4-4C46-8D20-F89AEE45E993}"/>
               </a:ext>
             </a:extLst>
           </p:cNvPr>
@@ -10087,7 +10087,7 @@
           <p:cNvPr id="25" name="">
             <a:extLst xmlns:a="http://schemas.openxmlformats.org/drawingml/2006/main">
               <a:ext uri="{FF2B5EF4-FFF2-40B4-BE49-F238E27FC236}">
-                <a16:creationId xmlns:a16="http://schemas.microsoft.com/office/drawing/2014/main" id="{D9ACDB5B-E652-4656-AA2D-EA6B4E5BA70D}"/>
+                <a16:creationId xmlns:a16="http://schemas.microsoft.com/office/drawing/2014/main" id="{541C8EA3-CBA3-4C6E-9640-B45BD66906A2}"/>
               </a:ext>
             </a:extLst>
           </p:cNvPr>
@@ -10120,7 +10120,7 @@
           <p:cNvPr id="26" name="">
             <a:extLst xmlns:a="http://schemas.openxmlformats.org/drawingml/2006/main">
               <a:ext uri="{FF2B5EF4-FFF2-40B4-BE49-F238E27FC236}">
-                <a16:creationId xmlns:a16="http://schemas.microsoft.com/office/drawing/2014/main" id="{D523A316-9317-4154-B3A8-FFF1DEF40098}"/>
+                <a16:creationId xmlns:a16="http://schemas.microsoft.com/office/drawing/2014/main" id="{52A850F3-30EC-4D83-827F-7C252273AF34}"/>
               </a:ext>
             </a:extLst>
           </p:cNvPr>
@@ -10155,7 +10155,7 @@
           <p:cNvPr id="27" name="">
             <a:extLst xmlns:a="http://schemas.openxmlformats.org/drawingml/2006/main">
               <a:ext uri="{FF2B5EF4-FFF2-40B4-BE49-F238E27FC236}">
-                <a16:creationId xmlns:a16="http://schemas.microsoft.com/office/drawing/2014/main" id="{BCE83004-3164-45CE-AE8B-CE7B445413FE}"/>
+                <a16:creationId xmlns:a16="http://schemas.microsoft.com/office/drawing/2014/main" id="{536C5293-4679-4DC9-83F9-5BEF60C2560C}"/>
               </a:ext>
             </a:extLst>
           </p:cNvPr>
@@ -10186,7 +10186,7 @@
           <p:cNvPr id="28" name="">
             <a:extLst xmlns:a="http://schemas.openxmlformats.org/drawingml/2006/main">
               <a:ext uri="{FF2B5EF4-FFF2-40B4-BE49-F238E27FC236}">
-                <a16:creationId xmlns:a16="http://schemas.microsoft.com/office/drawing/2014/main" id="{69EC02BC-0F6B-4D30-9EC5-C9604B8AC529}"/>
+                <a16:creationId xmlns:a16="http://schemas.microsoft.com/office/drawing/2014/main" id="{A13BEDAE-F5C8-4AFD-9C30-DDBD5C684847}"/>
               </a:ext>
             </a:extLst>
           </p:cNvPr>
@@ -10248,7 +10248,7 @@
           <p:cNvPr id="29" name="">
             <a:extLst xmlns:a="http://schemas.openxmlformats.org/drawingml/2006/main">
               <a:ext uri="{FF2B5EF4-FFF2-40B4-BE49-F238E27FC236}">
-                <a16:creationId xmlns:a16="http://schemas.microsoft.com/office/drawing/2014/main" id="{B0E03F8A-EB3C-4F5B-A859-AB78E4CD8A2E}"/>
+                <a16:creationId xmlns:a16="http://schemas.microsoft.com/office/drawing/2014/main" id="{186A7591-D33D-48AB-8BD4-6C40AB521429}"/>
               </a:ext>
             </a:extLst>
           </p:cNvPr>
@@ -10310,7 +10310,7 @@
           <p:cNvPr id="30" name="">
             <a:extLst xmlns:a="http://schemas.openxmlformats.org/drawingml/2006/main">
               <a:ext uri="{FF2B5EF4-FFF2-40B4-BE49-F238E27FC236}">
-                <a16:creationId xmlns:a16="http://schemas.microsoft.com/office/drawing/2014/main" id="{C83C92D5-ACA9-40AB-A323-C9CCBAD0CF76}"/>
+                <a16:creationId xmlns:a16="http://schemas.microsoft.com/office/drawing/2014/main" id="{CF4D2B14-4198-4ABD-BA6D-2A7B5B7601CC}"/>
               </a:ext>
             </a:extLst>
           </p:cNvPr>
@@ -10372,7 +10372,7 @@
           <p:cNvPr id="31" name="">
             <a:extLst xmlns:a="http://schemas.openxmlformats.org/drawingml/2006/main">
               <a:ext uri="{FF2B5EF4-FFF2-40B4-BE49-F238E27FC236}">
-                <a16:creationId xmlns:a16="http://schemas.microsoft.com/office/drawing/2014/main" id="{2F00FFAB-6FB6-447F-84F2-9C5A33DA0982}"/>
+                <a16:creationId xmlns:a16="http://schemas.microsoft.com/office/drawing/2014/main" id="{D8C02CCE-5DDB-4055-8AD1-9268DC86D0AE}"/>
               </a:ext>
             </a:extLst>
           </p:cNvPr>
@@ -10434,7 +10434,7 @@
           <p:cNvPr id="32" name="">
             <a:extLst xmlns:a="http://schemas.openxmlformats.org/drawingml/2006/main">
               <a:ext uri="{FF2B5EF4-FFF2-40B4-BE49-F238E27FC236}">
-                <a16:creationId xmlns:a16="http://schemas.microsoft.com/office/drawing/2014/main" id="{AF83E621-CD3C-47AD-8574-DC642163A008}"/>
+                <a16:creationId xmlns:a16="http://schemas.microsoft.com/office/drawing/2014/main" id="{5C944F61-2CD6-451D-8ACE-8E1C7FD27DAE}"/>
               </a:ext>
             </a:extLst>
           </p:cNvPr>
@@ -10494,7 +10494,7 @@
     </p:spTree>
     <p:extLst>
       <p:ext uri="{BB962C8B-B14F-4D97-AF65-F5344CB8AC3E}">
-        <p14:creationId xmlns:p14="http://schemas.microsoft.com/office/powerpoint/2010/main" val="564946211"/>
+        <p14:creationId xmlns:p14="http://schemas.microsoft.com/office/powerpoint/2010/main" val="274217581"/>
       </p:ext>
     </p:extLst>
   </p:cSld>
@@ -10522,7 +10522,7 @@
           <p:nvPr/>
         </p:nvPicPr>
         <p:blipFill>
-          <a:blip xmlns:r="http://schemas.openxmlformats.org/officeDocument/2006/relationships" xmlns:a="http://schemas.openxmlformats.org/drawingml/2006/main" r:embed="R76c3eb7b9dac4516"/>
+          <a:blip xmlns:r="http://schemas.openxmlformats.org/officeDocument/2006/relationships" xmlns:a="http://schemas.openxmlformats.org/drawingml/2006/main" r:embed="R73e6babdf501409e"/>
           <a:srcRect xmlns:a="http://schemas.openxmlformats.org/drawingml/2006/main" l="0" t="0" r="0" b="0"/>
           <a:stretch xmlns:a="http://schemas.openxmlformats.org/drawingml/2006/main">
             <a:fillRect l="0" t="0" r="0" b="0"/>
@@ -10543,7 +10543,7 @@
           <p:cNvPr id="2" name="">
             <a:extLst xmlns:a="http://schemas.openxmlformats.org/drawingml/2006/main">
               <a:ext uri="{FF2B5EF4-FFF2-40B4-BE49-F238E27FC236}">
-                <a16:creationId xmlns:a16="http://schemas.microsoft.com/office/drawing/2014/main" id="{79826FA0-FC8E-41E1-BA38-128553FEB2D6}"/>
+                <a16:creationId xmlns:a16="http://schemas.microsoft.com/office/drawing/2014/main" id="{949B7C1A-1E6F-46C1-AF68-B51CF22805E5}"/>
               </a:ext>
             </a:extLst>
           </p:cNvPr>
@@ -10605,7 +10605,7 @@
           <p:cNvPr id="3" name="">
             <a:extLst xmlns:a="http://schemas.openxmlformats.org/drawingml/2006/main">
               <a:ext uri="{FF2B5EF4-FFF2-40B4-BE49-F238E27FC236}">
-                <a16:creationId xmlns:a16="http://schemas.microsoft.com/office/drawing/2014/main" id="{BEB35D2D-90EB-4FA3-9970-92E90F8D3A1A}"/>
+                <a16:creationId xmlns:a16="http://schemas.microsoft.com/office/drawing/2014/main" id="{1B45831B-D0CC-42F8-9067-0A3331DC5471}"/>
               </a:ext>
             </a:extLst>
           </p:cNvPr>
@@ -10667,7 +10667,7 @@
           <p:cNvPr id="4" name="">
             <a:extLst xmlns:a="http://schemas.openxmlformats.org/drawingml/2006/main">
               <a:ext uri="{FF2B5EF4-FFF2-40B4-BE49-F238E27FC236}">
-                <a16:creationId xmlns:a16="http://schemas.microsoft.com/office/drawing/2014/main" id="{CE4BF4D4-4722-4D3E-876A-1E9520CF0E23}"/>
+                <a16:creationId xmlns:a16="http://schemas.microsoft.com/office/drawing/2014/main" id="{61E1A7D2-2CD7-441D-BC26-A1FC305518FD}"/>
               </a:ext>
             </a:extLst>
           </p:cNvPr>
@@ -10729,7 +10729,7 @@
           <p:cNvPr id="5" name="">
             <a:extLst xmlns:a="http://schemas.openxmlformats.org/drawingml/2006/main">
               <a:ext uri="{FF2B5EF4-FFF2-40B4-BE49-F238E27FC236}">
-                <a16:creationId xmlns:a16="http://schemas.microsoft.com/office/drawing/2014/main" id="{D6D8D6BA-A176-46B7-B0D0-6CF83253B61B}"/>
+                <a16:creationId xmlns:a16="http://schemas.microsoft.com/office/drawing/2014/main" id="{4BF2B817-EE6F-400C-BFA2-5008F07B685D}"/>
               </a:ext>
             </a:extLst>
           </p:cNvPr>
@@ -10760,7 +10760,7 @@
           <p:cNvPr id="6" name="">
             <a:extLst xmlns:a="http://schemas.openxmlformats.org/drawingml/2006/main">
               <a:ext uri="{FF2B5EF4-FFF2-40B4-BE49-F238E27FC236}">
-                <a16:creationId xmlns:a16="http://schemas.microsoft.com/office/drawing/2014/main" id="{57420BCF-8026-4341-AED3-5EDBA9BA057C}"/>
+                <a16:creationId xmlns:a16="http://schemas.microsoft.com/office/drawing/2014/main" id="{20733195-F81D-4119-BB20-3CA2F085A38E}"/>
               </a:ext>
             </a:extLst>
           </p:cNvPr>
@@ -10822,7 +10822,7 @@
           <p:cNvPr id="7" name="">
             <a:extLst xmlns:a="http://schemas.openxmlformats.org/drawingml/2006/main">
               <a:ext uri="{FF2B5EF4-FFF2-40B4-BE49-F238E27FC236}">
-                <a16:creationId xmlns:a16="http://schemas.microsoft.com/office/drawing/2014/main" id="{EEB192E9-E61D-4F64-90FE-B2EEF7539B06}"/>
+                <a16:creationId xmlns:a16="http://schemas.microsoft.com/office/drawing/2014/main" id="{748AA46E-D9B5-4496-BB60-2569574BA704}"/>
               </a:ext>
             </a:extLst>
           </p:cNvPr>
@@ -10855,7 +10855,7 @@
           <p:cNvPr id="8" name="">
             <a:extLst xmlns:a="http://schemas.openxmlformats.org/drawingml/2006/main">
               <a:ext uri="{FF2B5EF4-FFF2-40B4-BE49-F238E27FC236}">
-                <a16:creationId xmlns:a16="http://schemas.microsoft.com/office/drawing/2014/main" id="{11950EFA-6CC9-4CF0-8356-C4D394EB4D20}"/>
+                <a16:creationId xmlns:a16="http://schemas.microsoft.com/office/drawing/2014/main" id="{9861E43B-4EB3-4975-96AF-33BFF3481CBF}"/>
               </a:ext>
             </a:extLst>
           </p:cNvPr>
@@ -10890,7 +10890,7 @@
           <p:cNvPr id="9" name="">
             <a:extLst xmlns:a="http://schemas.openxmlformats.org/drawingml/2006/main">
               <a:ext uri="{FF2B5EF4-FFF2-40B4-BE49-F238E27FC236}">
-                <a16:creationId xmlns:a16="http://schemas.microsoft.com/office/drawing/2014/main" id="{3EA38D12-1A4A-465D-9166-7C6CDFE8C277}"/>
+                <a16:creationId xmlns:a16="http://schemas.microsoft.com/office/drawing/2014/main" id="{19C23574-0E31-48DD-97D7-A4B97F588353}"/>
               </a:ext>
             </a:extLst>
           </p:cNvPr>
@@ -10921,7 +10921,7 @@
           <p:cNvPr id="10" name="">
             <a:extLst xmlns:a="http://schemas.openxmlformats.org/drawingml/2006/main">
               <a:ext uri="{FF2B5EF4-FFF2-40B4-BE49-F238E27FC236}">
-                <a16:creationId xmlns:a16="http://schemas.microsoft.com/office/drawing/2014/main" id="{2FA6AE91-03A1-4061-AF23-97283F3441C5}"/>
+                <a16:creationId xmlns:a16="http://schemas.microsoft.com/office/drawing/2014/main" id="{3463817F-DBF6-4C31-81CC-0A3CC6B7E415}"/>
               </a:ext>
             </a:extLst>
           </p:cNvPr>
@@ -10983,7 +10983,7 @@
           <p:cNvPr id="11" name="">
             <a:extLst xmlns:a="http://schemas.openxmlformats.org/drawingml/2006/main">
               <a:ext uri="{FF2B5EF4-FFF2-40B4-BE49-F238E27FC236}">
-                <a16:creationId xmlns:a16="http://schemas.microsoft.com/office/drawing/2014/main" id="{7CA21A1A-65A4-4677-BCBD-5CC23A70BFAA}"/>
+                <a16:creationId xmlns:a16="http://schemas.microsoft.com/office/drawing/2014/main" id="{F58565AF-134A-4880-AFF7-5D616EF0D677}"/>
               </a:ext>
             </a:extLst>
           </p:cNvPr>
@@ -11045,7 +11045,7 @@
           <p:cNvPr id="12" name="">
             <a:extLst xmlns:a="http://schemas.openxmlformats.org/drawingml/2006/main">
               <a:ext uri="{FF2B5EF4-FFF2-40B4-BE49-F238E27FC236}">
-                <a16:creationId xmlns:a16="http://schemas.microsoft.com/office/drawing/2014/main" id="{CECD730B-C870-46AA-AB82-24311ABDE1BB}"/>
+                <a16:creationId xmlns:a16="http://schemas.microsoft.com/office/drawing/2014/main" id="{8672914D-0D36-4012-A3CC-B7302FC5ECE2}"/>
               </a:ext>
             </a:extLst>
           </p:cNvPr>
@@ -11107,7 +11107,7 @@
           <p:cNvPr id="13" name="">
             <a:extLst xmlns:a="http://schemas.openxmlformats.org/drawingml/2006/main">
               <a:ext uri="{FF2B5EF4-FFF2-40B4-BE49-F238E27FC236}">
-                <a16:creationId xmlns:a16="http://schemas.microsoft.com/office/drawing/2014/main" id="{7DBD2FD8-4A89-44C3-AE1F-5EB5F95D97CB}"/>
+                <a16:creationId xmlns:a16="http://schemas.microsoft.com/office/drawing/2014/main" id="{00B76E79-0463-4DCB-A02A-8145007C0098}"/>
               </a:ext>
             </a:extLst>
           </p:cNvPr>
@@ -11167,7 +11167,7 @@
     </p:spTree>
     <p:extLst>
       <p:ext uri="{BB962C8B-B14F-4D97-AF65-F5344CB8AC3E}">
-        <p14:creationId xmlns:p14="http://schemas.microsoft.com/office/powerpoint/2010/main" val="481078100"/>
+        <p14:creationId xmlns:p14="http://schemas.microsoft.com/office/powerpoint/2010/main" val="419769597"/>
       </p:ext>
     </p:extLst>
   </p:cSld>
@@ -11195,7 +11195,7 @@
           <p:nvPr/>
         </p:nvPicPr>
         <p:blipFill>
-          <a:blip xmlns:r="http://schemas.openxmlformats.org/officeDocument/2006/relationships" xmlns:a="http://schemas.openxmlformats.org/drawingml/2006/main" r:embed="R8c6d182f59e9441a"/>
+          <a:blip xmlns:r="http://schemas.openxmlformats.org/officeDocument/2006/relationships" xmlns:a="http://schemas.openxmlformats.org/drawingml/2006/main" r:embed="R9d0bdb2b7c9342e9"/>
           <a:srcRect xmlns:a="http://schemas.openxmlformats.org/drawingml/2006/main" l="0" t="0" r="0" b="0"/>
           <a:stretch xmlns:a="http://schemas.openxmlformats.org/drawingml/2006/main">
             <a:fillRect l="0" t="0" r="0" b="0"/>
@@ -11216,7 +11216,7 @@
           <p:cNvPr id="2" name="">
             <a:extLst xmlns:a="http://schemas.openxmlformats.org/drawingml/2006/main">
               <a:ext uri="{FF2B5EF4-FFF2-40B4-BE49-F238E27FC236}">
-                <a16:creationId xmlns:a16="http://schemas.microsoft.com/office/drawing/2014/main" id="{513C2B30-AA9D-49FF-AC69-7A101826EA09}"/>
+                <a16:creationId xmlns:a16="http://schemas.microsoft.com/office/drawing/2014/main" id="{C45BF423-43ED-4180-BC96-E41DFA2ED888}"/>
               </a:ext>
             </a:extLst>
           </p:cNvPr>
@@ -11278,7 +11278,7 @@
           <p:cNvPr id="3" name="">
             <a:extLst xmlns:a="http://schemas.openxmlformats.org/drawingml/2006/main">
               <a:ext uri="{FF2B5EF4-FFF2-40B4-BE49-F238E27FC236}">
-                <a16:creationId xmlns:a16="http://schemas.microsoft.com/office/drawing/2014/main" id="{87337782-BF4E-4D70-A5F3-F1F8EB9DF13F}"/>
+                <a16:creationId xmlns:a16="http://schemas.microsoft.com/office/drawing/2014/main" id="{7CC0DFC3-3BB0-4206-A503-69C4A24A2730}"/>
               </a:ext>
             </a:extLst>
           </p:cNvPr>
@@ -11340,7 +11340,7 @@
           <p:cNvPr id="4" name="">
             <a:extLst xmlns:a="http://schemas.openxmlformats.org/drawingml/2006/main">
               <a:ext uri="{FF2B5EF4-FFF2-40B4-BE49-F238E27FC236}">
-                <a16:creationId xmlns:a16="http://schemas.microsoft.com/office/drawing/2014/main" id="{E1411BA6-7530-4E5B-AC5C-A3138869368E}"/>
+                <a16:creationId xmlns:a16="http://schemas.microsoft.com/office/drawing/2014/main" id="{E28E539A-6F72-4931-BAE8-E0CF56AA796B}"/>
               </a:ext>
             </a:extLst>
           </p:cNvPr>
@@ -11402,7 +11402,7 @@
           <p:cNvPr id="5" name="">
             <a:extLst xmlns:a="http://schemas.openxmlformats.org/drawingml/2006/main">
               <a:ext uri="{FF2B5EF4-FFF2-40B4-BE49-F238E27FC236}">
-                <a16:creationId xmlns:a16="http://schemas.microsoft.com/office/drawing/2014/main" id="{2AEB16BA-6DB6-4C55-8CBA-6F1E16F78141}"/>
+                <a16:creationId xmlns:a16="http://schemas.microsoft.com/office/drawing/2014/main" id="{64610EB0-3081-4BFD-952C-AA394E2C2995}"/>
               </a:ext>
             </a:extLst>
           </p:cNvPr>
@@ -11433,7 +11433,7 @@
           <p:cNvPr id="6" name="">
             <a:extLst xmlns:a="http://schemas.openxmlformats.org/drawingml/2006/main">
               <a:ext uri="{FF2B5EF4-FFF2-40B4-BE49-F238E27FC236}">
-                <a16:creationId xmlns:a16="http://schemas.microsoft.com/office/drawing/2014/main" id="{43436EE7-9B85-4F7E-9021-388AEACBEA06}"/>
+                <a16:creationId xmlns:a16="http://schemas.microsoft.com/office/drawing/2014/main" id="{3F97EB39-0837-4907-9E0B-6DFA6A735690}"/>
               </a:ext>
             </a:extLst>
           </p:cNvPr>
@@ -11495,7 +11495,7 @@
           <p:cNvPr id="7" name="">
             <a:extLst xmlns:a="http://schemas.openxmlformats.org/drawingml/2006/main">
               <a:ext uri="{FF2B5EF4-FFF2-40B4-BE49-F238E27FC236}">
-                <a16:creationId xmlns:a16="http://schemas.microsoft.com/office/drawing/2014/main" id="{6166452F-CFA4-4E32-B1EA-061CD73A75C3}"/>
+                <a16:creationId xmlns:a16="http://schemas.microsoft.com/office/drawing/2014/main" id="{7DE10D75-774A-4B1E-83D7-B7ABDB72D6B1}"/>
               </a:ext>
             </a:extLst>
           </p:cNvPr>
@@ -11528,7 +11528,7 @@
           <p:cNvPr id="8" name="">
             <a:extLst xmlns:a="http://schemas.openxmlformats.org/drawingml/2006/main">
               <a:ext uri="{FF2B5EF4-FFF2-40B4-BE49-F238E27FC236}">
-                <a16:creationId xmlns:a16="http://schemas.microsoft.com/office/drawing/2014/main" id="{1A9A8581-88BD-47EC-88FD-3D72001A1AD6}"/>
+                <a16:creationId xmlns:a16="http://schemas.microsoft.com/office/drawing/2014/main" id="{00C0A3B3-85F9-48C3-B70A-53A34BD088A9}"/>
               </a:ext>
             </a:extLst>
           </p:cNvPr>
@@ -11563,7 +11563,7 @@
           <p:cNvPr id="9" name="">
             <a:extLst xmlns:a="http://schemas.openxmlformats.org/drawingml/2006/main">
               <a:ext uri="{FF2B5EF4-FFF2-40B4-BE49-F238E27FC236}">
-                <a16:creationId xmlns:a16="http://schemas.microsoft.com/office/drawing/2014/main" id="{160E0561-1862-470E-BCDA-DA408EC86492}"/>
+                <a16:creationId xmlns:a16="http://schemas.microsoft.com/office/drawing/2014/main" id="{D0C0B4BE-362C-4701-8CBE-6ACAA1AB991E}"/>
               </a:ext>
             </a:extLst>
           </p:cNvPr>
@@ -11594,7 +11594,7 @@
           <p:cNvPr id="10" name="">
             <a:extLst xmlns:a="http://schemas.openxmlformats.org/drawingml/2006/main">
               <a:ext uri="{FF2B5EF4-FFF2-40B4-BE49-F238E27FC236}">
-                <a16:creationId xmlns:a16="http://schemas.microsoft.com/office/drawing/2014/main" id="{B94C2C9B-10ED-4889-831F-E8CBCADCCB85}"/>
+                <a16:creationId xmlns:a16="http://schemas.microsoft.com/office/drawing/2014/main" id="{4F734B7E-406D-4440-8F77-6B4B80774E9E}"/>
               </a:ext>
             </a:extLst>
           </p:cNvPr>
@@ -11656,7 +11656,7 @@
           <p:cNvPr id="11" name="">
             <a:extLst xmlns:a="http://schemas.openxmlformats.org/drawingml/2006/main">
               <a:ext uri="{FF2B5EF4-FFF2-40B4-BE49-F238E27FC236}">
-                <a16:creationId xmlns:a16="http://schemas.microsoft.com/office/drawing/2014/main" id="{79BDCD36-BFDF-4D9C-A955-B5A06E89AC86}"/>
+                <a16:creationId xmlns:a16="http://schemas.microsoft.com/office/drawing/2014/main" id="{0C73EF9E-90C3-4064-8070-BF1F16E2B518}"/>
               </a:ext>
             </a:extLst>
           </p:cNvPr>
@@ -11718,7 +11718,7 @@
           <p:cNvPr id="12" name="">
             <a:extLst xmlns:a="http://schemas.openxmlformats.org/drawingml/2006/main">
               <a:ext uri="{FF2B5EF4-FFF2-40B4-BE49-F238E27FC236}">
-                <a16:creationId xmlns:a16="http://schemas.microsoft.com/office/drawing/2014/main" id="{BE23C3C5-0C1A-468A-B1FD-6FA27D3A3BB9}"/>
+                <a16:creationId xmlns:a16="http://schemas.microsoft.com/office/drawing/2014/main" id="{F62AA4EC-B268-4F1B-A061-7DAB9E74FEF0}"/>
               </a:ext>
             </a:extLst>
           </p:cNvPr>
@@ -11780,7 +11780,7 @@
           <p:cNvPr id="13" name="">
             <a:extLst xmlns:a="http://schemas.openxmlformats.org/drawingml/2006/main">
               <a:ext uri="{FF2B5EF4-FFF2-40B4-BE49-F238E27FC236}">
-                <a16:creationId xmlns:a16="http://schemas.microsoft.com/office/drawing/2014/main" id="{E7891603-23BE-4B46-8003-B0EC0C2DE117}"/>
+                <a16:creationId xmlns:a16="http://schemas.microsoft.com/office/drawing/2014/main" id="{AE12EA45-CC8E-48D6-8B9F-5DA33EB5ECCC}"/>
               </a:ext>
             </a:extLst>
           </p:cNvPr>
@@ -11813,7 +11813,7 @@
           <p:cNvPr id="14" name="">
             <a:extLst xmlns:a="http://schemas.openxmlformats.org/drawingml/2006/main">
               <a:ext uri="{FF2B5EF4-FFF2-40B4-BE49-F238E27FC236}">
-                <a16:creationId xmlns:a16="http://schemas.microsoft.com/office/drawing/2014/main" id="{77FDD8CF-F294-4440-ADED-C0FA2EDEB967}"/>
+                <a16:creationId xmlns:a16="http://schemas.microsoft.com/office/drawing/2014/main" id="{F7056C9F-C747-43BF-B435-184E62F658FD}"/>
               </a:ext>
             </a:extLst>
           </p:cNvPr>
@@ -11848,7 +11848,7 @@
           <p:cNvPr id="15" name="">
             <a:extLst xmlns:a="http://schemas.openxmlformats.org/drawingml/2006/main">
               <a:ext uri="{FF2B5EF4-FFF2-40B4-BE49-F238E27FC236}">
-                <a16:creationId xmlns:a16="http://schemas.microsoft.com/office/drawing/2014/main" id="{B56EA20D-1DC0-4BC7-B35E-4970CB130683}"/>
+                <a16:creationId xmlns:a16="http://schemas.microsoft.com/office/drawing/2014/main" id="{F97616F4-067D-4598-BC3A-D08868ADF7AE}"/>
               </a:ext>
             </a:extLst>
           </p:cNvPr>
@@ -11879,7 +11879,7 @@
           <p:cNvPr id="16" name="">
             <a:extLst xmlns:a="http://schemas.openxmlformats.org/drawingml/2006/main">
               <a:ext uri="{FF2B5EF4-FFF2-40B4-BE49-F238E27FC236}">
-                <a16:creationId xmlns:a16="http://schemas.microsoft.com/office/drawing/2014/main" id="{C24ACD2D-2962-4ECB-A808-50E3DC931B3C}"/>
+                <a16:creationId xmlns:a16="http://schemas.microsoft.com/office/drawing/2014/main" id="{8AD60266-560F-41B9-B0AA-5583D3394AF8}"/>
               </a:ext>
             </a:extLst>
           </p:cNvPr>
@@ -11941,7 +11941,7 @@
           <p:cNvPr id="17" name="">
             <a:extLst xmlns:a="http://schemas.openxmlformats.org/drawingml/2006/main">
               <a:ext uri="{FF2B5EF4-FFF2-40B4-BE49-F238E27FC236}">
-                <a16:creationId xmlns:a16="http://schemas.microsoft.com/office/drawing/2014/main" id="{3882EC55-B3FF-4872-B0DF-2BC4EA601BA3}"/>
+                <a16:creationId xmlns:a16="http://schemas.microsoft.com/office/drawing/2014/main" id="{2329F867-3252-4EB6-9C0A-5E0B340ED537}"/>
               </a:ext>
             </a:extLst>
           </p:cNvPr>
@@ -12003,7 +12003,7 @@
           <p:cNvPr id="18" name="">
             <a:extLst xmlns:a="http://schemas.openxmlformats.org/drawingml/2006/main">
               <a:ext uri="{FF2B5EF4-FFF2-40B4-BE49-F238E27FC236}">
-                <a16:creationId xmlns:a16="http://schemas.microsoft.com/office/drawing/2014/main" id="{E19E2F75-F229-42A2-A717-8C171815F7EC}"/>
+                <a16:creationId xmlns:a16="http://schemas.microsoft.com/office/drawing/2014/main" id="{D768E359-42DF-4640-948A-00B34EE01C19}"/>
               </a:ext>
             </a:extLst>
           </p:cNvPr>
@@ -12065,7 +12065,7 @@
           <p:cNvPr id="19" name="">
             <a:extLst xmlns:a="http://schemas.openxmlformats.org/drawingml/2006/main">
               <a:ext uri="{FF2B5EF4-FFF2-40B4-BE49-F238E27FC236}">
-                <a16:creationId xmlns:a16="http://schemas.microsoft.com/office/drawing/2014/main" id="{8972E440-8C69-40ED-BFCD-C750D3104552}"/>
+                <a16:creationId xmlns:a16="http://schemas.microsoft.com/office/drawing/2014/main" id="{AC06299E-B29B-4A3F-84A7-5150778B8E19}"/>
               </a:ext>
             </a:extLst>
           </p:cNvPr>
@@ -12098,7 +12098,7 @@
           <p:cNvPr id="20" name="">
             <a:extLst xmlns:a="http://schemas.openxmlformats.org/drawingml/2006/main">
               <a:ext uri="{FF2B5EF4-FFF2-40B4-BE49-F238E27FC236}">
-                <a16:creationId xmlns:a16="http://schemas.microsoft.com/office/drawing/2014/main" id="{2CD946B2-A332-4766-A00F-1E9AF5C3AE95}"/>
+                <a16:creationId xmlns:a16="http://schemas.microsoft.com/office/drawing/2014/main" id="{0606EFE5-B887-4ABA-995C-B88E1EC8BADB}"/>
               </a:ext>
             </a:extLst>
           </p:cNvPr>
@@ -12133,7 +12133,7 @@
           <p:cNvPr id="21" name="">
             <a:extLst xmlns:a="http://schemas.openxmlformats.org/drawingml/2006/main">
               <a:ext uri="{FF2B5EF4-FFF2-40B4-BE49-F238E27FC236}">
-                <a16:creationId xmlns:a16="http://schemas.microsoft.com/office/drawing/2014/main" id="{35890C08-599E-446E-9AEA-E8B23DD87AA3}"/>
+                <a16:creationId xmlns:a16="http://schemas.microsoft.com/office/drawing/2014/main" id="{2E7BA214-4F21-4C45-AA76-9832459CCAE6}"/>
               </a:ext>
             </a:extLst>
           </p:cNvPr>
@@ -12164,7 +12164,7 @@
           <p:cNvPr id="22" name="">
             <a:extLst xmlns:a="http://schemas.openxmlformats.org/drawingml/2006/main">
               <a:ext uri="{FF2B5EF4-FFF2-40B4-BE49-F238E27FC236}">
-                <a16:creationId xmlns:a16="http://schemas.microsoft.com/office/drawing/2014/main" id="{9C81A956-08D9-4537-AE3F-19EF55EEC1C2}"/>
+                <a16:creationId xmlns:a16="http://schemas.microsoft.com/office/drawing/2014/main" id="{98A921DC-F327-4F59-B815-65571C4C298E}"/>
               </a:ext>
             </a:extLst>
           </p:cNvPr>
@@ -12226,7 +12226,7 @@
           <p:cNvPr id="23" name="">
             <a:extLst xmlns:a="http://schemas.openxmlformats.org/drawingml/2006/main">
               <a:ext uri="{FF2B5EF4-FFF2-40B4-BE49-F238E27FC236}">
-                <a16:creationId xmlns:a16="http://schemas.microsoft.com/office/drawing/2014/main" id="{F12EBAEA-E0A6-4D07-9B36-508613DD83B0}"/>
+                <a16:creationId xmlns:a16="http://schemas.microsoft.com/office/drawing/2014/main" id="{B21BF4A7-7799-4A51-B2CB-CE23E08744E0}"/>
               </a:ext>
             </a:extLst>
           </p:cNvPr>
@@ -12288,7 +12288,7 @@
           <p:cNvPr id="24" name="">
             <a:extLst xmlns:a="http://schemas.openxmlformats.org/drawingml/2006/main">
               <a:ext uri="{FF2B5EF4-FFF2-40B4-BE49-F238E27FC236}">
-                <a16:creationId xmlns:a16="http://schemas.microsoft.com/office/drawing/2014/main" id="{1CABEC62-7228-4106-94BB-F8F8E294C5B1}"/>
+                <a16:creationId xmlns:a16="http://schemas.microsoft.com/office/drawing/2014/main" id="{0F833885-607F-49D6-8396-98A3355CD8F1}"/>
               </a:ext>
             </a:extLst>
           </p:cNvPr>
@@ -12350,7 +12350,7 @@
           <p:cNvPr id="25" name="">
             <a:extLst xmlns:a="http://schemas.openxmlformats.org/drawingml/2006/main">
               <a:ext uri="{FF2B5EF4-FFF2-40B4-BE49-F238E27FC236}">
-                <a16:creationId xmlns:a16="http://schemas.microsoft.com/office/drawing/2014/main" id="{633DAAB9-7771-4D5D-AF86-A0E1A0F31238}"/>
+                <a16:creationId xmlns:a16="http://schemas.microsoft.com/office/drawing/2014/main" id="{2B63B695-660D-4F9C-902B-7F1FA3E2FB03}"/>
               </a:ext>
             </a:extLst>
           </p:cNvPr>
@@ -12383,7 +12383,7 @@
           <p:cNvPr id="26" name="">
             <a:extLst xmlns:a="http://schemas.openxmlformats.org/drawingml/2006/main">
               <a:ext uri="{FF2B5EF4-FFF2-40B4-BE49-F238E27FC236}">
-                <a16:creationId xmlns:a16="http://schemas.microsoft.com/office/drawing/2014/main" id="{C177BC06-28EB-4B88-B0EE-B65B9C61D616}"/>
+                <a16:creationId xmlns:a16="http://schemas.microsoft.com/office/drawing/2014/main" id="{E0B97FD7-AE88-403B-A5AB-3DB6CEE55856}"/>
               </a:ext>
             </a:extLst>
           </p:cNvPr>
@@ -12418,7 +12418,7 @@
           <p:cNvPr id="27" name="">
             <a:extLst xmlns:a="http://schemas.openxmlformats.org/drawingml/2006/main">
               <a:ext uri="{FF2B5EF4-FFF2-40B4-BE49-F238E27FC236}">
-                <a16:creationId xmlns:a16="http://schemas.microsoft.com/office/drawing/2014/main" id="{585E2F6D-FBFA-454D-A6DC-320EB39983DD}"/>
+                <a16:creationId xmlns:a16="http://schemas.microsoft.com/office/drawing/2014/main" id="{15500703-B2CC-49E4-9404-C8422B7495A7}"/>
               </a:ext>
             </a:extLst>
           </p:cNvPr>
@@ -12449,7 +12449,7 @@
           <p:cNvPr id="28" name="">
             <a:extLst xmlns:a="http://schemas.openxmlformats.org/drawingml/2006/main">
               <a:ext uri="{FF2B5EF4-FFF2-40B4-BE49-F238E27FC236}">
-                <a16:creationId xmlns:a16="http://schemas.microsoft.com/office/drawing/2014/main" id="{319B1C40-20BB-408B-8330-23FCE9B61CCF}"/>
+                <a16:creationId xmlns:a16="http://schemas.microsoft.com/office/drawing/2014/main" id="{7EAB61D3-77A0-4E96-B7D1-17B6A59416F2}"/>
               </a:ext>
             </a:extLst>
           </p:cNvPr>
@@ -12511,7 +12511,7 @@
           <p:cNvPr id="29" name="">
             <a:extLst xmlns:a="http://schemas.openxmlformats.org/drawingml/2006/main">
               <a:ext uri="{FF2B5EF4-FFF2-40B4-BE49-F238E27FC236}">
-                <a16:creationId xmlns:a16="http://schemas.microsoft.com/office/drawing/2014/main" id="{8902FD6C-8736-4AF7-B718-4FA1FD8060AF}"/>
+                <a16:creationId xmlns:a16="http://schemas.microsoft.com/office/drawing/2014/main" id="{608DE804-6D9B-4EE9-9ED1-62D998CB872C}"/>
               </a:ext>
             </a:extLst>
           </p:cNvPr>
@@ -12573,7 +12573,7 @@
           <p:cNvPr id="30" name="">
             <a:extLst xmlns:a="http://schemas.openxmlformats.org/drawingml/2006/main">
               <a:ext uri="{FF2B5EF4-FFF2-40B4-BE49-F238E27FC236}">
-                <a16:creationId xmlns:a16="http://schemas.microsoft.com/office/drawing/2014/main" id="{34270371-A18B-45CA-9F22-009574A54750}"/>
+                <a16:creationId xmlns:a16="http://schemas.microsoft.com/office/drawing/2014/main" id="{480CAF32-856E-4849-BB4B-EAD14436DF4B}"/>
               </a:ext>
             </a:extLst>
           </p:cNvPr>
@@ -12635,7 +12635,7 @@
           <p:cNvPr id="31" name="">
             <a:extLst xmlns:a="http://schemas.openxmlformats.org/drawingml/2006/main">
               <a:ext uri="{FF2B5EF4-FFF2-40B4-BE49-F238E27FC236}">
-                <a16:creationId xmlns:a16="http://schemas.microsoft.com/office/drawing/2014/main" id="{4E64469C-8354-4C26-823A-3B3D08D0588A}"/>
+                <a16:creationId xmlns:a16="http://schemas.microsoft.com/office/drawing/2014/main" id="{03729D6B-CBB6-4351-B129-E71B58F0621A}"/>
               </a:ext>
             </a:extLst>
           </p:cNvPr>
@@ -12668,7 +12668,7 @@
           <p:cNvPr id="32" name="">
             <a:extLst xmlns:a="http://schemas.openxmlformats.org/drawingml/2006/main">
               <a:ext uri="{FF2B5EF4-FFF2-40B4-BE49-F238E27FC236}">
-                <a16:creationId xmlns:a16="http://schemas.microsoft.com/office/drawing/2014/main" id="{52C073B3-2ADD-40B5-BA37-529A4086BA51}"/>
+                <a16:creationId xmlns:a16="http://schemas.microsoft.com/office/drawing/2014/main" id="{726C83CA-32D0-43C9-A183-D67AE84ADFCD}"/>
               </a:ext>
             </a:extLst>
           </p:cNvPr>
@@ -12703,7 +12703,7 @@
           <p:cNvPr id="33" name="">
             <a:extLst xmlns:a="http://schemas.openxmlformats.org/drawingml/2006/main">
               <a:ext uri="{FF2B5EF4-FFF2-40B4-BE49-F238E27FC236}">
-                <a16:creationId xmlns:a16="http://schemas.microsoft.com/office/drawing/2014/main" id="{FC693625-E5D9-4EEC-912E-5DC44BD71E90}"/>
+                <a16:creationId xmlns:a16="http://schemas.microsoft.com/office/drawing/2014/main" id="{3F1332E9-8B24-4468-A2C5-FFEE73B2E0ED}"/>
               </a:ext>
             </a:extLst>
           </p:cNvPr>
@@ -12734,7 +12734,7 @@
           <p:cNvPr id="34" name="">
             <a:extLst xmlns:a="http://schemas.openxmlformats.org/drawingml/2006/main">
               <a:ext uri="{FF2B5EF4-FFF2-40B4-BE49-F238E27FC236}">
-                <a16:creationId xmlns:a16="http://schemas.microsoft.com/office/drawing/2014/main" id="{3FE5D48B-58D0-4A2F-9887-3E341F0384FF}"/>
+                <a16:creationId xmlns:a16="http://schemas.microsoft.com/office/drawing/2014/main" id="{A1EA643F-BD5A-45D4-B8A8-106113815262}"/>
               </a:ext>
             </a:extLst>
           </p:cNvPr>
@@ -12796,7 +12796,7 @@
           <p:cNvPr id="35" name="">
             <a:extLst xmlns:a="http://schemas.openxmlformats.org/drawingml/2006/main">
               <a:ext uri="{FF2B5EF4-FFF2-40B4-BE49-F238E27FC236}">
-                <a16:creationId xmlns:a16="http://schemas.microsoft.com/office/drawing/2014/main" id="{A5C4B865-DA01-4BA0-A5B1-1F51D5C8C6D0}"/>
+                <a16:creationId xmlns:a16="http://schemas.microsoft.com/office/drawing/2014/main" id="{99F97B92-9E08-4702-B646-88E8DA4F3F43}"/>
               </a:ext>
             </a:extLst>
           </p:cNvPr>
@@ -12858,7 +12858,7 @@
           <p:cNvPr id="36" name="">
             <a:extLst xmlns:a="http://schemas.openxmlformats.org/drawingml/2006/main">
               <a:ext uri="{FF2B5EF4-FFF2-40B4-BE49-F238E27FC236}">
-                <a16:creationId xmlns:a16="http://schemas.microsoft.com/office/drawing/2014/main" id="{7097741F-DBBD-4146-84EC-D343AC1FD3AE}"/>
+                <a16:creationId xmlns:a16="http://schemas.microsoft.com/office/drawing/2014/main" id="{14CC2F5D-93BA-48AE-9CAB-9C6872CE774B}"/>
               </a:ext>
             </a:extLst>
           </p:cNvPr>
@@ -12920,7 +12920,7 @@
           <p:cNvPr id="37" name="">
             <a:extLst xmlns:a="http://schemas.openxmlformats.org/drawingml/2006/main">
               <a:ext uri="{FF2B5EF4-FFF2-40B4-BE49-F238E27FC236}">
-                <a16:creationId xmlns:a16="http://schemas.microsoft.com/office/drawing/2014/main" id="{6D829B34-8792-40CC-915D-E8B10FF68F91}"/>
+                <a16:creationId xmlns:a16="http://schemas.microsoft.com/office/drawing/2014/main" id="{9FD54A09-2C27-4E42-AF25-F5B66663CB94}"/>
               </a:ext>
             </a:extLst>
           </p:cNvPr>
@@ -12982,7 +12982,7 @@
           <p:cNvPr id="38" name="">
             <a:extLst xmlns:a="http://schemas.openxmlformats.org/drawingml/2006/main">
               <a:ext uri="{FF2B5EF4-FFF2-40B4-BE49-F238E27FC236}">
-                <a16:creationId xmlns:a16="http://schemas.microsoft.com/office/drawing/2014/main" id="{A6291918-DFC5-41CE-880A-548224807A36}"/>
+                <a16:creationId xmlns:a16="http://schemas.microsoft.com/office/drawing/2014/main" id="{576C4F63-D4F7-477A-852A-086F46DB408D}"/>
               </a:ext>
             </a:extLst>
           </p:cNvPr>
@@ -13042,7 +13042,7 @@
     </p:spTree>
     <p:extLst>
       <p:ext uri="{BB962C8B-B14F-4D97-AF65-F5344CB8AC3E}">
-        <p14:creationId xmlns:p14="http://schemas.microsoft.com/office/powerpoint/2010/main" val="860277958"/>
+        <p14:creationId xmlns:p14="http://schemas.microsoft.com/office/powerpoint/2010/main" val="365281209"/>
       </p:ext>
     </p:extLst>
   </p:cSld>
@@ -13070,7 +13070,7 @@
           <p:nvPr/>
         </p:nvPicPr>
         <p:blipFill>
-          <a:blip xmlns:r="http://schemas.openxmlformats.org/officeDocument/2006/relationships" xmlns:a="http://schemas.openxmlformats.org/drawingml/2006/main" r:embed="R0f6b3b64bd894973"/>
+          <a:blip xmlns:r="http://schemas.openxmlformats.org/officeDocument/2006/relationships" xmlns:a="http://schemas.openxmlformats.org/drawingml/2006/main" r:embed="R5f7c996332d14f8f"/>
           <a:srcRect xmlns:a="http://schemas.openxmlformats.org/drawingml/2006/main" l="0" t="0" r="0" b="0"/>
           <a:stretch xmlns:a="http://schemas.openxmlformats.org/drawingml/2006/main">
             <a:fillRect l="0" t="0" r="0" b="0"/>
@@ -13091,7 +13091,7 @@
           <p:cNvPr id="2" name="">
             <a:extLst xmlns:a="http://schemas.openxmlformats.org/drawingml/2006/main">
               <a:ext uri="{FF2B5EF4-FFF2-40B4-BE49-F238E27FC236}">
-                <a16:creationId xmlns:a16="http://schemas.microsoft.com/office/drawing/2014/main" id="{022995D4-92AB-4CD0-B61E-4560EB0DB4A0}"/>
+                <a16:creationId xmlns:a16="http://schemas.microsoft.com/office/drawing/2014/main" id="{4AD6DBE3-7AA4-4F23-AA02-56DBBD7E5420}"/>
               </a:ext>
             </a:extLst>
           </p:cNvPr>
@@ -13153,7 +13153,7 @@
           <p:cNvPr id="3" name="">
             <a:extLst xmlns:a="http://schemas.openxmlformats.org/drawingml/2006/main">
               <a:ext uri="{FF2B5EF4-FFF2-40B4-BE49-F238E27FC236}">
-                <a16:creationId xmlns:a16="http://schemas.microsoft.com/office/drawing/2014/main" id="{B0224F94-AFBF-4108-81E5-20C4FE3324E8}"/>
+                <a16:creationId xmlns:a16="http://schemas.microsoft.com/office/drawing/2014/main" id="{D32D60B7-A8AC-4B10-9BEA-B884E14DC1EF}"/>
               </a:ext>
             </a:extLst>
           </p:cNvPr>
@@ -13215,7 +13215,7 @@
           <p:cNvPr id="4" name="">
             <a:extLst xmlns:a="http://schemas.openxmlformats.org/drawingml/2006/main">
               <a:ext uri="{FF2B5EF4-FFF2-40B4-BE49-F238E27FC236}">
-                <a16:creationId xmlns:a16="http://schemas.microsoft.com/office/drawing/2014/main" id="{CB2C4A81-23F2-41EC-A1A1-720458269FEE}"/>
+                <a16:creationId xmlns:a16="http://schemas.microsoft.com/office/drawing/2014/main" id="{1CDF3EAF-D786-47F3-8710-67907748FCE8}"/>
               </a:ext>
             </a:extLst>
           </p:cNvPr>
@@ -13277,7 +13277,7 @@
           <p:cNvPr id="5" name="">
             <a:extLst xmlns:a="http://schemas.openxmlformats.org/drawingml/2006/main">
               <a:ext uri="{FF2B5EF4-FFF2-40B4-BE49-F238E27FC236}">
-                <a16:creationId xmlns:a16="http://schemas.microsoft.com/office/drawing/2014/main" id="{DC057CAB-1F46-4FB2-A70C-006FAB7BFDA8}"/>
+                <a16:creationId xmlns:a16="http://schemas.microsoft.com/office/drawing/2014/main" id="{C3C0BB52-1970-4A91-AD23-07433562B4EE}"/>
               </a:ext>
             </a:extLst>
           </p:cNvPr>
@@ -13339,7 +13339,7 @@
           <p:cNvPr id="6" name="">
             <a:extLst xmlns:a="http://schemas.openxmlformats.org/drawingml/2006/main">
               <a:ext uri="{FF2B5EF4-FFF2-40B4-BE49-F238E27FC236}">
-                <a16:creationId xmlns:a16="http://schemas.microsoft.com/office/drawing/2014/main" id="{FE9F1547-3F24-4237-9997-FF13791C66B3}"/>
+                <a16:creationId xmlns:a16="http://schemas.microsoft.com/office/drawing/2014/main" id="{4F2EADCC-CDBB-4554-A809-87ECB7AC4B9F}"/>
               </a:ext>
             </a:extLst>
           </p:cNvPr>
@@ -13399,7 +13399,7 @@
     </p:spTree>
     <p:extLst>
       <p:ext uri="{BB962C8B-B14F-4D97-AF65-F5344CB8AC3E}">
-        <p14:creationId xmlns:p14="http://schemas.microsoft.com/office/powerpoint/2010/main" val="1832674735"/>
+        <p14:creationId xmlns:p14="http://schemas.microsoft.com/office/powerpoint/2010/main" val="1137351951"/>
       </p:ext>
     </p:extLst>
   </p:cSld>
@@ -13427,7 +13427,7 @@
           <p:nvPr/>
         </p:nvPicPr>
         <p:blipFill>
-          <a:blip xmlns:r="http://schemas.openxmlformats.org/officeDocument/2006/relationships" xmlns:a="http://schemas.openxmlformats.org/drawingml/2006/main" r:embed="R09a3f528f3d5420d"/>
+          <a:blip xmlns:r="http://schemas.openxmlformats.org/officeDocument/2006/relationships" xmlns:a="http://schemas.openxmlformats.org/drawingml/2006/main" r:embed="R715967cfa3e34e20"/>
           <a:srcRect xmlns:a="http://schemas.openxmlformats.org/drawingml/2006/main" l="0" t="0" r="0" b="0"/>
           <a:stretch xmlns:a="http://schemas.openxmlformats.org/drawingml/2006/main">
             <a:fillRect l="0" t="0" r="0" b="0"/>
@@ -13448,7 +13448,7 @@
           <p:cNvPr id="2" name="">
             <a:extLst xmlns:a="http://schemas.openxmlformats.org/drawingml/2006/main">
               <a:ext uri="{FF2B5EF4-FFF2-40B4-BE49-F238E27FC236}">
-                <a16:creationId xmlns:a16="http://schemas.microsoft.com/office/drawing/2014/main" id="{90FE578E-3ADF-4280-AD27-DD278DAF1D82}"/>
+                <a16:creationId xmlns:a16="http://schemas.microsoft.com/office/drawing/2014/main" id="{3FABBBC5-6A24-4833-8D97-F60FC5A93E47}"/>
               </a:ext>
             </a:extLst>
           </p:cNvPr>
@@ -13510,7 +13510,7 @@
           <p:cNvPr id="3" name="">
             <a:extLst xmlns:a="http://schemas.openxmlformats.org/drawingml/2006/main">
               <a:ext uri="{FF2B5EF4-FFF2-40B4-BE49-F238E27FC236}">
-                <a16:creationId xmlns:a16="http://schemas.microsoft.com/office/drawing/2014/main" id="{059A8592-E01F-4881-9818-9E9816AC6814}"/>
+                <a16:creationId xmlns:a16="http://schemas.microsoft.com/office/drawing/2014/main" id="{3357A7E8-2EAD-4DB5-B1A3-5275688C268D}"/>
               </a:ext>
             </a:extLst>
           </p:cNvPr>
@@ -13572,7 +13572,7 @@
           <p:cNvPr id="4" name="">
             <a:extLst xmlns:a="http://schemas.openxmlformats.org/drawingml/2006/main">
               <a:ext uri="{FF2B5EF4-FFF2-40B4-BE49-F238E27FC236}">
-                <a16:creationId xmlns:a16="http://schemas.microsoft.com/office/drawing/2014/main" id="{4ABA8A1B-E1E9-4626-B0A2-A52E71F9B5F0}"/>
+                <a16:creationId xmlns:a16="http://schemas.microsoft.com/office/drawing/2014/main" id="{A27147FF-B90D-4996-A18B-8B141E7DAE6C}"/>
               </a:ext>
             </a:extLst>
           </p:cNvPr>
@@ -13634,7 +13634,7 @@
           <p:cNvPr id="5" name="">
             <a:extLst xmlns:a="http://schemas.openxmlformats.org/drawingml/2006/main">
               <a:ext uri="{FF2B5EF4-FFF2-40B4-BE49-F238E27FC236}">
-                <a16:creationId xmlns:a16="http://schemas.microsoft.com/office/drawing/2014/main" id="{E7F2DD0A-E88B-42FA-A3C9-84996EA58DC5}"/>
+                <a16:creationId xmlns:a16="http://schemas.microsoft.com/office/drawing/2014/main" id="{8E53A10D-005F-45BC-A53D-9C0FBE3BB3A8}"/>
               </a:ext>
             </a:extLst>
           </p:cNvPr>
@@ -13665,7 +13665,7 @@
           <p:cNvPr id="6" name="">
             <a:extLst xmlns:a="http://schemas.openxmlformats.org/drawingml/2006/main">
               <a:ext uri="{FF2B5EF4-FFF2-40B4-BE49-F238E27FC236}">
-                <a16:creationId xmlns:a16="http://schemas.microsoft.com/office/drawing/2014/main" id="{7A3DB901-2603-48D4-AED9-639CAAD5D1E8}"/>
+                <a16:creationId xmlns:a16="http://schemas.microsoft.com/office/drawing/2014/main" id="{481BD7DB-84C8-4BC8-947B-B6D219C8CF6B}"/>
               </a:ext>
             </a:extLst>
           </p:cNvPr>
@@ -13727,7 +13727,7 @@
           <p:cNvPr id="7" name="">
             <a:extLst xmlns:a="http://schemas.openxmlformats.org/drawingml/2006/main">
               <a:ext uri="{FF2B5EF4-FFF2-40B4-BE49-F238E27FC236}">
-                <a16:creationId xmlns:a16="http://schemas.microsoft.com/office/drawing/2014/main" id="{451B85C0-AAFA-4B99-B590-250A80EB68A4}"/>
+                <a16:creationId xmlns:a16="http://schemas.microsoft.com/office/drawing/2014/main" id="{34E2B6ED-1FF2-480A-BAC5-C887DD54AF3A}"/>
               </a:ext>
             </a:extLst>
           </p:cNvPr>
@@ -13760,7 +13760,7 @@
           <p:cNvPr id="8" name="">
             <a:extLst xmlns:a="http://schemas.openxmlformats.org/drawingml/2006/main">
               <a:ext uri="{FF2B5EF4-FFF2-40B4-BE49-F238E27FC236}">
-                <a16:creationId xmlns:a16="http://schemas.microsoft.com/office/drawing/2014/main" id="{96AD7ECC-812F-47FC-9443-DBE550ABF578}"/>
+                <a16:creationId xmlns:a16="http://schemas.microsoft.com/office/drawing/2014/main" id="{AC26A35B-F24A-482F-BE3A-D4A4CDADFF88}"/>
               </a:ext>
             </a:extLst>
           </p:cNvPr>
@@ -13795,7 +13795,7 @@
           <p:cNvPr id="9" name="">
             <a:extLst xmlns:a="http://schemas.openxmlformats.org/drawingml/2006/main">
               <a:ext uri="{FF2B5EF4-FFF2-40B4-BE49-F238E27FC236}">
-                <a16:creationId xmlns:a16="http://schemas.microsoft.com/office/drawing/2014/main" id="{96C75488-8D17-45D5-B71E-33FDDF870D93}"/>
+                <a16:creationId xmlns:a16="http://schemas.microsoft.com/office/drawing/2014/main" id="{2EDA8F62-3720-4B43-9468-E0E0D8170673}"/>
               </a:ext>
             </a:extLst>
           </p:cNvPr>
@@ -13826,7 +13826,7 @@
           <p:cNvPr id="10" name="">
             <a:extLst xmlns:a="http://schemas.openxmlformats.org/drawingml/2006/main">
               <a:ext uri="{FF2B5EF4-FFF2-40B4-BE49-F238E27FC236}">
-                <a16:creationId xmlns:a16="http://schemas.microsoft.com/office/drawing/2014/main" id="{0A06B5F4-A6DB-4868-B516-BDEF6430862B}"/>
+                <a16:creationId xmlns:a16="http://schemas.microsoft.com/office/drawing/2014/main" id="{8094FCB0-1018-4A33-9AEC-2A6D20F64E64}"/>
               </a:ext>
             </a:extLst>
           </p:cNvPr>
@@ -13888,7 +13888,7 @@
           <p:cNvPr id="11" name="">
             <a:extLst xmlns:a="http://schemas.openxmlformats.org/drawingml/2006/main">
               <a:ext uri="{FF2B5EF4-FFF2-40B4-BE49-F238E27FC236}">
-                <a16:creationId xmlns:a16="http://schemas.microsoft.com/office/drawing/2014/main" id="{C9A0956B-0FA6-48AB-AD83-65CA63C6D9D9}"/>
+                <a16:creationId xmlns:a16="http://schemas.microsoft.com/office/drawing/2014/main" id="{5F5E9E28-293F-47DA-9E84-C9DBE10F1380}"/>
               </a:ext>
             </a:extLst>
           </p:cNvPr>
@@ -13950,7 +13950,7 @@
           <p:cNvPr id="12" name="">
             <a:extLst xmlns:a="http://schemas.openxmlformats.org/drawingml/2006/main">
               <a:ext uri="{FF2B5EF4-FFF2-40B4-BE49-F238E27FC236}">
-                <a16:creationId xmlns:a16="http://schemas.microsoft.com/office/drawing/2014/main" id="{059E05BD-7A3A-4DE2-9D3B-15F1AEBE9E3B}"/>
+                <a16:creationId xmlns:a16="http://schemas.microsoft.com/office/drawing/2014/main" id="{BF5D6898-712D-41C1-97CC-8E09A2EBDBA3}"/>
               </a:ext>
             </a:extLst>
           </p:cNvPr>
@@ -14012,7 +14012,7 @@
           <p:cNvPr id="13" name="">
             <a:extLst xmlns:a="http://schemas.openxmlformats.org/drawingml/2006/main">
               <a:ext uri="{FF2B5EF4-FFF2-40B4-BE49-F238E27FC236}">
-                <a16:creationId xmlns:a16="http://schemas.microsoft.com/office/drawing/2014/main" id="{B60A6F28-5670-4B1F-87E5-57D3CDDA0A87}"/>
+                <a16:creationId xmlns:a16="http://schemas.microsoft.com/office/drawing/2014/main" id="{23BA3FBB-50EB-4FBE-B2BA-D556D51581E2}"/>
               </a:ext>
             </a:extLst>
           </p:cNvPr>
@@ -14045,7 +14045,7 @@
           <p:cNvPr id="14" name="">
             <a:extLst xmlns:a="http://schemas.openxmlformats.org/drawingml/2006/main">
               <a:ext uri="{FF2B5EF4-FFF2-40B4-BE49-F238E27FC236}">
-                <a16:creationId xmlns:a16="http://schemas.microsoft.com/office/drawing/2014/main" id="{DEA91B4D-151F-47D4-8457-810889D69798}"/>
+                <a16:creationId xmlns:a16="http://schemas.microsoft.com/office/drawing/2014/main" id="{82D9C258-919C-4DBD-81CD-0086F346E460}"/>
               </a:ext>
             </a:extLst>
           </p:cNvPr>
@@ -14080,7 +14080,7 @@
           <p:cNvPr id="15" name="">
             <a:extLst xmlns:a="http://schemas.openxmlformats.org/drawingml/2006/main">
               <a:ext uri="{FF2B5EF4-FFF2-40B4-BE49-F238E27FC236}">
-                <a16:creationId xmlns:a16="http://schemas.microsoft.com/office/drawing/2014/main" id="{DB9F4D73-8EB9-4E4F-87B7-36B5D8AFB509}"/>
+                <a16:creationId xmlns:a16="http://schemas.microsoft.com/office/drawing/2014/main" id="{B57543BB-FB76-4064-B966-5DE23902CB4F}"/>
               </a:ext>
             </a:extLst>
           </p:cNvPr>
@@ -14111,7 +14111,7 @@
           <p:cNvPr id="16" name="">
             <a:extLst xmlns:a="http://schemas.openxmlformats.org/drawingml/2006/main">
               <a:ext uri="{FF2B5EF4-FFF2-40B4-BE49-F238E27FC236}">
-                <a16:creationId xmlns:a16="http://schemas.microsoft.com/office/drawing/2014/main" id="{D9854DBD-6556-468D-8E69-6DE3CD6A2BCD}"/>
+                <a16:creationId xmlns:a16="http://schemas.microsoft.com/office/drawing/2014/main" id="{3A52ABFA-A75A-45AA-AC04-6B1320CA45C6}"/>
               </a:ext>
             </a:extLst>
           </p:cNvPr>
@@ -14173,7 +14173,7 @@
           <p:cNvPr id="17" name="">
             <a:extLst xmlns:a="http://schemas.openxmlformats.org/drawingml/2006/main">
               <a:ext uri="{FF2B5EF4-FFF2-40B4-BE49-F238E27FC236}">
-                <a16:creationId xmlns:a16="http://schemas.microsoft.com/office/drawing/2014/main" id="{1871FBFF-038A-4391-AA79-A3FB949F6E1F}"/>
+                <a16:creationId xmlns:a16="http://schemas.microsoft.com/office/drawing/2014/main" id="{4FB9709C-F993-4A4F-AC26-A7E6D50253A2}"/>
               </a:ext>
             </a:extLst>
           </p:cNvPr>
@@ -14235,7 +14235,7 @@
           <p:cNvPr id="18" name="">
             <a:extLst xmlns:a="http://schemas.openxmlformats.org/drawingml/2006/main">
               <a:ext uri="{FF2B5EF4-FFF2-40B4-BE49-F238E27FC236}">
-                <a16:creationId xmlns:a16="http://schemas.microsoft.com/office/drawing/2014/main" id="{FDE9FE9C-51A5-46A2-8025-5D321818C7AB}"/>
+                <a16:creationId xmlns:a16="http://schemas.microsoft.com/office/drawing/2014/main" id="{4584A4B6-E472-4561-89A5-EB578C61C56F}"/>
               </a:ext>
             </a:extLst>
           </p:cNvPr>
@@ -14297,7 +14297,7 @@
           <p:cNvPr id="19" name="">
             <a:extLst xmlns:a="http://schemas.openxmlformats.org/drawingml/2006/main">
               <a:ext uri="{FF2B5EF4-FFF2-40B4-BE49-F238E27FC236}">
-                <a16:creationId xmlns:a16="http://schemas.microsoft.com/office/drawing/2014/main" id="{EE5B624F-BAA4-4CCC-88BA-F811D15E6F30}"/>
+                <a16:creationId xmlns:a16="http://schemas.microsoft.com/office/drawing/2014/main" id="{5DCDBBDF-6084-4FAC-A46B-EE637CC0328F}"/>
               </a:ext>
             </a:extLst>
           </p:cNvPr>
@@ -14330,7 +14330,7 @@
           <p:cNvPr id="20" name="">
             <a:extLst xmlns:a="http://schemas.openxmlformats.org/drawingml/2006/main">
               <a:ext uri="{FF2B5EF4-FFF2-40B4-BE49-F238E27FC236}">
-                <a16:creationId xmlns:a16="http://schemas.microsoft.com/office/drawing/2014/main" id="{E8CF4FD4-BCDF-434F-9199-22A288C81353}"/>
+                <a16:creationId xmlns:a16="http://schemas.microsoft.com/office/drawing/2014/main" id="{403EE53F-AC7C-4F6A-9F5F-C40EF0C9E55F}"/>
               </a:ext>
             </a:extLst>
           </p:cNvPr>
@@ -14365,7 +14365,7 @@
           <p:cNvPr id="21" name="">
             <a:extLst xmlns:a="http://schemas.openxmlformats.org/drawingml/2006/main">
               <a:ext uri="{FF2B5EF4-FFF2-40B4-BE49-F238E27FC236}">
-                <a16:creationId xmlns:a16="http://schemas.microsoft.com/office/drawing/2014/main" id="{D2770288-9DFD-477F-BFE2-6B668C0C3A07}"/>
+                <a16:creationId xmlns:a16="http://schemas.microsoft.com/office/drawing/2014/main" id="{72258958-4836-4966-A98D-5EC17D582C53}"/>
               </a:ext>
             </a:extLst>
           </p:cNvPr>
@@ -14396,7 +14396,7 @@
           <p:cNvPr id="22" name="">
             <a:extLst xmlns:a="http://schemas.openxmlformats.org/drawingml/2006/main">
               <a:ext uri="{FF2B5EF4-FFF2-40B4-BE49-F238E27FC236}">
-                <a16:creationId xmlns:a16="http://schemas.microsoft.com/office/drawing/2014/main" id="{EA72A463-A889-4EE0-9C80-788EAB42FC63}"/>
+                <a16:creationId xmlns:a16="http://schemas.microsoft.com/office/drawing/2014/main" id="{F1E7115A-5DDD-4A20-B486-7AD8F350DCDE}"/>
               </a:ext>
             </a:extLst>
           </p:cNvPr>
@@ -14458,7 +14458,7 @@
           <p:cNvPr id="23" name="">
             <a:extLst xmlns:a="http://schemas.openxmlformats.org/drawingml/2006/main">
               <a:ext uri="{FF2B5EF4-FFF2-40B4-BE49-F238E27FC236}">
-                <a16:creationId xmlns:a16="http://schemas.microsoft.com/office/drawing/2014/main" id="{BAD59E51-C194-41A5-89CD-4EB0B02BBD59}"/>
+                <a16:creationId xmlns:a16="http://schemas.microsoft.com/office/drawing/2014/main" id="{C80E775F-1CF7-4DA5-A5D1-05D0D9146939}"/>
               </a:ext>
             </a:extLst>
           </p:cNvPr>
@@ -14520,7 +14520,7 @@
           <p:cNvPr id="24" name="">
             <a:extLst xmlns:a="http://schemas.openxmlformats.org/drawingml/2006/main">
               <a:ext uri="{FF2B5EF4-FFF2-40B4-BE49-F238E27FC236}">
-                <a16:creationId xmlns:a16="http://schemas.microsoft.com/office/drawing/2014/main" id="{13FDA75C-1504-40D0-94B1-F1F30E591B99}"/>
+                <a16:creationId xmlns:a16="http://schemas.microsoft.com/office/drawing/2014/main" id="{1DD536BE-C545-48DC-BFB5-4D027AC431B8}"/>
               </a:ext>
             </a:extLst>
           </p:cNvPr>
@@ -14582,7 +14582,7 @@
           <p:cNvPr id="25" name="">
             <a:extLst xmlns:a="http://schemas.openxmlformats.org/drawingml/2006/main">
               <a:ext uri="{FF2B5EF4-FFF2-40B4-BE49-F238E27FC236}">
-                <a16:creationId xmlns:a16="http://schemas.microsoft.com/office/drawing/2014/main" id="{470DF450-19FB-4450-952F-CCF23979EAF3}"/>
+                <a16:creationId xmlns:a16="http://schemas.microsoft.com/office/drawing/2014/main" id="{B280CD0C-A097-4E50-9088-1BD9869718CC}"/>
               </a:ext>
             </a:extLst>
           </p:cNvPr>
@@ -14644,7 +14644,7 @@
           <p:cNvPr id="26" name="">
             <a:extLst xmlns:a="http://schemas.openxmlformats.org/drawingml/2006/main">
               <a:ext uri="{FF2B5EF4-FFF2-40B4-BE49-F238E27FC236}">
-                <a16:creationId xmlns:a16="http://schemas.microsoft.com/office/drawing/2014/main" id="{6133940F-BBB9-47A6-A205-2DCE7079C702}"/>
+                <a16:creationId xmlns:a16="http://schemas.microsoft.com/office/drawing/2014/main" id="{F9E6827D-E532-47E5-B428-D6922CEE4560}"/>
               </a:ext>
             </a:extLst>
           </p:cNvPr>
@@ -14704,7 +14704,7 @@
     </p:spTree>
     <p:extLst>
       <p:ext uri="{BB962C8B-B14F-4D97-AF65-F5344CB8AC3E}">
-        <p14:creationId xmlns:p14="http://schemas.microsoft.com/office/powerpoint/2010/main" val="2030618189"/>
+        <p14:creationId xmlns:p14="http://schemas.microsoft.com/office/powerpoint/2010/main" val="1369694222"/>
       </p:ext>
     </p:extLst>
   </p:cSld>
@@ -14732,7 +14732,7 @@
           <p:nvPr/>
         </p:nvPicPr>
         <p:blipFill>
-          <a:blip xmlns:r="http://schemas.openxmlformats.org/officeDocument/2006/relationships" xmlns:a="http://schemas.openxmlformats.org/drawingml/2006/main" r:embed="R028fd60439d349a1"/>
+          <a:blip xmlns:r="http://schemas.openxmlformats.org/officeDocument/2006/relationships" xmlns:a="http://schemas.openxmlformats.org/drawingml/2006/main" r:embed="R3006054d08104c54"/>
           <a:srcRect xmlns:a="http://schemas.openxmlformats.org/drawingml/2006/main" l="0" t="0" r="0" b="0"/>
           <a:stretch xmlns:a="http://schemas.openxmlformats.org/drawingml/2006/main">
             <a:fillRect l="0" t="0" r="0" b="0"/>
@@ -14753,7 +14753,7 @@
           <p:cNvPr id="2" name="">
             <a:extLst xmlns:a="http://schemas.openxmlformats.org/drawingml/2006/main">
               <a:ext uri="{FF2B5EF4-FFF2-40B4-BE49-F238E27FC236}">
-                <a16:creationId xmlns:a16="http://schemas.microsoft.com/office/drawing/2014/main" id="{29BDFEF3-BFDF-4438-A56A-E984A52EFF10}"/>
+                <a16:creationId xmlns:a16="http://schemas.microsoft.com/office/drawing/2014/main" id="{4792E825-6F8F-4209-8A78-B4265782BF4E}"/>
               </a:ext>
             </a:extLst>
           </p:cNvPr>
@@ -14815,7 +14815,7 @@
           <p:cNvPr id="3" name="">
             <a:extLst xmlns:a="http://schemas.openxmlformats.org/drawingml/2006/main">
               <a:ext uri="{FF2B5EF4-FFF2-40B4-BE49-F238E27FC236}">
-                <a16:creationId xmlns:a16="http://schemas.microsoft.com/office/drawing/2014/main" id="{2695EF9E-2519-4726-8850-E2D75769113B}"/>
+                <a16:creationId xmlns:a16="http://schemas.microsoft.com/office/drawing/2014/main" id="{87566D6A-C6A5-4A21-A4FB-5B6D9CB6C430}"/>
               </a:ext>
             </a:extLst>
           </p:cNvPr>
@@ -14877,7 +14877,7 @@
           <p:cNvPr id="4" name="">
             <a:extLst xmlns:a="http://schemas.openxmlformats.org/drawingml/2006/main">
               <a:ext uri="{FF2B5EF4-FFF2-40B4-BE49-F238E27FC236}">
-                <a16:creationId xmlns:a16="http://schemas.microsoft.com/office/drawing/2014/main" id="{ECBEA284-5F58-458F-A96D-8A25DD899ADB}"/>
+                <a16:creationId xmlns:a16="http://schemas.microsoft.com/office/drawing/2014/main" id="{ADFFE443-E41B-4AC8-807A-151D2E638A08}"/>
               </a:ext>
             </a:extLst>
           </p:cNvPr>
@@ -14939,7 +14939,7 @@
           <p:cNvPr id="5" name="">
             <a:extLst xmlns:a="http://schemas.openxmlformats.org/drawingml/2006/main">
               <a:ext uri="{FF2B5EF4-FFF2-40B4-BE49-F238E27FC236}">
-                <a16:creationId xmlns:a16="http://schemas.microsoft.com/office/drawing/2014/main" id="{2246901C-C1A1-4D48-B952-29C17C505782}"/>
+                <a16:creationId xmlns:a16="http://schemas.microsoft.com/office/drawing/2014/main" id="{B90A1A15-BC92-4A22-84D9-A9E1B12C7089}"/>
               </a:ext>
             </a:extLst>
           </p:cNvPr>
@@ -14970,7 +14970,7 @@
           <p:cNvPr id="6" name="">
             <a:extLst xmlns:a="http://schemas.openxmlformats.org/drawingml/2006/main">
               <a:ext uri="{FF2B5EF4-FFF2-40B4-BE49-F238E27FC236}">
-                <a16:creationId xmlns:a16="http://schemas.microsoft.com/office/drawing/2014/main" id="{CBEB5ED8-A4E4-4AA4-8550-6D507205A336}"/>
+                <a16:creationId xmlns:a16="http://schemas.microsoft.com/office/drawing/2014/main" id="{19F952C0-DFAC-4EC5-816E-CC87DFBB533D}"/>
               </a:ext>
             </a:extLst>
           </p:cNvPr>
@@ -15032,7 +15032,7 @@
           <p:cNvPr id="7" name="">
             <a:extLst xmlns:a="http://schemas.openxmlformats.org/drawingml/2006/main">
               <a:ext uri="{FF2B5EF4-FFF2-40B4-BE49-F238E27FC236}">
-                <a16:creationId xmlns:a16="http://schemas.microsoft.com/office/drawing/2014/main" id="{F90F3F2A-F095-428F-BB16-06EDCE2F2362}"/>
+                <a16:creationId xmlns:a16="http://schemas.microsoft.com/office/drawing/2014/main" id="{9D077B7F-7E4D-4866-927B-1A62EDB9309C}"/>
               </a:ext>
             </a:extLst>
           </p:cNvPr>
@@ -15065,7 +15065,7 @@
           <p:cNvPr id="8" name="">
             <a:extLst xmlns:a="http://schemas.openxmlformats.org/drawingml/2006/main">
               <a:ext uri="{FF2B5EF4-FFF2-40B4-BE49-F238E27FC236}">
-                <a16:creationId xmlns:a16="http://schemas.microsoft.com/office/drawing/2014/main" id="{C4339094-804A-48F3-9AE4-86AD9035167A}"/>
+                <a16:creationId xmlns:a16="http://schemas.microsoft.com/office/drawing/2014/main" id="{D0306CD6-6B50-453E-9E50-D0ECF9C20124}"/>
               </a:ext>
             </a:extLst>
           </p:cNvPr>
@@ -15100,7 +15100,7 @@
           <p:cNvPr id="9" name="">
             <a:extLst xmlns:a="http://schemas.openxmlformats.org/drawingml/2006/main">
               <a:ext uri="{FF2B5EF4-FFF2-40B4-BE49-F238E27FC236}">
-                <a16:creationId xmlns:a16="http://schemas.microsoft.com/office/drawing/2014/main" id="{0F214482-DA1B-4088-B037-C8C78AD169A3}"/>
+                <a16:creationId xmlns:a16="http://schemas.microsoft.com/office/drawing/2014/main" id="{2AF2F940-42E5-4C06-AE4C-92516B3D6905}"/>
               </a:ext>
             </a:extLst>
           </p:cNvPr>
@@ -15131,7 +15131,7 @@
           <p:cNvPr id="10" name="">
             <a:extLst xmlns:a="http://schemas.openxmlformats.org/drawingml/2006/main">
               <a:ext uri="{FF2B5EF4-FFF2-40B4-BE49-F238E27FC236}">
-                <a16:creationId xmlns:a16="http://schemas.microsoft.com/office/drawing/2014/main" id="{D4C8EAFB-8F03-4750-BF55-BED567F5B41B}"/>
+                <a16:creationId xmlns:a16="http://schemas.microsoft.com/office/drawing/2014/main" id="{5D5196D3-F240-480B-8E51-7F5237BF5F73}"/>
               </a:ext>
             </a:extLst>
           </p:cNvPr>
@@ -15193,7 +15193,7 @@
           <p:cNvPr id="11" name="">
             <a:extLst xmlns:a="http://schemas.openxmlformats.org/drawingml/2006/main">
               <a:ext uri="{FF2B5EF4-FFF2-40B4-BE49-F238E27FC236}">
-                <a16:creationId xmlns:a16="http://schemas.microsoft.com/office/drawing/2014/main" id="{80642B15-FB03-4B3D-BAE6-8FBBCCF02147}"/>
+                <a16:creationId xmlns:a16="http://schemas.microsoft.com/office/drawing/2014/main" id="{B1829607-68D1-4C53-89B9-8C6437AD784F}"/>
               </a:ext>
             </a:extLst>
           </p:cNvPr>
@@ -15255,7 +15255,7 @@
           <p:cNvPr id="12" name="">
             <a:extLst xmlns:a="http://schemas.openxmlformats.org/drawingml/2006/main">
               <a:ext uri="{FF2B5EF4-FFF2-40B4-BE49-F238E27FC236}">
-                <a16:creationId xmlns:a16="http://schemas.microsoft.com/office/drawing/2014/main" id="{72B4BC16-9FE2-4717-BC76-DBAEECD75EB9}"/>
+                <a16:creationId xmlns:a16="http://schemas.microsoft.com/office/drawing/2014/main" id="{9C70ACD9-16CD-430D-974A-3313134AC80A}"/>
               </a:ext>
             </a:extLst>
           </p:cNvPr>
@@ -15317,7 +15317,7 @@
           <p:cNvPr id="13" name="">
             <a:extLst xmlns:a="http://schemas.openxmlformats.org/drawingml/2006/main">
               <a:ext uri="{FF2B5EF4-FFF2-40B4-BE49-F238E27FC236}">
-                <a16:creationId xmlns:a16="http://schemas.microsoft.com/office/drawing/2014/main" id="{DD4AFD6A-8FE1-488B-9640-70819678F827}"/>
+                <a16:creationId xmlns:a16="http://schemas.microsoft.com/office/drawing/2014/main" id="{E103F60D-ED93-455B-A95C-4A8F713CA950}"/>
               </a:ext>
             </a:extLst>
           </p:cNvPr>
@@ -15350,7 +15350,7 @@
           <p:cNvPr id="14" name="">
             <a:extLst xmlns:a="http://schemas.openxmlformats.org/drawingml/2006/main">
               <a:ext uri="{FF2B5EF4-FFF2-40B4-BE49-F238E27FC236}">
-                <a16:creationId xmlns:a16="http://schemas.microsoft.com/office/drawing/2014/main" id="{E7F391DD-0652-4451-9FD5-6C1130B99C17}"/>
+                <a16:creationId xmlns:a16="http://schemas.microsoft.com/office/drawing/2014/main" id="{5F0995D0-20BF-41FE-8667-704B0A0C4255}"/>
               </a:ext>
             </a:extLst>
           </p:cNvPr>
@@ -15385,7 +15385,7 @@
           <p:cNvPr id="15" name="">
             <a:extLst xmlns:a="http://schemas.openxmlformats.org/drawingml/2006/main">
               <a:ext uri="{FF2B5EF4-FFF2-40B4-BE49-F238E27FC236}">
-                <a16:creationId xmlns:a16="http://schemas.microsoft.com/office/drawing/2014/main" id="{3E6F950A-F259-4ABD-AEDF-BF94D298F522}"/>
+                <a16:creationId xmlns:a16="http://schemas.microsoft.com/office/drawing/2014/main" id="{8282067C-4E8A-40A1-A803-4DDD9874AA2F}"/>
               </a:ext>
             </a:extLst>
           </p:cNvPr>
@@ -15416,7 +15416,7 @@
           <p:cNvPr id="16" name="">
             <a:extLst xmlns:a="http://schemas.openxmlformats.org/drawingml/2006/main">
               <a:ext uri="{FF2B5EF4-FFF2-40B4-BE49-F238E27FC236}">
-                <a16:creationId xmlns:a16="http://schemas.microsoft.com/office/drawing/2014/main" id="{3BB36B5B-7AE6-45C1-8968-49FB23D506F8}"/>
+                <a16:creationId xmlns:a16="http://schemas.microsoft.com/office/drawing/2014/main" id="{51F673DA-6DC5-4ED2-9A50-53D0375EC6F5}"/>
               </a:ext>
             </a:extLst>
           </p:cNvPr>
@@ -15478,7 +15478,7 @@
           <p:cNvPr id="17" name="">
             <a:extLst xmlns:a="http://schemas.openxmlformats.org/drawingml/2006/main">
               <a:ext uri="{FF2B5EF4-FFF2-40B4-BE49-F238E27FC236}">
-                <a16:creationId xmlns:a16="http://schemas.microsoft.com/office/drawing/2014/main" id="{6EA8B3C8-22A7-45E1-B9E6-D4B6A4F619AD}"/>
+                <a16:creationId xmlns:a16="http://schemas.microsoft.com/office/drawing/2014/main" id="{F3600C39-435B-4000-9943-D4030B2ADCFC}"/>
               </a:ext>
             </a:extLst>
           </p:cNvPr>
@@ -15540,7 +15540,7 @@
           <p:cNvPr id="18" name="">
             <a:extLst xmlns:a="http://schemas.openxmlformats.org/drawingml/2006/main">
               <a:ext uri="{FF2B5EF4-FFF2-40B4-BE49-F238E27FC236}">
-                <a16:creationId xmlns:a16="http://schemas.microsoft.com/office/drawing/2014/main" id="{C7764E73-D59B-4BE4-80E9-0B259C31321C}"/>
+                <a16:creationId xmlns:a16="http://schemas.microsoft.com/office/drawing/2014/main" id="{13F78543-A835-4AAF-BA75-E98128DF33C5}"/>
               </a:ext>
             </a:extLst>
           </p:cNvPr>
@@ -15602,7 +15602,7 @@
           <p:cNvPr id="19" name="">
             <a:extLst xmlns:a="http://schemas.openxmlformats.org/drawingml/2006/main">
               <a:ext uri="{FF2B5EF4-FFF2-40B4-BE49-F238E27FC236}">
-                <a16:creationId xmlns:a16="http://schemas.microsoft.com/office/drawing/2014/main" id="{3B013044-18FC-4A5C-96C5-2A90F795DE91}"/>
+                <a16:creationId xmlns:a16="http://schemas.microsoft.com/office/drawing/2014/main" id="{F1A7D432-5901-44AC-AD5A-6C2FC478E495}"/>
               </a:ext>
             </a:extLst>
           </p:cNvPr>
@@ -15635,7 +15635,7 @@
           <p:cNvPr id="20" name="">
             <a:extLst xmlns:a="http://schemas.openxmlformats.org/drawingml/2006/main">
               <a:ext uri="{FF2B5EF4-FFF2-40B4-BE49-F238E27FC236}">
-                <a16:creationId xmlns:a16="http://schemas.microsoft.com/office/drawing/2014/main" id="{69728823-4856-4DC6-870F-991BA15BBA18}"/>
+                <a16:creationId xmlns:a16="http://schemas.microsoft.com/office/drawing/2014/main" id="{9F1BD31B-72C2-4A62-A18B-F119986B2529}"/>
               </a:ext>
             </a:extLst>
           </p:cNvPr>
@@ -15670,7 +15670,7 @@
           <p:cNvPr id="21" name="">
             <a:extLst xmlns:a="http://schemas.openxmlformats.org/drawingml/2006/main">
               <a:ext uri="{FF2B5EF4-FFF2-40B4-BE49-F238E27FC236}">
-                <a16:creationId xmlns:a16="http://schemas.microsoft.com/office/drawing/2014/main" id="{272CA9A6-A812-487E-BAFC-8AA66FFEDA55}"/>
+                <a16:creationId xmlns:a16="http://schemas.microsoft.com/office/drawing/2014/main" id="{C223E576-C68B-4419-8BCD-CB6DB61E2367}"/>
               </a:ext>
             </a:extLst>
           </p:cNvPr>
@@ -15701,7 +15701,7 @@
           <p:cNvPr id="22" name="">
             <a:extLst xmlns:a="http://schemas.openxmlformats.org/drawingml/2006/main">
               <a:ext uri="{FF2B5EF4-FFF2-40B4-BE49-F238E27FC236}">
-                <a16:creationId xmlns:a16="http://schemas.microsoft.com/office/drawing/2014/main" id="{48C969F2-1108-4807-B4B2-4CC5CEEFD854}"/>
+                <a16:creationId xmlns:a16="http://schemas.microsoft.com/office/drawing/2014/main" id="{63B2B4CD-C81C-4B3F-B370-8B06E318234E}"/>
               </a:ext>
             </a:extLst>
           </p:cNvPr>
@@ -15763,7 +15763,7 @@
           <p:cNvPr id="23" name="">
             <a:extLst xmlns:a="http://schemas.openxmlformats.org/drawingml/2006/main">
               <a:ext uri="{FF2B5EF4-FFF2-40B4-BE49-F238E27FC236}">
-                <a16:creationId xmlns:a16="http://schemas.microsoft.com/office/drawing/2014/main" id="{007A007E-6A1E-4F32-8A2F-4EECF22B5122}"/>
+                <a16:creationId xmlns:a16="http://schemas.microsoft.com/office/drawing/2014/main" id="{3157EDFF-CB42-49EF-A0B9-CDC5F74188C1}"/>
               </a:ext>
             </a:extLst>
           </p:cNvPr>
@@ -15825,7 +15825,7 @@
           <p:cNvPr id="24" name="">
             <a:extLst xmlns:a="http://schemas.openxmlformats.org/drawingml/2006/main">
               <a:ext uri="{FF2B5EF4-FFF2-40B4-BE49-F238E27FC236}">
-                <a16:creationId xmlns:a16="http://schemas.microsoft.com/office/drawing/2014/main" id="{07A19111-2A69-4706-B6D4-6D27B0BE282C}"/>
+                <a16:creationId xmlns:a16="http://schemas.microsoft.com/office/drawing/2014/main" id="{981CF06C-6B9B-48E6-8D59-F7B979BF4D1C}"/>
               </a:ext>
             </a:extLst>
           </p:cNvPr>
@@ -15887,7 +15887,7 @@
           <p:cNvPr id="25" name="">
             <a:extLst xmlns:a="http://schemas.openxmlformats.org/drawingml/2006/main">
               <a:ext uri="{FF2B5EF4-FFF2-40B4-BE49-F238E27FC236}">
-                <a16:creationId xmlns:a16="http://schemas.microsoft.com/office/drawing/2014/main" id="{B1089667-C380-456C-9162-5E391ECD6CBB}"/>
+                <a16:creationId xmlns:a16="http://schemas.microsoft.com/office/drawing/2014/main" id="{22C3888E-29A8-42B5-B3E6-FB75577F37E5}"/>
               </a:ext>
             </a:extLst>
           </p:cNvPr>
@@ -15949,7 +15949,7 @@
           <p:cNvPr id="26" name="">
             <a:extLst xmlns:a="http://schemas.openxmlformats.org/drawingml/2006/main">
               <a:ext uri="{FF2B5EF4-FFF2-40B4-BE49-F238E27FC236}">
-                <a16:creationId xmlns:a16="http://schemas.microsoft.com/office/drawing/2014/main" id="{00057732-2405-4A8D-AC10-627533C87136}"/>
+                <a16:creationId xmlns:a16="http://schemas.microsoft.com/office/drawing/2014/main" id="{B1C21B48-8B05-4E05-83A2-FD88831995F6}"/>
               </a:ext>
             </a:extLst>
           </p:cNvPr>
@@ -16009,7 +16009,7 @@
     </p:spTree>
     <p:extLst>
       <p:ext uri="{BB962C8B-B14F-4D97-AF65-F5344CB8AC3E}">
-        <p14:creationId xmlns:p14="http://schemas.microsoft.com/office/powerpoint/2010/main" val="1693228000"/>
+        <p14:creationId xmlns:p14="http://schemas.microsoft.com/office/powerpoint/2010/main" val="174202416"/>
       </p:ext>
     </p:extLst>
   </p:cSld>
@@ -16037,7 +16037,7 @@
           <p:nvPr/>
         </p:nvPicPr>
         <p:blipFill>
-          <a:blip xmlns:r="http://schemas.openxmlformats.org/officeDocument/2006/relationships" xmlns:a="http://schemas.openxmlformats.org/drawingml/2006/main" r:embed="R1ca296adf1e14540"/>
+          <a:blip xmlns:r="http://schemas.openxmlformats.org/officeDocument/2006/relationships" xmlns:a="http://schemas.openxmlformats.org/drawingml/2006/main" r:embed="R994215140df3419c"/>
           <a:srcRect xmlns:a="http://schemas.openxmlformats.org/drawingml/2006/main" l="0" t="0" r="0" b="0"/>
           <a:stretch xmlns:a="http://schemas.openxmlformats.org/drawingml/2006/main">
             <a:fillRect l="0" t="0" r="0" b="0"/>
@@ -16058,7 +16058,7 @@
           <p:cNvPr id="2" name="">
             <a:extLst xmlns:a="http://schemas.openxmlformats.org/drawingml/2006/main">
               <a:ext uri="{FF2B5EF4-FFF2-40B4-BE49-F238E27FC236}">
-                <a16:creationId xmlns:a16="http://schemas.microsoft.com/office/drawing/2014/main" id="{5D81D230-C474-498A-98E3-388AA5CA7803}"/>
+                <a16:creationId xmlns:a16="http://schemas.microsoft.com/office/drawing/2014/main" id="{7A46401F-4D06-4F89-94BC-B8615415439C}"/>
               </a:ext>
             </a:extLst>
           </p:cNvPr>
@@ -16120,7 +16120,7 @@
           <p:cNvPr id="3" name="">
             <a:extLst xmlns:a="http://schemas.openxmlformats.org/drawingml/2006/main">
               <a:ext uri="{FF2B5EF4-FFF2-40B4-BE49-F238E27FC236}">
-                <a16:creationId xmlns:a16="http://schemas.microsoft.com/office/drawing/2014/main" id="{829E30DE-B552-4BCF-A1D3-D7A27FD8F99D}"/>
+                <a16:creationId xmlns:a16="http://schemas.microsoft.com/office/drawing/2014/main" id="{9A9E73CF-07CD-49DC-B2BB-96F2A7F3F240}"/>
               </a:ext>
             </a:extLst>
           </p:cNvPr>
@@ -16182,7 +16182,7 @@
           <p:cNvPr id="4" name="">
             <a:extLst xmlns:a="http://schemas.openxmlformats.org/drawingml/2006/main">
               <a:ext uri="{FF2B5EF4-FFF2-40B4-BE49-F238E27FC236}">
-                <a16:creationId xmlns:a16="http://schemas.microsoft.com/office/drawing/2014/main" id="{36325FCF-62FA-46E1-BFCB-F2522F6737F1}"/>
+                <a16:creationId xmlns:a16="http://schemas.microsoft.com/office/drawing/2014/main" id="{33704DB7-1D80-4270-BD03-CC3EEC55C6C3}"/>
               </a:ext>
             </a:extLst>
           </p:cNvPr>
@@ -16244,7 +16244,7 @@
           <p:cNvPr id="5" name="">
             <a:extLst xmlns:a="http://schemas.openxmlformats.org/drawingml/2006/main">
               <a:ext uri="{FF2B5EF4-FFF2-40B4-BE49-F238E27FC236}">
-                <a16:creationId xmlns:a16="http://schemas.microsoft.com/office/drawing/2014/main" id="{916F8297-0161-496A-BA99-82D7799851DB}"/>
+                <a16:creationId xmlns:a16="http://schemas.microsoft.com/office/drawing/2014/main" id="{89AB0445-4A3E-4542-A5F9-70DA535B8255}"/>
               </a:ext>
             </a:extLst>
           </p:cNvPr>
@@ -16275,7 +16275,7 @@
           <p:cNvPr id="6" name="">
             <a:extLst xmlns:a="http://schemas.openxmlformats.org/drawingml/2006/main">
               <a:ext uri="{FF2B5EF4-FFF2-40B4-BE49-F238E27FC236}">
-                <a16:creationId xmlns:a16="http://schemas.microsoft.com/office/drawing/2014/main" id="{152769AE-F4CB-4DB4-9D63-D0FEFC79574C}"/>
+                <a16:creationId xmlns:a16="http://schemas.microsoft.com/office/drawing/2014/main" id="{7EA64EF6-F314-4881-B767-3EA82B2AF3D9}"/>
               </a:ext>
             </a:extLst>
           </p:cNvPr>
@@ -16337,7 +16337,7 @@
           <p:cNvPr id="7" name="">
             <a:extLst xmlns:a="http://schemas.openxmlformats.org/drawingml/2006/main">
               <a:ext uri="{FF2B5EF4-FFF2-40B4-BE49-F238E27FC236}">
-                <a16:creationId xmlns:a16="http://schemas.microsoft.com/office/drawing/2014/main" id="{0327F833-F663-48C4-98C0-FB25D87ACDAD}"/>
+                <a16:creationId xmlns:a16="http://schemas.microsoft.com/office/drawing/2014/main" id="{B9B1A555-0B86-46E5-8806-087A16C9303F}"/>
               </a:ext>
             </a:extLst>
           </p:cNvPr>
@@ -16370,7 +16370,7 @@
           <p:cNvPr id="8" name="">
             <a:extLst xmlns:a="http://schemas.openxmlformats.org/drawingml/2006/main">
               <a:ext uri="{FF2B5EF4-FFF2-40B4-BE49-F238E27FC236}">
-                <a16:creationId xmlns:a16="http://schemas.microsoft.com/office/drawing/2014/main" id="{939338CB-07BA-4B8D-875C-F3F2430A4601}"/>
+                <a16:creationId xmlns:a16="http://schemas.microsoft.com/office/drawing/2014/main" id="{5C473641-F40A-4767-8936-B7812BEA48B1}"/>
               </a:ext>
             </a:extLst>
           </p:cNvPr>
@@ -16405,7 +16405,7 @@
           <p:cNvPr id="9" name="">
             <a:extLst xmlns:a="http://schemas.openxmlformats.org/drawingml/2006/main">
               <a:ext uri="{FF2B5EF4-FFF2-40B4-BE49-F238E27FC236}">
-                <a16:creationId xmlns:a16="http://schemas.microsoft.com/office/drawing/2014/main" id="{DCFE8446-69E1-4705-808E-DE4AD4AC7D7F}"/>
+                <a16:creationId xmlns:a16="http://schemas.microsoft.com/office/drawing/2014/main" id="{DD69F30B-8A9C-4AC0-8FA1-7AD6FF680BE3}"/>
               </a:ext>
             </a:extLst>
           </p:cNvPr>
@@ -16436,7 +16436,7 @@
           <p:cNvPr id="10" name="">
             <a:extLst xmlns:a="http://schemas.openxmlformats.org/drawingml/2006/main">
               <a:ext uri="{FF2B5EF4-FFF2-40B4-BE49-F238E27FC236}">
-                <a16:creationId xmlns:a16="http://schemas.microsoft.com/office/drawing/2014/main" id="{D89C3661-5213-4135-A960-B79C64A7C83E}"/>
+                <a16:creationId xmlns:a16="http://schemas.microsoft.com/office/drawing/2014/main" id="{0BABF98C-F209-4CEE-B431-2D12FFAA79A3}"/>
               </a:ext>
             </a:extLst>
           </p:cNvPr>
@@ -16498,7 +16498,7 @@
           <p:cNvPr id="11" name="">
             <a:extLst xmlns:a="http://schemas.openxmlformats.org/drawingml/2006/main">
               <a:ext uri="{FF2B5EF4-FFF2-40B4-BE49-F238E27FC236}">
-                <a16:creationId xmlns:a16="http://schemas.microsoft.com/office/drawing/2014/main" id="{EC070D35-F595-4004-B6BB-0593FDB00C79}"/>
+                <a16:creationId xmlns:a16="http://schemas.microsoft.com/office/drawing/2014/main" id="{20710696-BEBC-4FB3-9E6F-4C8EB9C1C5FE}"/>
               </a:ext>
             </a:extLst>
           </p:cNvPr>
@@ -16560,7 +16560,7 @@
           <p:cNvPr id="12" name="">
             <a:extLst xmlns:a="http://schemas.openxmlformats.org/drawingml/2006/main">
               <a:ext uri="{FF2B5EF4-FFF2-40B4-BE49-F238E27FC236}">
-                <a16:creationId xmlns:a16="http://schemas.microsoft.com/office/drawing/2014/main" id="{9A15AAEE-DAE4-4131-A73A-301DD3614BE8}"/>
+                <a16:creationId xmlns:a16="http://schemas.microsoft.com/office/drawing/2014/main" id="{69F9FE8C-3BD4-49DB-BFAF-5DD4E1AEE1E5}"/>
               </a:ext>
             </a:extLst>
           </p:cNvPr>
@@ -16593,7 +16593,7 @@
           <p:cNvPr id="13" name="">
             <a:extLst xmlns:a="http://schemas.openxmlformats.org/drawingml/2006/main">
               <a:ext uri="{FF2B5EF4-FFF2-40B4-BE49-F238E27FC236}">
-                <a16:creationId xmlns:a16="http://schemas.microsoft.com/office/drawing/2014/main" id="{F1DB2680-A64F-47E9-AEB2-5FB4ECC25B7F}"/>
+                <a16:creationId xmlns:a16="http://schemas.microsoft.com/office/drawing/2014/main" id="{9F0089AC-06B3-48B5-BF96-C42F3D2D6259}"/>
               </a:ext>
             </a:extLst>
           </p:cNvPr>
@@ -16628,7 +16628,7 @@
           <p:cNvPr id="14" name="">
             <a:extLst xmlns:a="http://schemas.openxmlformats.org/drawingml/2006/main">
               <a:ext uri="{FF2B5EF4-FFF2-40B4-BE49-F238E27FC236}">
-                <a16:creationId xmlns:a16="http://schemas.microsoft.com/office/drawing/2014/main" id="{A585D90F-6191-480C-AE46-C500FD03FB9E}"/>
+                <a16:creationId xmlns:a16="http://schemas.microsoft.com/office/drawing/2014/main" id="{75CD6037-7BA8-4F04-90C2-06F0B989B056}"/>
               </a:ext>
             </a:extLst>
           </p:cNvPr>
@@ -16659,7 +16659,7 @@
           <p:cNvPr id="15" name="">
             <a:extLst xmlns:a="http://schemas.openxmlformats.org/drawingml/2006/main">
               <a:ext uri="{FF2B5EF4-FFF2-40B4-BE49-F238E27FC236}">
-                <a16:creationId xmlns:a16="http://schemas.microsoft.com/office/drawing/2014/main" id="{19A0534E-D50E-44DB-B58D-76FE41BBE1BD}"/>
+                <a16:creationId xmlns:a16="http://schemas.microsoft.com/office/drawing/2014/main" id="{A86B1B3F-2606-4612-B00B-2B81CD04F441}"/>
               </a:ext>
             </a:extLst>
           </p:cNvPr>
@@ -16721,7 +16721,7 @@
           <p:cNvPr id="16" name="">
             <a:extLst xmlns:a="http://schemas.openxmlformats.org/drawingml/2006/main">
               <a:ext uri="{FF2B5EF4-FFF2-40B4-BE49-F238E27FC236}">
-                <a16:creationId xmlns:a16="http://schemas.microsoft.com/office/drawing/2014/main" id="{9959038E-33E1-40EC-9EAF-5F690B471405}"/>
+                <a16:creationId xmlns:a16="http://schemas.microsoft.com/office/drawing/2014/main" id="{43A0F0E7-1821-4ACD-A47D-B66DE444EEA1}"/>
               </a:ext>
             </a:extLst>
           </p:cNvPr>
@@ -16783,7 +16783,7 @@
           <p:cNvPr id="17" name="">
             <a:extLst xmlns:a="http://schemas.openxmlformats.org/drawingml/2006/main">
               <a:ext uri="{FF2B5EF4-FFF2-40B4-BE49-F238E27FC236}">
-                <a16:creationId xmlns:a16="http://schemas.microsoft.com/office/drawing/2014/main" id="{20FB6BF3-243D-4C57-8347-7638F3256F62}"/>
+                <a16:creationId xmlns:a16="http://schemas.microsoft.com/office/drawing/2014/main" id="{88592CE9-4841-425A-AB7F-E611E8B39023}"/>
               </a:ext>
             </a:extLst>
           </p:cNvPr>
@@ -16816,7 +16816,7 @@
           <p:cNvPr id="18" name="">
             <a:extLst xmlns:a="http://schemas.openxmlformats.org/drawingml/2006/main">
               <a:ext uri="{FF2B5EF4-FFF2-40B4-BE49-F238E27FC236}">
-                <a16:creationId xmlns:a16="http://schemas.microsoft.com/office/drawing/2014/main" id="{D9019C58-01EB-4669-842A-2BBB9305BB6E}"/>
+                <a16:creationId xmlns:a16="http://schemas.microsoft.com/office/drawing/2014/main" id="{02FFDD00-A332-4783-A7AB-762EE924E7A1}"/>
               </a:ext>
             </a:extLst>
           </p:cNvPr>
@@ -16851,7 +16851,7 @@
           <p:cNvPr id="19" name="">
             <a:extLst xmlns:a="http://schemas.openxmlformats.org/drawingml/2006/main">
               <a:ext uri="{FF2B5EF4-FFF2-40B4-BE49-F238E27FC236}">
-                <a16:creationId xmlns:a16="http://schemas.microsoft.com/office/drawing/2014/main" id="{52880143-E55F-4BDB-9A16-1E835B11B931}"/>
+                <a16:creationId xmlns:a16="http://schemas.microsoft.com/office/drawing/2014/main" id="{92CED4AF-81C3-411A-B0F5-CAFEFFC8165A}"/>
               </a:ext>
             </a:extLst>
           </p:cNvPr>
@@ -16882,7 +16882,7 @@
           <p:cNvPr id="20" name="">
             <a:extLst xmlns:a="http://schemas.openxmlformats.org/drawingml/2006/main">
               <a:ext uri="{FF2B5EF4-FFF2-40B4-BE49-F238E27FC236}">
-                <a16:creationId xmlns:a16="http://schemas.microsoft.com/office/drawing/2014/main" id="{1CE7D406-08BC-43C8-B935-594ABFCE9E1B}"/>
+                <a16:creationId xmlns:a16="http://schemas.microsoft.com/office/drawing/2014/main" id="{9740E227-F791-4453-89C1-03F852274E09}"/>
               </a:ext>
             </a:extLst>
           </p:cNvPr>
@@ -16944,7 +16944,7 @@
           <p:cNvPr id="21" name="">
             <a:extLst xmlns:a="http://schemas.openxmlformats.org/drawingml/2006/main">
               <a:ext uri="{FF2B5EF4-FFF2-40B4-BE49-F238E27FC236}">
-                <a16:creationId xmlns:a16="http://schemas.microsoft.com/office/drawing/2014/main" id="{9F40E381-2B6D-4B3B-B3F1-4CB6D00FE4BD}"/>
+                <a16:creationId xmlns:a16="http://schemas.microsoft.com/office/drawing/2014/main" id="{C547E928-2C23-4BA9-86CE-FE5C40692127}"/>
               </a:ext>
             </a:extLst>
           </p:cNvPr>
@@ -17006,7 +17006,7 @@
           <p:cNvPr id="22" name="">
             <a:extLst xmlns:a="http://schemas.openxmlformats.org/drawingml/2006/main">
               <a:ext uri="{FF2B5EF4-FFF2-40B4-BE49-F238E27FC236}">
-                <a16:creationId xmlns:a16="http://schemas.microsoft.com/office/drawing/2014/main" id="{DC41DBF3-3EC4-4682-8F90-A283FB383B51}"/>
+                <a16:creationId xmlns:a16="http://schemas.microsoft.com/office/drawing/2014/main" id="{D2342201-099B-49FD-9366-8D9BF0BDF02F}"/>
               </a:ext>
             </a:extLst>
           </p:cNvPr>
@@ -17068,7 +17068,7 @@
           <p:cNvPr id="23" name="">
             <a:extLst xmlns:a="http://schemas.openxmlformats.org/drawingml/2006/main">
               <a:ext uri="{FF2B5EF4-FFF2-40B4-BE49-F238E27FC236}">
-                <a16:creationId xmlns:a16="http://schemas.microsoft.com/office/drawing/2014/main" id="{9E7A531D-7616-41C6-A3E7-320151F370F1}"/>
+                <a16:creationId xmlns:a16="http://schemas.microsoft.com/office/drawing/2014/main" id="{2B34E288-30F1-4435-BEE7-01DFFC287BC0}"/>
               </a:ext>
             </a:extLst>
           </p:cNvPr>
@@ -17128,7 +17128,7 @@
     </p:spTree>
     <p:extLst>
       <p:ext uri="{BB962C8B-B14F-4D97-AF65-F5344CB8AC3E}">
-        <p14:creationId xmlns:p14="http://schemas.microsoft.com/office/powerpoint/2010/main" val="197116716"/>
+        <p14:creationId xmlns:p14="http://schemas.microsoft.com/office/powerpoint/2010/main" val="786269417"/>
       </p:ext>
     </p:extLst>
   </p:cSld>
@@ -17156,7 +17156,7 @@
           <p:nvPr/>
         </p:nvPicPr>
         <p:blipFill>
-          <a:blip xmlns:r="http://schemas.openxmlformats.org/officeDocument/2006/relationships" xmlns:a="http://schemas.openxmlformats.org/drawingml/2006/main" r:embed="R22fe9a8e5e9c4a83"/>
+          <a:blip xmlns:r="http://schemas.openxmlformats.org/officeDocument/2006/relationships" xmlns:a="http://schemas.openxmlformats.org/drawingml/2006/main" r:embed="R53bfbfa95a3b46d2"/>
           <a:srcRect xmlns:a="http://schemas.openxmlformats.org/drawingml/2006/main" l="0" t="0" r="0" b="0"/>
           <a:stretch xmlns:a="http://schemas.openxmlformats.org/drawingml/2006/main">
             <a:fillRect l="0" t="0" r="0" b="0"/>
@@ -17177,7 +17177,7 @@
           <p:cNvPr id="2" name="">
             <a:extLst xmlns:a="http://schemas.openxmlformats.org/drawingml/2006/main">
               <a:ext uri="{FF2B5EF4-FFF2-40B4-BE49-F238E27FC236}">
-                <a16:creationId xmlns:a16="http://schemas.microsoft.com/office/drawing/2014/main" id="{1A6BAC7E-DC61-4857-8EFF-C6A13716E9CC}"/>
+                <a16:creationId xmlns:a16="http://schemas.microsoft.com/office/drawing/2014/main" id="{200613FF-09AC-4DB1-8019-417A0222C893}"/>
               </a:ext>
             </a:extLst>
           </p:cNvPr>
@@ -17239,7 +17239,7 @@
           <p:cNvPr id="3" name="">
             <a:extLst xmlns:a="http://schemas.openxmlformats.org/drawingml/2006/main">
               <a:ext uri="{FF2B5EF4-FFF2-40B4-BE49-F238E27FC236}">
-                <a16:creationId xmlns:a16="http://schemas.microsoft.com/office/drawing/2014/main" id="{95E5BC00-0A72-489D-AF4E-89AC9E13A0CE}"/>
+                <a16:creationId xmlns:a16="http://schemas.microsoft.com/office/drawing/2014/main" id="{DC8B4CE0-1E9A-4E8F-A058-3F2C4202673C}"/>
               </a:ext>
             </a:extLst>
           </p:cNvPr>
@@ -17301,7 +17301,7 @@
           <p:cNvPr id="4" name="">
             <a:extLst xmlns:a="http://schemas.openxmlformats.org/drawingml/2006/main">
               <a:ext uri="{FF2B5EF4-FFF2-40B4-BE49-F238E27FC236}">
-                <a16:creationId xmlns:a16="http://schemas.microsoft.com/office/drawing/2014/main" id="{D8C351B3-B4CA-4AC4-BC58-E70526C9D958}"/>
+                <a16:creationId xmlns:a16="http://schemas.microsoft.com/office/drawing/2014/main" id="{65C83182-07DC-43DE-AF3B-5319BF57B710}"/>
               </a:ext>
             </a:extLst>
           </p:cNvPr>
@@ -17363,7 +17363,7 @@
           <p:cNvPr id="5" name="">
             <a:extLst xmlns:a="http://schemas.openxmlformats.org/drawingml/2006/main">
               <a:ext uri="{FF2B5EF4-FFF2-40B4-BE49-F238E27FC236}">
-                <a16:creationId xmlns:a16="http://schemas.microsoft.com/office/drawing/2014/main" id="{D1083A9A-43F8-4804-ABC4-206AC9FFF72D}"/>
+                <a16:creationId xmlns:a16="http://schemas.microsoft.com/office/drawing/2014/main" id="{1BE9FF51-A7F0-4A91-9A03-5DFE45C80C37}"/>
               </a:ext>
             </a:extLst>
           </p:cNvPr>
@@ -17394,7 +17394,7 @@
           <p:cNvPr id="6" name="">
             <a:extLst xmlns:a="http://schemas.openxmlformats.org/drawingml/2006/main">
               <a:ext uri="{FF2B5EF4-FFF2-40B4-BE49-F238E27FC236}">
-                <a16:creationId xmlns:a16="http://schemas.microsoft.com/office/drawing/2014/main" id="{28BBDBAC-4556-43D6-AE77-F6C91492CFA4}"/>
+                <a16:creationId xmlns:a16="http://schemas.microsoft.com/office/drawing/2014/main" id="{0612BC93-40F0-4AD3-BF7F-3F605989C64B}"/>
               </a:ext>
             </a:extLst>
           </p:cNvPr>
@@ -17456,7 +17456,7 @@
           <p:cNvPr id="7" name="">
             <a:extLst xmlns:a="http://schemas.openxmlformats.org/drawingml/2006/main">
               <a:ext uri="{FF2B5EF4-FFF2-40B4-BE49-F238E27FC236}">
-                <a16:creationId xmlns:a16="http://schemas.microsoft.com/office/drawing/2014/main" id="{23C0D5C3-EA6E-4DDD-8CEE-1ECD96DB0094}"/>
+                <a16:creationId xmlns:a16="http://schemas.microsoft.com/office/drawing/2014/main" id="{479A23E9-DA2D-4089-B2A8-DDDB037183CC}"/>
               </a:ext>
             </a:extLst>
           </p:cNvPr>
@@ -17489,7 +17489,7 @@
           <p:cNvPr id="8" name="">
             <a:extLst xmlns:a="http://schemas.openxmlformats.org/drawingml/2006/main">
               <a:ext uri="{FF2B5EF4-FFF2-40B4-BE49-F238E27FC236}">
-                <a16:creationId xmlns:a16="http://schemas.microsoft.com/office/drawing/2014/main" id="{B3C97B38-0AAC-4FCC-A397-1977DD0FB40D}"/>
+                <a16:creationId xmlns:a16="http://schemas.microsoft.com/office/drawing/2014/main" id="{4FB9D305-3EA5-4636-B32A-9328D510ED6E}"/>
               </a:ext>
             </a:extLst>
           </p:cNvPr>
@@ -17524,7 +17524,7 @@
           <p:cNvPr id="9" name="">
             <a:extLst xmlns:a="http://schemas.openxmlformats.org/drawingml/2006/main">
               <a:ext uri="{FF2B5EF4-FFF2-40B4-BE49-F238E27FC236}">
-                <a16:creationId xmlns:a16="http://schemas.microsoft.com/office/drawing/2014/main" id="{7ECF93AD-123E-488A-935F-E4465BDBB918}"/>
+                <a16:creationId xmlns:a16="http://schemas.microsoft.com/office/drawing/2014/main" id="{E97E73A4-C825-41C1-ACD2-61F7134D4AA7}"/>
               </a:ext>
             </a:extLst>
           </p:cNvPr>
@@ -17555,7 +17555,7 @@
           <p:cNvPr id="10" name="">
             <a:extLst xmlns:a="http://schemas.openxmlformats.org/drawingml/2006/main">
               <a:ext uri="{FF2B5EF4-FFF2-40B4-BE49-F238E27FC236}">
-                <a16:creationId xmlns:a16="http://schemas.microsoft.com/office/drawing/2014/main" id="{B6840AF4-3581-4F0A-9DC7-6675D3AC9BB7}"/>
+                <a16:creationId xmlns:a16="http://schemas.microsoft.com/office/drawing/2014/main" id="{49A9E9CB-2B24-46E7-A2A8-649D05D11AE4}"/>
               </a:ext>
             </a:extLst>
           </p:cNvPr>
@@ -17617,7 +17617,7 @@
           <p:cNvPr id="11" name="">
             <a:extLst xmlns:a="http://schemas.openxmlformats.org/drawingml/2006/main">
               <a:ext uri="{FF2B5EF4-FFF2-40B4-BE49-F238E27FC236}">
-                <a16:creationId xmlns:a16="http://schemas.microsoft.com/office/drawing/2014/main" id="{F04FC886-5019-4678-B888-DE1ECF77C915}"/>
+                <a16:creationId xmlns:a16="http://schemas.microsoft.com/office/drawing/2014/main" id="{67EAF029-4A81-4CD9-9FB1-6AB08739CF91}"/>
               </a:ext>
             </a:extLst>
           </p:cNvPr>
@@ -17679,7 +17679,7 @@
           <p:cNvPr id="12" name="">
             <a:extLst xmlns:a="http://schemas.openxmlformats.org/drawingml/2006/main">
               <a:ext uri="{FF2B5EF4-FFF2-40B4-BE49-F238E27FC236}">
-                <a16:creationId xmlns:a16="http://schemas.microsoft.com/office/drawing/2014/main" id="{C1EA1224-698E-4B45-AD7D-3049CDA317A9}"/>
+                <a16:creationId xmlns:a16="http://schemas.microsoft.com/office/drawing/2014/main" id="{5B80EF3D-EFCE-45AB-89BB-D3443FD76C0D}"/>
               </a:ext>
             </a:extLst>
           </p:cNvPr>
@@ -17712,7 +17712,7 @@
           <p:cNvPr id="13" name="">
             <a:extLst xmlns:a="http://schemas.openxmlformats.org/drawingml/2006/main">
               <a:ext uri="{FF2B5EF4-FFF2-40B4-BE49-F238E27FC236}">
-                <a16:creationId xmlns:a16="http://schemas.microsoft.com/office/drawing/2014/main" id="{045BA127-745F-4655-86F3-8E65C222A294}"/>
+                <a16:creationId xmlns:a16="http://schemas.microsoft.com/office/drawing/2014/main" id="{74944700-3487-424B-848D-B81330891D7F}"/>
               </a:ext>
             </a:extLst>
           </p:cNvPr>
@@ -17747,7 +17747,7 @@
           <p:cNvPr id="14" name="">
             <a:extLst xmlns:a="http://schemas.openxmlformats.org/drawingml/2006/main">
               <a:ext uri="{FF2B5EF4-FFF2-40B4-BE49-F238E27FC236}">
-                <a16:creationId xmlns:a16="http://schemas.microsoft.com/office/drawing/2014/main" id="{06A460AA-7949-4A5D-9315-5BFCE2961328}"/>
+                <a16:creationId xmlns:a16="http://schemas.microsoft.com/office/drawing/2014/main" id="{58F39D51-5057-4762-A63B-6104BCFB529D}"/>
               </a:ext>
             </a:extLst>
           </p:cNvPr>
@@ -17778,7 +17778,7 @@
           <p:cNvPr id="15" name="">
             <a:extLst xmlns:a="http://schemas.openxmlformats.org/drawingml/2006/main">
               <a:ext uri="{FF2B5EF4-FFF2-40B4-BE49-F238E27FC236}">
-                <a16:creationId xmlns:a16="http://schemas.microsoft.com/office/drawing/2014/main" id="{3E9EE8B0-D767-4102-AFEC-F7E2BB80E60F}"/>
+                <a16:creationId xmlns:a16="http://schemas.microsoft.com/office/drawing/2014/main" id="{A9F524F3-F787-44EC-A8A5-F0DBD09F4058}"/>
               </a:ext>
             </a:extLst>
           </p:cNvPr>
@@ -17840,7 +17840,7 @@
           <p:cNvPr id="16" name="">
             <a:extLst xmlns:a="http://schemas.openxmlformats.org/drawingml/2006/main">
               <a:ext uri="{FF2B5EF4-FFF2-40B4-BE49-F238E27FC236}">
-                <a16:creationId xmlns:a16="http://schemas.microsoft.com/office/drawing/2014/main" id="{95ACE7D4-9721-4AED-999E-C0B2AE55FC21}"/>
+                <a16:creationId xmlns:a16="http://schemas.microsoft.com/office/drawing/2014/main" id="{1855318C-D91A-4C1E-ABB3-751546B83F5D}"/>
               </a:ext>
             </a:extLst>
           </p:cNvPr>
@@ -17902,7 +17902,7 @@
           <p:cNvPr id="17" name="">
             <a:extLst xmlns:a="http://schemas.openxmlformats.org/drawingml/2006/main">
               <a:ext uri="{FF2B5EF4-FFF2-40B4-BE49-F238E27FC236}">
-                <a16:creationId xmlns:a16="http://schemas.microsoft.com/office/drawing/2014/main" id="{D7F82407-0E8C-4FA4-BF54-2667303DE11E}"/>
+                <a16:creationId xmlns:a16="http://schemas.microsoft.com/office/drawing/2014/main" id="{E5D691D6-DD78-40E5-B14D-5180E91A8DCD}"/>
               </a:ext>
             </a:extLst>
           </p:cNvPr>
@@ -17964,7 +17964,7 @@
           <p:cNvPr id="18" name="">
             <a:extLst xmlns:a="http://schemas.openxmlformats.org/drawingml/2006/main">
               <a:ext uri="{FF2B5EF4-FFF2-40B4-BE49-F238E27FC236}">
-                <a16:creationId xmlns:a16="http://schemas.microsoft.com/office/drawing/2014/main" id="{76E6DDB8-7296-418A-8DD3-4D2B90F382D6}"/>
+                <a16:creationId xmlns:a16="http://schemas.microsoft.com/office/drawing/2014/main" id="{02946B4A-DFBF-4A6B-B3C9-F05B0FE6F98D}"/>
               </a:ext>
             </a:extLst>
           </p:cNvPr>
@@ -18024,7 +18024,7 @@
     </p:spTree>
     <p:extLst>
       <p:ext uri="{BB962C8B-B14F-4D97-AF65-F5344CB8AC3E}">
-        <p14:creationId xmlns:p14="http://schemas.microsoft.com/office/powerpoint/2010/main" val="479292647"/>
+        <p14:creationId xmlns:p14="http://schemas.microsoft.com/office/powerpoint/2010/main" val="2060396219"/>
       </p:ext>
     </p:extLst>
   </p:cSld>
@@ -18052,7 +18052,7 @@
           <p:nvPr/>
         </p:nvPicPr>
         <p:blipFill>
-          <a:blip xmlns:r="http://schemas.openxmlformats.org/officeDocument/2006/relationships" xmlns:a="http://schemas.openxmlformats.org/drawingml/2006/main" r:embed="Rb1306eaec77f44db"/>
+          <a:blip xmlns:r="http://schemas.openxmlformats.org/officeDocument/2006/relationships" xmlns:a="http://schemas.openxmlformats.org/drawingml/2006/main" r:embed="Re6632ec39e134343"/>
           <a:srcRect xmlns:a="http://schemas.openxmlformats.org/drawingml/2006/main" l="0" t="0" r="0" b="0"/>
           <a:stretch xmlns:a="http://schemas.openxmlformats.org/drawingml/2006/main">
             <a:fillRect l="0" t="0" r="0" b="0"/>
@@ -18073,7 +18073,7 @@
           <p:cNvPr id="2" name="">
             <a:extLst xmlns:a="http://schemas.openxmlformats.org/drawingml/2006/main">
               <a:ext uri="{FF2B5EF4-FFF2-40B4-BE49-F238E27FC236}">
-                <a16:creationId xmlns:a16="http://schemas.microsoft.com/office/drawing/2014/main" id="{94D40D85-E656-400C-8D1E-A291D4432DD0}"/>
+                <a16:creationId xmlns:a16="http://schemas.microsoft.com/office/drawing/2014/main" id="{940052CC-07C7-4120-BE4E-28863B2261F9}"/>
               </a:ext>
             </a:extLst>
           </p:cNvPr>
@@ -18135,7 +18135,7 @@
           <p:cNvPr id="3" name="">
             <a:extLst xmlns:a="http://schemas.openxmlformats.org/drawingml/2006/main">
               <a:ext uri="{FF2B5EF4-FFF2-40B4-BE49-F238E27FC236}">
-                <a16:creationId xmlns:a16="http://schemas.microsoft.com/office/drawing/2014/main" id="{751731D8-92A9-43BB-9A18-F3D8D6FDEEB0}"/>
+                <a16:creationId xmlns:a16="http://schemas.microsoft.com/office/drawing/2014/main" id="{56EEB2C2-3854-46BF-B242-92A1417FB66F}"/>
               </a:ext>
             </a:extLst>
           </p:cNvPr>
@@ -18197,7 +18197,7 @@
           <p:cNvPr id="4" name="">
             <a:extLst xmlns:a="http://schemas.openxmlformats.org/drawingml/2006/main">
               <a:ext uri="{FF2B5EF4-FFF2-40B4-BE49-F238E27FC236}">
-                <a16:creationId xmlns:a16="http://schemas.microsoft.com/office/drawing/2014/main" id="{758E4B9B-7ECA-4383-BDD6-061A97976972}"/>
+                <a16:creationId xmlns:a16="http://schemas.microsoft.com/office/drawing/2014/main" id="{6B10E567-AC98-453D-A15B-DD3F193A64D6}"/>
               </a:ext>
             </a:extLst>
           </p:cNvPr>
@@ -18259,7 +18259,7 @@
           <p:cNvPr id="5" name="">
             <a:extLst xmlns:a="http://schemas.openxmlformats.org/drawingml/2006/main">
               <a:ext uri="{FF2B5EF4-FFF2-40B4-BE49-F238E27FC236}">
-                <a16:creationId xmlns:a16="http://schemas.microsoft.com/office/drawing/2014/main" id="{DBD774BE-D7D3-488D-9D63-9166599F2926}"/>
+                <a16:creationId xmlns:a16="http://schemas.microsoft.com/office/drawing/2014/main" id="{E88B23EF-4EB5-4A46-B970-6E0215D0A786}"/>
               </a:ext>
             </a:extLst>
           </p:cNvPr>
@@ -18290,7 +18290,7 @@
           <p:cNvPr id="6" name="">
             <a:extLst xmlns:a="http://schemas.openxmlformats.org/drawingml/2006/main">
               <a:ext uri="{FF2B5EF4-FFF2-40B4-BE49-F238E27FC236}">
-                <a16:creationId xmlns:a16="http://schemas.microsoft.com/office/drawing/2014/main" id="{72B2AEBC-D939-4294-BA4A-2A1C2C44AD83}"/>
+                <a16:creationId xmlns:a16="http://schemas.microsoft.com/office/drawing/2014/main" id="{BC462A87-4869-444B-B93E-187A03452D5E}"/>
               </a:ext>
             </a:extLst>
           </p:cNvPr>
@@ -18352,7 +18352,7 @@
           <p:cNvPr id="7" name="">
             <a:extLst xmlns:a="http://schemas.openxmlformats.org/drawingml/2006/main">
               <a:ext uri="{FF2B5EF4-FFF2-40B4-BE49-F238E27FC236}">
-                <a16:creationId xmlns:a16="http://schemas.microsoft.com/office/drawing/2014/main" id="{EE294A3A-252B-4320-84BD-0F7D5917532E}"/>
+                <a16:creationId xmlns:a16="http://schemas.microsoft.com/office/drawing/2014/main" id="{19A3EA47-8593-4F40-8FF0-54E249D16008}"/>
               </a:ext>
             </a:extLst>
           </p:cNvPr>
@@ -18385,7 +18385,7 @@
           <p:cNvPr id="8" name="">
             <a:extLst xmlns:a="http://schemas.openxmlformats.org/drawingml/2006/main">
               <a:ext uri="{FF2B5EF4-FFF2-40B4-BE49-F238E27FC236}">
-                <a16:creationId xmlns:a16="http://schemas.microsoft.com/office/drawing/2014/main" id="{508EF219-0EB8-42EB-9A4D-71C7CC1C1386}"/>
+                <a16:creationId xmlns:a16="http://schemas.microsoft.com/office/drawing/2014/main" id="{FBE524FC-FE34-4D1E-BA31-6F9C6A76FBBB}"/>
               </a:ext>
             </a:extLst>
           </p:cNvPr>
@@ -18420,7 +18420,7 @@
           <p:cNvPr id="9" name="">
             <a:extLst xmlns:a="http://schemas.openxmlformats.org/drawingml/2006/main">
               <a:ext uri="{FF2B5EF4-FFF2-40B4-BE49-F238E27FC236}">
-                <a16:creationId xmlns:a16="http://schemas.microsoft.com/office/drawing/2014/main" id="{5B500DED-261A-4177-87C5-7362FDBA7E7A}"/>
+                <a16:creationId xmlns:a16="http://schemas.microsoft.com/office/drawing/2014/main" id="{352361C1-11C1-431F-8691-C8DAFDE4D002}"/>
               </a:ext>
             </a:extLst>
           </p:cNvPr>
@@ -18451,7 +18451,7 @@
           <p:cNvPr id="10" name="">
             <a:extLst xmlns:a="http://schemas.openxmlformats.org/drawingml/2006/main">
               <a:ext uri="{FF2B5EF4-FFF2-40B4-BE49-F238E27FC236}">
-                <a16:creationId xmlns:a16="http://schemas.microsoft.com/office/drawing/2014/main" id="{53BFFC9D-F4AE-4096-BB15-00AB963239A3}"/>
+                <a16:creationId xmlns:a16="http://schemas.microsoft.com/office/drawing/2014/main" id="{B9A3B2C9-BA05-4E39-A5BD-547469042419}"/>
               </a:ext>
             </a:extLst>
           </p:cNvPr>
@@ -18513,7 +18513,7 @@
           <p:cNvPr id="11" name="">
             <a:extLst xmlns:a="http://schemas.openxmlformats.org/drawingml/2006/main">
               <a:ext uri="{FF2B5EF4-FFF2-40B4-BE49-F238E27FC236}">
-                <a16:creationId xmlns:a16="http://schemas.microsoft.com/office/drawing/2014/main" id="{976A8752-21F9-4321-B167-3DD2A2348CA0}"/>
+                <a16:creationId xmlns:a16="http://schemas.microsoft.com/office/drawing/2014/main" id="{B945E479-4B9F-4833-BCDA-40448B56F3B8}"/>
               </a:ext>
             </a:extLst>
           </p:cNvPr>
@@ -18575,7 +18575,7 @@
           <p:cNvPr id="12" name="">
             <a:extLst xmlns:a="http://schemas.openxmlformats.org/drawingml/2006/main">
               <a:ext uri="{FF2B5EF4-FFF2-40B4-BE49-F238E27FC236}">
-                <a16:creationId xmlns:a16="http://schemas.microsoft.com/office/drawing/2014/main" id="{0CF0E1D5-8396-4213-8622-1B9D24B6B7A1}"/>
+                <a16:creationId xmlns:a16="http://schemas.microsoft.com/office/drawing/2014/main" id="{1337269A-CB1A-4BA5-848B-2A46DDC3605A}"/>
               </a:ext>
             </a:extLst>
           </p:cNvPr>
@@ -18637,7 +18637,7 @@
           <p:cNvPr id="13" name="">
             <a:extLst xmlns:a="http://schemas.openxmlformats.org/drawingml/2006/main">
               <a:ext uri="{FF2B5EF4-FFF2-40B4-BE49-F238E27FC236}">
-                <a16:creationId xmlns:a16="http://schemas.microsoft.com/office/drawing/2014/main" id="{113CB275-1147-4BA6-B80A-A4A8995018C1}"/>
+                <a16:creationId xmlns:a16="http://schemas.microsoft.com/office/drawing/2014/main" id="{4B2333FA-1582-48B2-AB7A-E543DD23B2EB}"/>
               </a:ext>
             </a:extLst>
           </p:cNvPr>
@@ -18670,7 +18670,7 @@
           <p:cNvPr id="14" name="">
             <a:extLst xmlns:a="http://schemas.openxmlformats.org/drawingml/2006/main">
               <a:ext uri="{FF2B5EF4-FFF2-40B4-BE49-F238E27FC236}">
-                <a16:creationId xmlns:a16="http://schemas.microsoft.com/office/drawing/2014/main" id="{6EF8567B-0963-4916-9A2E-351C559095B5}"/>
+                <a16:creationId xmlns:a16="http://schemas.microsoft.com/office/drawing/2014/main" id="{F126206D-C11A-49AD-8455-6315E191B275}"/>
               </a:ext>
             </a:extLst>
           </p:cNvPr>
@@ -18705,7 +18705,7 @@
           <p:cNvPr id="15" name="">
             <a:extLst xmlns:a="http://schemas.openxmlformats.org/drawingml/2006/main">
               <a:ext uri="{FF2B5EF4-FFF2-40B4-BE49-F238E27FC236}">
-                <a16:creationId xmlns:a16="http://schemas.microsoft.com/office/drawing/2014/main" id="{872EECCB-190D-4336-B049-EF26BBB3C823}"/>
+                <a16:creationId xmlns:a16="http://schemas.microsoft.com/office/drawing/2014/main" id="{ED3F99CB-5163-41F1-979E-C4CA19F64A95}"/>
               </a:ext>
             </a:extLst>
           </p:cNvPr>
@@ -18736,7 +18736,7 @@
           <p:cNvPr id="16" name="">
             <a:extLst xmlns:a="http://schemas.openxmlformats.org/drawingml/2006/main">
               <a:ext uri="{FF2B5EF4-FFF2-40B4-BE49-F238E27FC236}">
-                <a16:creationId xmlns:a16="http://schemas.microsoft.com/office/drawing/2014/main" id="{989E3FBA-6BE3-43BA-9BD2-D07C137221E6}"/>
+                <a16:creationId xmlns:a16="http://schemas.microsoft.com/office/drawing/2014/main" id="{CDAC81E3-DDD1-4E98-8B8A-C46C17752669}"/>
               </a:ext>
             </a:extLst>
           </p:cNvPr>
@@ -18798,7 +18798,7 @@
           <p:cNvPr id="17" name="">
             <a:extLst xmlns:a="http://schemas.openxmlformats.org/drawingml/2006/main">
               <a:ext uri="{FF2B5EF4-FFF2-40B4-BE49-F238E27FC236}">
-                <a16:creationId xmlns:a16="http://schemas.microsoft.com/office/drawing/2014/main" id="{B5844AD4-E73B-49D5-9879-1971739E23C0}"/>
+                <a16:creationId xmlns:a16="http://schemas.microsoft.com/office/drawing/2014/main" id="{E93F427E-7A44-4649-A26A-3191600D1CF5}"/>
               </a:ext>
             </a:extLst>
           </p:cNvPr>
@@ -18860,7 +18860,7 @@
           <p:cNvPr id="18" name="">
             <a:extLst xmlns:a="http://schemas.openxmlformats.org/drawingml/2006/main">
               <a:ext uri="{FF2B5EF4-FFF2-40B4-BE49-F238E27FC236}">
-                <a16:creationId xmlns:a16="http://schemas.microsoft.com/office/drawing/2014/main" id="{35657B36-1DAB-4B58-BD8B-CB87D5771CC8}"/>
+                <a16:creationId xmlns:a16="http://schemas.microsoft.com/office/drawing/2014/main" id="{0A5A275D-E366-4532-82E8-1B9BA2842458}"/>
               </a:ext>
             </a:extLst>
           </p:cNvPr>
@@ -18922,7 +18922,7 @@
           <p:cNvPr id="19" name="">
             <a:extLst xmlns:a="http://schemas.openxmlformats.org/drawingml/2006/main">
               <a:ext uri="{FF2B5EF4-FFF2-40B4-BE49-F238E27FC236}">
-                <a16:creationId xmlns:a16="http://schemas.microsoft.com/office/drawing/2014/main" id="{BED6642E-9136-4C21-A8A6-B87A782C510E}"/>
+                <a16:creationId xmlns:a16="http://schemas.microsoft.com/office/drawing/2014/main" id="{29A9650F-7067-4EE9-9266-C9FFF5CD022A}"/>
               </a:ext>
             </a:extLst>
           </p:cNvPr>
@@ -18955,7 +18955,7 @@
           <p:cNvPr id="20" name="">
             <a:extLst xmlns:a="http://schemas.openxmlformats.org/drawingml/2006/main">
               <a:ext uri="{FF2B5EF4-FFF2-40B4-BE49-F238E27FC236}">
-                <a16:creationId xmlns:a16="http://schemas.microsoft.com/office/drawing/2014/main" id="{9C17857F-6300-45FB-8DF8-A69356AC1CA7}"/>
+                <a16:creationId xmlns:a16="http://schemas.microsoft.com/office/drawing/2014/main" id="{4E38C69E-B487-46CD-9678-E37267BC41F8}"/>
               </a:ext>
             </a:extLst>
           </p:cNvPr>
@@ -18990,7 +18990,7 @@
           <p:cNvPr id="21" name="">
             <a:extLst xmlns:a="http://schemas.openxmlformats.org/drawingml/2006/main">
               <a:ext uri="{FF2B5EF4-FFF2-40B4-BE49-F238E27FC236}">
-                <a16:creationId xmlns:a16="http://schemas.microsoft.com/office/drawing/2014/main" id="{7DC490B9-A627-41C4-AFDF-EF84CB227F29}"/>
+                <a16:creationId xmlns:a16="http://schemas.microsoft.com/office/drawing/2014/main" id="{C69C820A-90E7-4585-A632-B56062BF5928}"/>
               </a:ext>
             </a:extLst>
           </p:cNvPr>
@@ -19021,7 +19021,7 @@
           <p:cNvPr id="22" name="">
             <a:extLst xmlns:a="http://schemas.openxmlformats.org/drawingml/2006/main">
               <a:ext uri="{FF2B5EF4-FFF2-40B4-BE49-F238E27FC236}">
-                <a16:creationId xmlns:a16="http://schemas.microsoft.com/office/drawing/2014/main" id="{81F6B720-5110-46EF-BC31-BCCF58695BB2}"/>
+                <a16:creationId xmlns:a16="http://schemas.microsoft.com/office/drawing/2014/main" id="{FB0440B7-1061-4F98-94B9-52E7850C2DF9}"/>
               </a:ext>
             </a:extLst>
           </p:cNvPr>
@@ -19083,7 +19083,7 @@
           <p:cNvPr id="23" name="">
             <a:extLst xmlns:a="http://schemas.openxmlformats.org/drawingml/2006/main">
               <a:ext uri="{FF2B5EF4-FFF2-40B4-BE49-F238E27FC236}">
-                <a16:creationId xmlns:a16="http://schemas.microsoft.com/office/drawing/2014/main" id="{01E6BA7A-AE7E-4C9E-8E8B-B75070458A6C}"/>
+                <a16:creationId xmlns:a16="http://schemas.microsoft.com/office/drawing/2014/main" id="{C8262237-D47A-4136-AF30-B5A074B83BA2}"/>
               </a:ext>
             </a:extLst>
           </p:cNvPr>
@@ -19145,7 +19145,7 @@
           <p:cNvPr id="24" name="">
             <a:extLst xmlns:a="http://schemas.openxmlformats.org/drawingml/2006/main">
               <a:ext uri="{FF2B5EF4-FFF2-40B4-BE49-F238E27FC236}">
-                <a16:creationId xmlns:a16="http://schemas.microsoft.com/office/drawing/2014/main" id="{2B3F75F1-961C-4370-8F0F-BD2C70B9151F}"/>
+                <a16:creationId xmlns:a16="http://schemas.microsoft.com/office/drawing/2014/main" id="{A6DDB017-892F-462F-AB13-3A1034A1BF96}"/>
               </a:ext>
             </a:extLst>
           </p:cNvPr>
@@ -19207,7 +19207,7 @@
           <p:cNvPr id="25" name="">
             <a:extLst xmlns:a="http://schemas.openxmlformats.org/drawingml/2006/main">
               <a:ext uri="{FF2B5EF4-FFF2-40B4-BE49-F238E27FC236}">
-                <a16:creationId xmlns:a16="http://schemas.microsoft.com/office/drawing/2014/main" id="{B978E9E0-4D28-42B6-A65E-1B1FF19D58F4}"/>
+                <a16:creationId xmlns:a16="http://schemas.microsoft.com/office/drawing/2014/main" id="{A44ECBCB-E849-47CF-A4CB-ED4A93EE710F}"/>
               </a:ext>
             </a:extLst>
           </p:cNvPr>
@@ -19240,7 +19240,7 @@
           <p:cNvPr id="26" name="">
             <a:extLst xmlns:a="http://schemas.openxmlformats.org/drawingml/2006/main">
               <a:ext uri="{FF2B5EF4-FFF2-40B4-BE49-F238E27FC236}">
-                <a16:creationId xmlns:a16="http://schemas.microsoft.com/office/drawing/2014/main" id="{16770B9A-08FA-47CC-A5A2-87327B7C4A34}"/>
+                <a16:creationId xmlns:a16="http://schemas.microsoft.com/office/drawing/2014/main" id="{84C6E443-06B9-4579-9B27-700210E1FD6E}"/>
               </a:ext>
             </a:extLst>
           </p:cNvPr>
@@ -19275,7 +19275,7 @@
           <p:cNvPr id="27" name="">
             <a:extLst xmlns:a="http://schemas.openxmlformats.org/drawingml/2006/main">
               <a:ext uri="{FF2B5EF4-FFF2-40B4-BE49-F238E27FC236}">
-                <a16:creationId xmlns:a16="http://schemas.microsoft.com/office/drawing/2014/main" id="{0B906736-6819-4FE3-A189-108AA7B898E1}"/>
+                <a16:creationId xmlns:a16="http://schemas.microsoft.com/office/drawing/2014/main" id="{FA4152AA-EB87-4FD5-8BE9-42FCC519F7C4}"/>
               </a:ext>
             </a:extLst>
           </p:cNvPr>
@@ -19306,7 +19306,7 @@
           <p:cNvPr id="28" name="">
             <a:extLst xmlns:a="http://schemas.openxmlformats.org/drawingml/2006/main">
               <a:ext uri="{FF2B5EF4-FFF2-40B4-BE49-F238E27FC236}">
-                <a16:creationId xmlns:a16="http://schemas.microsoft.com/office/drawing/2014/main" id="{3D6BABAE-799F-471D-9FCC-CE6E06A36124}"/>
+                <a16:creationId xmlns:a16="http://schemas.microsoft.com/office/drawing/2014/main" id="{3A922C68-1C96-4D22-951A-0045B7A8EC17}"/>
               </a:ext>
             </a:extLst>
           </p:cNvPr>
@@ -19368,7 +19368,7 @@
           <p:cNvPr id="29" name="">
             <a:extLst xmlns:a="http://schemas.openxmlformats.org/drawingml/2006/main">
               <a:ext uri="{FF2B5EF4-FFF2-40B4-BE49-F238E27FC236}">
-                <a16:creationId xmlns:a16="http://schemas.microsoft.com/office/drawing/2014/main" id="{41F4F702-3920-419C-8541-6531F62D1261}"/>
+                <a16:creationId xmlns:a16="http://schemas.microsoft.com/office/drawing/2014/main" id="{EECBC9FB-7F86-46B4-8F39-5DFE04FE811A}"/>
               </a:ext>
             </a:extLst>
           </p:cNvPr>
@@ -19430,7 +19430,7 @@
           <p:cNvPr id="30" name="">
             <a:extLst xmlns:a="http://schemas.openxmlformats.org/drawingml/2006/main">
               <a:ext uri="{FF2B5EF4-FFF2-40B4-BE49-F238E27FC236}">
-                <a16:creationId xmlns:a16="http://schemas.microsoft.com/office/drawing/2014/main" id="{7B7FCFFC-BDE1-4C4F-805E-5677170A5FA3}"/>
+                <a16:creationId xmlns:a16="http://schemas.microsoft.com/office/drawing/2014/main" id="{F1C799A0-2728-4C7F-856E-293078C3DCF6}"/>
               </a:ext>
             </a:extLst>
           </p:cNvPr>
@@ -19492,7 +19492,7 @@
           <p:cNvPr id="31" name="">
             <a:extLst xmlns:a="http://schemas.openxmlformats.org/drawingml/2006/main">
               <a:ext uri="{FF2B5EF4-FFF2-40B4-BE49-F238E27FC236}">
-                <a16:creationId xmlns:a16="http://schemas.microsoft.com/office/drawing/2014/main" id="{851C248B-E923-41B7-8321-483E72DD6ACB}"/>
+                <a16:creationId xmlns:a16="http://schemas.microsoft.com/office/drawing/2014/main" id="{8C4E466F-DA4F-42B6-99F0-062CD09ED0F8}"/>
               </a:ext>
             </a:extLst>
           </p:cNvPr>
@@ -19554,7 +19554,7 @@
           <p:cNvPr id="32" name="">
             <a:extLst xmlns:a="http://schemas.openxmlformats.org/drawingml/2006/main">
               <a:ext uri="{FF2B5EF4-FFF2-40B4-BE49-F238E27FC236}">
-                <a16:creationId xmlns:a16="http://schemas.microsoft.com/office/drawing/2014/main" id="{60EE2DD0-84D5-4E44-AE5E-C752BFCDE8E9}"/>
+                <a16:creationId xmlns:a16="http://schemas.microsoft.com/office/drawing/2014/main" id="{D6CD550E-DE21-4B48-82A4-DBC4B8DFFEFE}"/>
               </a:ext>
             </a:extLst>
           </p:cNvPr>
@@ -19614,7 +19614,7 @@
     </p:spTree>
     <p:extLst>
       <p:ext uri="{BB962C8B-B14F-4D97-AF65-F5344CB8AC3E}">
-        <p14:creationId xmlns:p14="http://schemas.microsoft.com/office/powerpoint/2010/main" val="1758153982"/>
+        <p14:creationId xmlns:p14="http://schemas.microsoft.com/office/powerpoint/2010/main" val="945128920"/>
       </p:ext>
     </p:extLst>
   </p:cSld>
@@ -19642,7 +19642,7 @@
           <p:nvPr/>
         </p:nvPicPr>
         <p:blipFill>
-          <a:blip xmlns:r="http://schemas.openxmlformats.org/officeDocument/2006/relationships" xmlns:a="http://schemas.openxmlformats.org/drawingml/2006/main" r:embed="Rac96a83cabfb4dbf"/>
+          <a:blip xmlns:r="http://schemas.openxmlformats.org/officeDocument/2006/relationships" xmlns:a="http://schemas.openxmlformats.org/drawingml/2006/main" r:embed="R60129370f4634fb0"/>
           <a:srcRect xmlns:a="http://schemas.openxmlformats.org/drawingml/2006/main" l="0" t="0" r="0" b="0"/>
           <a:stretch xmlns:a="http://schemas.openxmlformats.org/drawingml/2006/main">
             <a:fillRect l="0" t="0" r="0" b="0"/>
@@ -19663,7 +19663,7 @@
           <p:cNvPr id="2" name="">
             <a:extLst xmlns:a="http://schemas.openxmlformats.org/drawingml/2006/main">
               <a:ext uri="{FF2B5EF4-FFF2-40B4-BE49-F238E27FC236}">
-                <a16:creationId xmlns:a16="http://schemas.microsoft.com/office/drawing/2014/main" id="{76D31BC3-DE20-47BF-B9A4-ABB2E75A77CD}"/>
+                <a16:creationId xmlns:a16="http://schemas.microsoft.com/office/drawing/2014/main" id="{D48DEE8A-0413-4666-BEE5-716CB9DADD1C}"/>
               </a:ext>
             </a:extLst>
           </p:cNvPr>
@@ -19725,7 +19725,7 @@
           <p:cNvPr id="3" name="">
             <a:extLst xmlns:a="http://schemas.openxmlformats.org/drawingml/2006/main">
               <a:ext uri="{FF2B5EF4-FFF2-40B4-BE49-F238E27FC236}">
-                <a16:creationId xmlns:a16="http://schemas.microsoft.com/office/drawing/2014/main" id="{D276AFAE-CEF1-4FAA-9678-3B6C47955A03}"/>
+                <a16:creationId xmlns:a16="http://schemas.microsoft.com/office/drawing/2014/main" id="{48D29BD7-BA10-4185-916F-E3EF3695BF5F}"/>
               </a:ext>
             </a:extLst>
           </p:cNvPr>
@@ -19787,7 +19787,7 @@
           <p:cNvPr id="4" name="">
             <a:extLst xmlns:a="http://schemas.openxmlformats.org/drawingml/2006/main">
               <a:ext uri="{FF2B5EF4-FFF2-40B4-BE49-F238E27FC236}">
-                <a16:creationId xmlns:a16="http://schemas.microsoft.com/office/drawing/2014/main" id="{B4CE91AA-0C5A-4DCD-9988-BADF9B8EEFF7}"/>
+                <a16:creationId xmlns:a16="http://schemas.microsoft.com/office/drawing/2014/main" id="{84C3A7FC-6388-4419-8236-1C5699C771E5}"/>
               </a:ext>
             </a:extLst>
           </p:cNvPr>
@@ -19849,7 +19849,7 @@
           <p:cNvPr id="5" name="">
             <a:extLst xmlns:a="http://schemas.openxmlformats.org/drawingml/2006/main">
               <a:ext uri="{FF2B5EF4-FFF2-40B4-BE49-F238E27FC236}">
-                <a16:creationId xmlns:a16="http://schemas.microsoft.com/office/drawing/2014/main" id="{89CA1381-9CFA-4E90-8E33-9BD28B6B175C}"/>
+                <a16:creationId xmlns:a16="http://schemas.microsoft.com/office/drawing/2014/main" id="{707E75F5-B9DB-4920-9234-07CF3B7243A6}"/>
               </a:ext>
             </a:extLst>
           </p:cNvPr>
@@ -19880,7 +19880,7 @@
           <p:cNvPr id="6" name="">
             <a:extLst xmlns:a="http://schemas.openxmlformats.org/drawingml/2006/main">
               <a:ext uri="{FF2B5EF4-FFF2-40B4-BE49-F238E27FC236}">
-                <a16:creationId xmlns:a16="http://schemas.microsoft.com/office/drawing/2014/main" id="{4F12033A-0F40-4D8B-A31D-7C1C1D2794BA}"/>
+                <a16:creationId xmlns:a16="http://schemas.microsoft.com/office/drawing/2014/main" id="{11DF0935-3049-4242-93D2-31AC7EC66E86}"/>
               </a:ext>
             </a:extLst>
           </p:cNvPr>
@@ -19942,7 +19942,7 @@
           <p:cNvPr id="7" name="">
             <a:extLst xmlns:a="http://schemas.openxmlformats.org/drawingml/2006/main">
               <a:ext uri="{FF2B5EF4-FFF2-40B4-BE49-F238E27FC236}">
-                <a16:creationId xmlns:a16="http://schemas.microsoft.com/office/drawing/2014/main" id="{8D9F4E2C-738B-47D7-82A2-E343CF616AD5}"/>
+                <a16:creationId xmlns:a16="http://schemas.microsoft.com/office/drawing/2014/main" id="{D52AF352-D7BA-4E6C-86EE-28365FFCE1C7}"/>
               </a:ext>
             </a:extLst>
           </p:cNvPr>
@@ -19975,7 +19975,7 @@
           <p:cNvPr id="8" name="">
             <a:extLst xmlns:a="http://schemas.openxmlformats.org/drawingml/2006/main">
               <a:ext uri="{FF2B5EF4-FFF2-40B4-BE49-F238E27FC236}">
-                <a16:creationId xmlns:a16="http://schemas.microsoft.com/office/drawing/2014/main" id="{D95C1C02-D1E2-48B2-8165-53019FDF4CE8}"/>
+                <a16:creationId xmlns:a16="http://schemas.microsoft.com/office/drawing/2014/main" id="{496C47EC-51C2-47AC-AA6D-F157A018D580}"/>
               </a:ext>
             </a:extLst>
           </p:cNvPr>
@@ -20010,7 +20010,7 @@
           <p:cNvPr id="9" name="">
             <a:extLst xmlns:a="http://schemas.openxmlformats.org/drawingml/2006/main">
               <a:ext uri="{FF2B5EF4-FFF2-40B4-BE49-F238E27FC236}">
-                <a16:creationId xmlns:a16="http://schemas.microsoft.com/office/drawing/2014/main" id="{E641821F-2A61-4C5C-BF2D-649E317384F8}"/>
+                <a16:creationId xmlns:a16="http://schemas.microsoft.com/office/drawing/2014/main" id="{FA474DC8-2CA1-4C57-A98C-F26D8ECB8770}"/>
               </a:ext>
             </a:extLst>
           </p:cNvPr>
@@ -20041,7 +20041,7 @@
           <p:cNvPr id="10" name="">
             <a:extLst xmlns:a="http://schemas.openxmlformats.org/drawingml/2006/main">
               <a:ext uri="{FF2B5EF4-FFF2-40B4-BE49-F238E27FC236}">
-                <a16:creationId xmlns:a16="http://schemas.microsoft.com/office/drawing/2014/main" id="{5073647F-6685-4076-88CE-9D40FED13091}"/>
+                <a16:creationId xmlns:a16="http://schemas.microsoft.com/office/drawing/2014/main" id="{58F0091D-DC65-42F8-A6DC-2BB4FC159EEC}"/>
               </a:ext>
             </a:extLst>
           </p:cNvPr>
@@ -20103,7 +20103,7 @@
           <p:cNvPr id="11" name="">
             <a:extLst xmlns:a="http://schemas.openxmlformats.org/drawingml/2006/main">
               <a:ext uri="{FF2B5EF4-FFF2-40B4-BE49-F238E27FC236}">
-                <a16:creationId xmlns:a16="http://schemas.microsoft.com/office/drawing/2014/main" id="{ECDFFED1-D005-466E-9DF0-2BC2F7D2DC7A}"/>
+                <a16:creationId xmlns:a16="http://schemas.microsoft.com/office/drawing/2014/main" id="{50CD13EB-8C74-451D-B62F-82756CBBB1CB}"/>
               </a:ext>
             </a:extLst>
           </p:cNvPr>
@@ -20165,7 +20165,7 @@
           <p:cNvPr id="12" name="">
             <a:extLst xmlns:a="http://schemas.openxmlformats.org/drawingml/2006/main">
               <a:ext uri="{FF2B5EF4-FFF2-40B4-BE49-F238E27FC236}">
-                <a16:creationId xmlns:a16="http://schemas.microsoft.com/office/drawing/2014/main" id="{3FF422A8-9D5F-4753-9A26-21C154F76C27}"/>
+                <a16:creationId xmlns:a16="http://schemas.microsoft.com/office/drawing/2014/main" id="{AEB03FAD-C50F-4CBA-A9B2-0E8231D44B4D}"/>
               </a:ext>
             </a:extLst>
           </p:cNvPr>
@@ -20198,7 +20198,7 @@
           <p:cNvPr id="13" name="">
             <a:extLst xmlns:a="http://schemas.openxmlformats.org/drawingml/2006/main">
               <a:ext uri="{FF2B5EF4-FFF2-40B4-BE49-F238E27FC236}">
-                <a16:creationId xmlns:a16="http://schemas.microsoft.com/office/drawing/2014/main" id="{32C6E634-79C5-4283-8F70-4486F766F835}"/>
+                <a16:creationId xmlns:a16="http://schemas.microsoft.com/office/drawing/2014/main" id="{7626D10F-B9E6-4A15-8C16-CED7D6EF5C42}"/>
               </a:ext>
             </a:extLst>
           </p:cNvPr>
@@ -20233,7 +20233,7 @@
           <p:cNvPr id="14" name="">
             <a:extLst xmlns:a="http://schemas.openxmlformats.org/drawingml/2006/main">
               <a:ext uri="{FF2B5EF4-FFF2-40B4-BE49-F238E27FC236}">
-                <a16:creationId xmlns:a16="http://schemas.microsoft.com/office/drawing/2014/main" id="{29AE871B-95D9-4641-A8BD-EE5742D00C17}"/>
+                <a16:creationId xmlns:a16="http://schemas.microsoft.com/office/drawing/2014/main" id="{E1F18960-D9EA-4408-A8B9-839187318196}"/>
               </a:ext>
             </a:extLst>
           </p:cNvPr>
@@ -20264,7 +20264,7 @@
           <p:cNvPr id="15" name="">
             <a:extLst xmlns:a="http://schemas.openxmlformats.org/drawingml/2006/main">
               <a:ext uri="{FF2B5EF4-FFF2-40B4-BE49-F238E27FC236}">
-                <a16:creationId xmlns:a16="http://schemas.microsoft.com/office/drawing/2014/main" id="{16FF4662-8BFF-4F50-9386-F3AB68F5CE7F}"/>
+                <a16:creationId xmlns:a16="http://schemas.microsoft.com/office/drawing/2014/main" id="{672E45DD-4410-4654-9DA4-CE00AF4FD235}"/>
               </a:ext>
             </a:extLst>
           </p:cNvPr>
@@ -20326,7 +20326,7 @@
           <p:cNvPr id="16" name="">
             <a:extLst xmlns:a="http://schemas.openxmlformats.org/drawingml/2006/main">
               <a:ext uri="{FF2B5EF4-FFF2-40B4-BE49-F238E27FC236}">
-                <a16:creationId xmlns:a16="http://schemas.microsoft.com/office/drawing/2014/main" id="{35ED899F-326A-4E8F-A600-F496CBDC802B}"/>
+                <a16:creationId xmlns:a16="http://schemas.microsoft.com/office/drawing/2014/main" id="{7A8EEBEC-67B0-46DA-B64B-DCA256B7866B}"/>
               </a:ext>
             </a:extLst>
           </p:cNvPr>
@@ -20388,7 +20388,7 @@
           <p:cNvPr id="17" name="">
             <a:extLst xmlns:a="http://schemas.openxmlformats.org/drawingml/2006/main">
               <a:ext uri="{FF2B5EF4-FFF2-40B4-BE49-F238E27FC236}">
-                <a16:creationId xmlns:a16="http://schemas.microsoft.com/office/drawing/2014/main" id="{B5554806-B574-4C2F-A7F2-3AEC6F7BAA63}"/>
+                <a16:creationId xmlns:a16="http://schemas.microsoft.com/office/drawing/2014/main" id="{6E49D12D-848D-4C3B-83B8-2FDC0066884E}"/>
               </a:ext>
             </a:extLst>
           </p:cNvPr>
@@ -20421,7 +20421,7 @@
           <p:cNvPr id="18" name="">
             <a:extLst xmlns:a="http://schemas.openxmlformats.org/drawingml/2006/main">
               <a:ext uri="{FF2B5EF4-FFF2-40B4-BE49-F238E27FC236}">
-                <a16:creationId xmlns:a16="http://schemas.microsoft.com/office/drawing/2014/main" id="{D723AE86-76A3-4261-82D7-A65C1C5EE656}"/>
+                <a16:creationId xmlns:a16="http://schemas.microsoft.com/office/drawing/2014/main" id="{A49E5D0D-E969-4244-B3E8-E7489E60DAB3}"/>
               </a:ext>
             </a:extLst>
           </p:cNvPr>
@@ -20456,7 +20456,7 @@
           <p:cNvPr id="19" name="">
             <a:extLst xmlns:a="http://schemas.openxmlformats.org/drawingml/2006/main">
               <a:ext uri="{FF2B5EF4-FFF2-40B4-BE49-F238E27FC236}">
-                <a16:creationId xmlns:a16="http://schemas.microsoft.com/office/drawing/2014/main" id="{C30299A1-98F2-44A9-9126-18E1D8604E67}"/>
+                <a16:creationId xmlns:a16="http://schemas.microsoft.com/office/drawing/2014/main" id="{B79C50FE-B962-4E3D-9ACA-2925191F2598}"/>
               </a:ext>
             </a:extLst>
           </p:cNvPr>
@@ -20487,7 +20487,7 @@
           <p:cNvPr id="20" name="">
             <a:extLst xmlns:a="http://schemas.openxmlformats.org/drawingml/2006/main">
               <a:ext uri="{FF2B5EF4-FFF2-40B4-BE49-F238E27FC236}">
-                <a16:creationId xmlns:a16="http://schemas.microsoft.com/office/drawing/2014/main" id="{5BA99DF6-6BD4-4D25-86BC-61BEC8561E60}"/>
+                <a16:creationId xmlns:a16="http://schemas.microsoft.com/office/drawing/2014/main" id="{99707036-AE15-459B-B2F8-908781BBDE6C}"/>
               </a:ext>
             </a:extLst>
           </p:cNvPr>
@@ -20549,7 +20549,7 @@
           <p:cNvPr id="21" name="">
             <a:extLst xmlns:a="http://schemas.openxmlformats.org/drawingml/2006/main">
               <a:ext uri="{FF2B5EF4-FFF2-40B4-BE49-F238E27FC236}">
-                <a16:creationId xmlns:a16="http://schemas.microsoft.com/office/drawing/2014/main" id="{C8BF724C-8674-4263-B86C-D261CBA53C0F}"/>
+                <a16:creationId xmlns:a16="http://schemas.microsoft.com/office/drawing/2014/main" id="{E962A639-79DD-4167-BC01-174170BA9555}"/>
               </a:ext>
             </a:extLst>
           </p:cNvPr>
@@ -20611,7 +20611,7 @@
           <p:cNvPr id="22" name="">
             <a:extLst xmlns:a="http://schemas.openxmlformats.org/drawingml/2006/main">
               <a:ext uri="{FF2B5EF4-FFF2-40B4-BE49-F238E27FC236}">
-                <a16:creationId xmlns:a16="http://schemas.microsoft.com/office/drawing/2014/main" id="{0DD7E955-F6DF-4598-9970-616586EBF2FF}"/>
+                <a16:creationId xmlns:a16="http://schemas.microsoft.com/office/drawing/2014/main" id="{A5474CD4-B136-4700-951F-E26775494649}"/>
               </a:ext>
             </a:extLst>
           </p:cNvPr>
@@ -20673,7 +20673,7 @@
           <p:cNvPr id="23" name="">
             <a:extLst xmlns:a="http://schemas.openxmlformats.org/drawingml/2006/main">
               <a:ext uri="{FF2B5EF4-FFF2-40B4-BE49-F238E27FC236}">
-                <a16:creationId xmlns:a16="http://schemas.microsoft.com/office/drawing/2014/main" id="{673996F9-D2B3-43B3-B962-FBAACCB2DD0B}"/>
+                <a16:creationId xmlns:a16="http://schemas.microsoft.com/office/drawing/2014/main" id="{CF1228D6-B1A1-4255-A0C5-997CBE6D8280}"/>
               </a:ext>
             </a:extLst>
           </p:cNvPr>
@@ -20733,7 +20733,7 @@
     </p:spTree>
     <p:extLst>
       <p:ext uri="{BB962C8B-B14F-4D97-AF65-F5344CB8AC3E}">
-        <p14:creationId xmlns:p14="http://schemas.microsoft.com/office/powerpoint/2010/main" val="1354117961"/>
+        <p14:creationId xmlns:p14="http://schemas.microsoft.com/office/powerpoint/2010/main" val="1046960377"/>
       </p:ext>
     </p:extLst>
   </p:cSld>

</xml_diff>